<commit_message>
docs: English-only project documentation (Hebrew stays on the site alone)
Per the scope rule (requirement 2 applies Hebrew to the site itself, not the
project artifacts): README, DEPLOYMENT, SLIDES, the generated .pptx deck and
package.json metadata are now English. Deliberately still Hebrew: the brand
name (proper noun) and the literal UI-string specs quoted in ARCHITECTURE.md,
which define what the Hebrew site displays.

Co-Authored-By: Claude Fable 5 <noreply@anthropic.com>
</commit_message>
<xml_diff>
--- a/docs/DefiNet-Defense-Deck.pptx
+++ b/docs/DefiNet-Defense-Deck.pptx
@@ -1,6 +1,6 @@
 
 <file path=ppt/presentation.xml><?xml version="1.0" encoding="utf-8"?>
-<p:presentation xmlns:a="http://schemas.openxmlformats.org/drawingml/2006/main" xmlns:r="http://schemas.openxmlformats.org/officeDocument/2006/relationships" xmlns:p="http://schemas.openxmlformats.org/presentationml/2006/main" rtl="1" saveSubsetFonts="1" autoCompressPictures="0">
+<p:presentation xmlns:a="http://schemas.openxmlformats.org/drawingml/2006/main" xmlns:r="http://schemas.openxmlformats.org/officeDocument/2006/relationships" xmlns:p="http://schemas.openxmlformats.org/presentationml/2006/main" saveSubsetFonts="1" autoCompressPictures="0">
   <p:sldMasterIdLst>
     <p:sldMasterId id="2147483648" r:id="rId1"/>
   </p:sldMasterIdLst>
@@ -507,7 +507,7 @@
           <a:p>
             <a:r>
               <a:rPr lang="en-US" dirty="0"/>
-              <a:t>שקף פתיחה: הציגו את השמות, מיקום ה-GitHub והכתובת בענן. הדגישו שהמוצר ממפה גם דפיברילטורים בתנועה — מה שמפות קיימות לא עושות.</a:t>
+              <a:t>Opening slide: introduce yourselves, the GitHub location and the cloud address. Emphasize the differentiator: the product maps defibrillators IN MOTION — which existing maps do not do.</a:t>
             </a:r>
             <a:endParaRPr lang="en-US" dirty="0"/>
           </a:p>
@@ -595,7 +595,7 @@
           <a:p>
             <a:r>
               <a:rPr lang="en-US" dirty="0"/>
-              <a:t>שקף חובה. עברו על כל בעיה בקצרה. הנקודה: אנחנו יודעים בדיוק איפה הגבולות של המערכת.</a:t>
+              <a:t>Mandatory slide. Walk through each issue briefly. The message: we know exactly where the system boundaries are.</a:t>
             </a:r>
             <a:endParaRPr lang="en-US" dirty="0"/>
           </a:p>
@@ -683,7 +683,7 @@
           <a:p>
             <a:r>
               <a:rPr lang="en-US" dirty="0"/>
-              <a:t>הזרימה מימין לשמאל: הדפדפן פונה ל-Next.js, שפונה ל-Express, שמדבר עם שני מסדי הנתונים. הסבירו למה SQL לנתונים טבלאיים ו-NoSQL למסמכי אירוע עשירים.</a:t>
+              <a:t>Flow left to right: the browser talks to Next.js, which talks to Express, which owns both databases. Explain why SQL for tabular data and NoSQL for rich incident documents.</a:t>
             </a:r>
             <a:endParaRPr lang="en-US" dirty="0"/>
           </a:p>
@@ -771,7 +771,7 @@
           <a:p>
             <a:r>
               <a:rPr lang="en-US" dirty="0"/>
-              <a:t>אם ישאלו על שורה ספציפית: scatterAround מפזר אחיד בדיסק, haversineM מחשב מרחק על פני כדור. אם מסירים את תנאי a.inRadius — מכשירים מחוץ לרדיוס יקבלו דירוג ויוזנקו בטעות.</a:t>
+              <a:t>If asked about a specific line: scatterAround samples uniformly in a disk; haversineM computes great-circle distance. Removing the a.inRadius condition would rank and dispatch devices outside the radius.</a:t>
             </a:r>
             <a:endParaRPr lang="en-US" dirty="0"/>
           </a:p>
@@ -859,7 +859,7 @@
           <a:p>
             <a:r>
               <a:rPr lang="en-US" dirty="0"/>
-              <a:t>רוטציה: כל refresh מבטל את הטוקן הישן ומנפיק חדש. אם תוקף גנב עוגייה — בשימוש הבא שלה היא כבר מבוטלת והתקיפה מתה. אם מסירים את שורת ה-UPDATE — מאבדים את ההגנה מפני replay.</a:t>
+              <a:t>Rotation: every refresh revokes the old token and issues a new one. If an attacker steals the cookie, its next use finds it already revoked. Removing the UPDATE line removes the replay protection.</a:t>
             </a:r>
             <a:endParaRPr lang="en-US" dirty="0"/>
           </a:p>
@@ -947,7 +947,7 @@
           <a:p>
             <a:r>
               <a:rPr lang="en-US" dirty="0"/>
-              <a:t>סיכום: שלושת מדדי הציון — כיסוי, איכות, מוכנות. הדגישו שהערוץ הכפול (Push+SMS+LoRa) מתועד ביומן ההתראות של האדמין, וניתן להדגמה חיה בסימולטור.</a:t>
+              <a:t>Summary: the three grading metrics — coverage, quality, submission readiness. The dual channel (Push+SMS+LoRa) is recorded in the admin alert log and demonstrable live in the simulator.</a:t>
             </a:r>
             <a:endParaRPr lang="en-US" dirty="0"/>
           </a:p>
@@ -1328,8 +1328,8 @@
         </p:nvSpPr>
         <p:spPr>
           <a:xfrm>
-            <a:off x="548640" y="1371600"/>
-            <a:ext cx="11064240" cy="1097280"/>
+            <a:off x="548640" y="1280160"/>
+            <a:ext cx="7772400" cy="1097280"/>
           </a:xfrm>
           <a:prstGeom prst="rect">
             <a:avLst/>
@@ -1341,11 +1341,11 @@
           <a:bodyPr wrap="square" rtlCol="0" anchor="ctr"/>
           <a:lstStyle/>
           <a:p>
-            <a:pPr rtl="1" algn="r" indent="0" marL="0">
-              <a:buNone/>
-            </a:pPr>
-            <a:r>
-              <a:rPr lang="en-US" sz="6600" b="1" dirty="0">
+            <a:pPr algn="l" indent="0" marL="0">
+              <a:buNone/>
+            </a:pPr>
+            <a:r>
+              <a:rPr lang="en-US" sz="6400" b="1" dirty="0">
                 <a:solidFill>
                   <a:srgbClr val="FFFFFF"/>
                 </a:solidFill>
@@ -1353,9 +1353,9 @@
                 <a:ea typeface="Arial" pitchFamily="34" charset="-122"/>
                 <a:cs typeface="Arial" pitchFamily="34" charset="-120"/>
               </a:rPr>
-              <a:t>דפי-נט</a:t>
-            </a:r>
-            <a:endParaRPr lang="en-US" sz="6600" dirty="0"/>
+              <a:t>DefiNet</a:t>
+            </a:r>
+            <a:endParaRPr lang="en-US" sz="6400" dirty="0"/>
           </a:p>
         </p:txBody>
       </p:sp>
@@ -1367,8 +1367,8 @@
         </p:nvSpPr>
         <p:spPr>
           <a:xfrm>
-            <a:off x="548640" y="2468880"/>
-            <a:ext cx="11064240" cy="548640"/>
+            <a:off x="548640" y="2286000"/>
+            <a:ext cx="8229600" cy="548640"/>
           </a:xfrm>
           <a:prstGeom prst="rect">
             <a:avLst/>
@@ -1380,54 +1380,132 @@
           <a:bodyPr wrap="square" rtlCol="0" anchor="ctr"/>
           <a:lstStyle/>
           <a:p>
-            <a:pPr rtl="1" algn="r" indent="0" marL="0">
-              <a:buNone/>
-            </a:pPr>
-            <a:r>
-              <a:rPr lang="en-US" sz="2200" dirty="0">
+            <a:pPr algn="l" indent="0" marL="0">
+              <a:buNone/>
+            </a:pPr>
+            <a:r>
+              <a:rPr lang="en-US" sz="2400" dirty="0">
                 <a:solidFill>
                   <a:srgbClr val="CBD5E1"/>
+                </a:solidFill>
+                <a:latin typeface="Calibri" pitchFamily="34" charset="0"/>
+                <a:ea typeface="Calibri" pitchFamily="34" charset="-122"/>
+                <a:cs typeface="Calibri" pitchFamily="34" charset="-120"/>
+              </a:rPr>
+              <a:t>דפי-נט — Smart Defibrillator Network</a:t>
+            </a:r>
+            <a:endParaRPr lang="en-US" sz="2400" dirty="0"/>
+          </a:p>
+        </p:txBody>
+      </p:sp>
+      <p:sp>
+        <p:nvSpPr>
+          <p:cNvPr id="4" name="Text 2"/>
+          <p:cNvSpPr/>
+          <p:nvPr/>
+        </p:nvSpPr>
+        <p:spPr>
+          <a:xfrm>
+            <a:off x="548640" y="2834640"/>
+            <a:ext cx="8778240" cy="457200"/>
+          </a:xfrm>
+          <a:prstGeom prst="rect">
+            <a:avLst/>
+          </a:prstGeom>
+          <a:noFill/>
+          <a:ln/>
+        </p:spPr>
+        <p:txBody>
+          <a:bodyPr wrap="square" rtlCol="0" anchor="ctr"/>
+          <a:lstStyle/>
+          <a:p>
+            <a:pPr algn="l" indent="0" marL="0">
+              <a:buNone/>
+            </a:pPr>
+            <a:r>
+              <a:rPr lang="en-US" sz="1600" dirty="0">
+                <a:solidFill>
+                  <a:srgbClr val="94A3B8"/>
+                </a:solidFill>
+                <a:latin typeface="Calibri" pitchFamily="34" charset="0"/>
+                <a:ea typeface="Calibri" pitchFamily="34" charset="-122"/>
+                <a:cs typeface="Calibri" pitchFamily="34" charset="-120"/>
+              </a:rPr>
+              <a:t>Real-time mapping and dispatch of stationary and moving defibrillators</a:t>
+            </a:r>
+            <a:endParaRPr lang="en-US" sz="1600" dirty="0"/>
+          </a:p>
+        </p:txBody>
+      </p:sp>
+      <p:sp>
+        <p:nvSpPr>
+          <p:cNvPr id="5" name="Shape 3"/>
+          <p:cNvSpPr/>
+          <p:nvPr/>
+        </p:nvSpPr>
+        <p:spPr>
+          <a:xfrm>
+            <a:off x="9144000" y="1417320"/>
+            <a:ext cx="2468880" cy="822960"/>
+          </a:xfrm>
+          <a:prstGeom prst="rect">
+            <a:avLst/>
+          </a:prstGeom>
+          <a:solidFill>
+            <a:srgbClr val="DC2626"/>
+          </a:solidFill>
+          <a:ln/>
+        </p:spPr>
+      </p:sp>
+      <p:sp>
+        <p:nvSpPr>
+          <p:cNvPr id="6" name="Text 4"/>
+          <p:cNvSpPr/>
+          <p:nvPr/>
+        </p:nvSpPr>
+        <p:spPr>
+          <a:xfrm>
+            <a:off x="9144000" y="1417320"/>
+            <a:ext cx="2468880" cy="822960"/>
+          </a:xfrm>
+          <a:prstGeom prst="rect">
+            <a:avLst/>
+          </a:prstGeom>
+          <a:noFill/>
+          <a:ln/>
+        </p:spPr>
+        <p:txBody>
+          <a:bodyPr wrap="square" rtlCol="0" anchor="ctr"/>
+          <a:lstStyle/>
+          <a:p>
+            <a:pPr algn="ctr" indent="0" marL="0">
+              <a:buNone/>
+            </a:pPr>
+            <a:r>
+              <a:rPr lang="en-US" sz="1700" b="1" dirty="0">
+                <a:solidFill>
+                  <a:srgbClr val="FFFFFF"/>
                 </a:solidFill>
                 <a:latin typeface="Arial" pitchFamily="34" charset="0"/>
                 <a:ea typeface="Arial" pitchFamily="34" charset="-122"/>
                 <a:cs typeface="Arial" pitchFamily="34" charset="-120"/>
               </a:rPr>
-              <a:t>רשת דפיברילטורים חכמה — מיפוי מכשירים נייחים וניידים בזמן אמת</a:t>
-            </a:r>
-            <a:endParaRPr lang="en-US" sz="2200" dirty="0"/>
-          </a:p>
-        </p:txBody>
-      </p:sp>
-      <p:sp>
-        <p:nvSpPr>
-          <p:cNvPr id="4" name="Shape 2"/>
-          <p:cNvSpPr/>
-          <p:nvPr/>
-        </p:nvSpPr>
-        <p:spPr>
-          <a:xfrm>
-            <a:off x="8869680" y="1554480"/>
-            <a:ext cx="2743200" cy="822960"/>
-          </a:xfrm>
-          <a:prstGeom prst="rect">
-            <a:avLst/>
-          </a:prstGeom>
-          <a:solidFill>
-            <a:srgbClr val="DC2626"/>
-          </a:solidFill>
-          <a:ln/>
-        </p:spPr>
-      </p:sp>
-      <p:sp>
-        <p:nvSpPr>
-          <p:cNvPr id="5" name="Text 3"/>
-          <p:cNvSpPr/>
-          <p:nvPr/>
-        </p:nvSpPr>
-        <p:spPr>
-          <a:xfrm>
-            <a:off x="8869680" y="1554480"/>
-            <a:ext cx="2743200" cy="822960"/>
+              <a:t>Every minute counts</a:t>
+            </a:r>
+            <a:endParaRPr lang="en-US" sz="1700" dirty="0"/>
+          </a:p>
+        </p:txBody>
+      </p:sp>
+      <p:sp>
+        <p:nvSpPr>
+          <p:cNvPr id="7" name="Text 5"/>
+          <p:cNvSpPr/>
+          <p:nvPr/>
+        </p:nvSpPr>
+        <p:spPr>
+          <a:xfrm>
+            <a:off x="548640" y="3474720"/>
+            <a:ext cx="11064240" cy="822960"/>
           </a:xfrm>
           <a:prstGeom prst="rect">
             <a:avLst/>
@@ -1439,83 +1517,44 @@
           <a:bodyPr wrap="square" rtlCol="0" anchor="ctr"/>
           <a:lstStyle/>
           <a:p>
-            <a:pPr rtl="1" algn="ctr" indent="0" marL="0">
-              <a:buNone/>
-            </a:pPr>
-            <a:r>
-              <a:rPr lang="en-US" sz="2200" b="1" dirty="0">
-                <a:solidFill>
-                  <a:srgbClr val="FFFFFF"/>
-                </a:solidFill>
-                <a:latin typeface="Arial" pitchFamily="34" charset="0"/>
-                <a:ea typeface="Arial" pitchFamily="34" charset="-122"/>
-                <a:cs typeface="Arial" pitchFamily="34" charset="-120"/>
-              </a:rPr>
-              <a:t>כל דקה קובעת</a:t>
-            </a:r>
-            <a:endParaRPr lang="en-US" sz="2200" dirty="0"/>
-          </a:p>
-        </p:txBody>
-      </p:sp>
-      <p:sp>
-        <p:nvSpPr>
-          <p:cNvPr id="6" name="Text 4"/>
-          <p:cNvSpPr/>
-          <p:nvPr/>
-        </p:nvSpPr>
-        <p:spPr>
-          <a:xfrm>
-            <a:off x="548640" y="3383280"/>
-            <a:ext cx="11064240" cy="914400"/>
-          </a:xfrm>
-          <a:prstGeom prst="rect">
-            <a:avLst/>
-          </a:prstGeom>
-          <a:noFill/>
-          <a:ln/>
-        </p:spPr>
-        <p:txBody>
-          <a:bodyPr wrap="square" rtlCol="0" anchor="ctr"/>
-          <a:lstStyle/>
-          <a:p>
-            <a:pPr algn="r" indent="0" marL="0">
-              <a:buNone/>
-            </a:pPr>
-            <a:r>
-              <a:rPr lang="en-US" sz="1600" dirty="0">
+            <a:pPr algn="l" indent="0" marL="0">
+              <a:buNone/>
+            </a:pPr>
+            <a:r>
+              <a:rPr lang="en-US" sz="1500" dirty="0">
                 <a:solidFill>
                   <a:srgbClr val="E2E8F0"/>
                 </a:solidFill>
-                <a:latin typeface="Arial" pitchFamily="34" charset="0"/>
-                <a:ea typeface="Arial" pitchFamily="34" charset="-122"/>
-                <a:cs typeface="Arial" pitchFamily="34" charset="-120"/>
-              </a:rPr>
-              <a:t>פרויקט קורס «פיתוח בסביבות WEB»</a:t>
-            </a:r>
-            <a:endParaRPr lang="en-US" sz="1600" dirty="0"/>
-          </a:p>
-          <a:p>
-            <a:pPr algn="r" indent="0" marL="0">
-              <a:buNone/>
-            </a:pPr>
-            <a:r>
-              <a:rPr lang="en-US" sz="1300" dirty="0">
+                <a:latin typeface="Calibri" pitchFamily="34" charset="0"/>
+                <a:ea typeface="Calibri" pitchFamily="34" charset="-122"/>
+                <a:cs typeface="Calibri" pitchFamily="34" charset="-120"/>
+              </a:rPr>
+              <a:t>Course project — "Development on Web Platforms"</a:t>
+            </a:r>
+            <a:endParaRPr lang="en-US" sz="1500" dirty="0"/>
+          </a:p>
+          <a:p>
+            <a:pPr algn="l" indent="0" marL="0">
+              <a:buNone/>
+            </a:pPr>
+            <a:r>
+              <a:rPr lang="en-US" sz="1250" dirty="0">
                 <a:solidFill>
                   <a:srgbClr val="94A3B8"/>
                 </a:solidFill>
-                <a:latin typeface="Arial" pitchFamily="34" charset="0"/>
-                <a:ea typeface="Arial" pitchFamily="34" charset="-122"/>
-                <a:cs typeface="Arial" pitchFamily="34" charset="-120"/>
-              </a:rPr>
-              <a:t>Next.js 15 · Express · SQLite · MongoDB · LoRa 433MHz</a:t>
-            </a:r>
-            <a:endParaRPr lang="en-US" sz="1600" dirty="0"/>
-          </a:p>
-        </p:txBody>
-      </p:sp>
-      <p:sp>
-        <p:nvSpPr>
-          <p:cNvPr id="7" name="Text 5"/>
+                <a:latin typeface="Calibri" pitchFamily="34" charset="0"/>
+                <a:ea typeface="Calibri" pitchFamily="34" charset="-122"/>
+                <a:cs typeface="Calibri" pitchFamily="34" charset="-120"/>
+              </a:rPr>
+              <a:t>Next.js 15 · Express · SQLite · MongoDB · LoRa 433MHz · Meshtastic · MAGNUS satellite</a:t>
+            </a:r>
+            <a:endParaRPr lang="en-US" sz="1500" dirty="0"/>
+          </a:p>
+        </p:txBody>
+      </p:sp>
+      <p:sp>
+        <p:nvSpPr>
+          <p:cNvPr id="8" name="Text 6"/>
           <p:cNvSpPr/>
           <p:nvPr/>
         </p:nvSpPr>
@@ -1534,7 +1573,7 @@
           <a:bodyPr wrap="square" rtlCol="0" anchor="t"/>
           <a:lstStyle/>
           <a:p>
-            <a:pPr algn="r" indent="0" marL="0">
+            <a:pPr algn="l" indent="0" marL="0">
               <a:spcAft>
                 <a:spcPts val="600"/>
               </a:spcAft>
@@ -1545,16 +1584,16 @@
                 <a:solidFill>
                   <a:srgbClr val="FFFFFF"/>
                 </a:solidFill>
-                <a:latin typeface="Arial" pitchFamily="34" charset="0"/>
-                <a:ea typeface="Arial" pitchFamily="34" charset="-122"/>
-                <a:cs typeface="Arial" pitchFamily="34" charset="-120"/>
-              </a:rPr>
-              <a:t>מבצעים: ______________ · ______________</a:t>
+                <a:latin typeface="Calibri" pitchFamily="34" charset="0"/>
+                <a:ea typeface="Calibri" pitchFamily="34" charset="-122"/>
+                <a:cs typeface="Calibri" pitchFamily="34" charset="-120"/>
+              </a:rPr>
+              <a:t>Authors:  ______________  ·  ______________</a:t>
             </a:r>
             <a:endParaRPr lang="en-US" sz="1500" dirty="0"/>
           </a:p>
           <a:p>
-            <a:pPr algn="r" indent="0" marL="0">
+            <a:pPr algn="l" indent="0" marL="0">
               <a:spcAft>
                 <a:spcPts val="600"/>
               </a:spcAft>
@@ -1565,16 +1604,16 @@
                 <a:solidFill>
                   <a:srgbClr val="059669"/>
                 </a:solidFill>
-                <a:latin typeface="Arial" pitchFamily="34" charset="0"/>
-                <a:ea typeface="Arial" pitchFamily="34" charset="-122"/>
-                <a:cs typeface="Arial" pitchFamily="34" charset="-120"/>
-              </a:rPr>
-              <a:t>GitHub: ________________________________</a:t>
+                <a:latin typeface="Calibri" pitchFamily="34" charset="0"/>
+                <a:ea typeface="Calibri" pitchFamily="34" charset="-122"/>
+                <a:cs typeface="Calibri" pitchFamily="34" charset="-120"/>
+              </a:rPr>
+              <a:t>GitHub:  github.com/dolfinvarshev/Development-on-web-platforms</a:t>
             </a:r>
             <a:endParaRPr lang="en-US" sz="1500" dirty="0"/>
           </a:p>
           <a:p>
-            <a:pPr algn="r" indent="0" marL="0">
+            <a:pPr algn="l" indent="0" marL="0">
               <a:spcAft>
                 <a:spcPts val="600"/>
               </a:spcAft>
@@ -1585,16 +1624,16 @@
                 <a:solidFill>
                   <a:srgbClr val="059669"/>
                 </a:solidFill>
-                <a:latin typeface="Arial" pitchFamily="34" charset="0"/>
-                <a:ea typeface="Arial" pitchFamily="34" charset="-122"/>
-                <a:cs typeface="Arial" pitchFamily="34" charset="-120"/>
-              </a:rPr>
-              <a:t>כתובת בענן: ____________________________</a:t>
+                <a:latin typeface="Calibri" pitchFamily="34" charset="0"/>
+                <a:ea typeface="Calibri" pitchFamily="34" charset="-122"/>
+                <a:cs typeface="Calibri" pitchFamily="34" charset="-120"/>
+              </a:rPr>
+              <a:t>Cloud:  ____________________________________</a:t>
             </a:r>
             <a:endParaRPr lang="en-US" sz="1500" dirty="0"/>
           </a:p>
           <a:p>
-            <a:pPr algn="r" indent="0" marL="0">
+            <a:pPr algn="l" indent="0" marL="0">
               <a:buNone/>
             </a:pPr>
             <a:r>
@@ -1602,11 +1641,11 @@
                 <a:solidFill>
                   <a:srgbClr val="CBD5E1"/>
                 </a:solidFill>
-                <a:latin typeface="Arial" pitchFamily="34" charset="0"/>
-                <a:ea typeface="Arial" pitchFamily="34" charset="-122"/>
-                <a:cs typeface="Arial" pitchFamily="34" charset="-120"/>
-              </a:rPr>
-              <a:t>כניסת מנהל להדגמה: micha / 1234</a:t>
+                <a:latin typeface="Calibri" pitchFamily="34" charset="0"/>
+                <a:ea typeface="Calibri" pitchFamily="34" charset="-122"/>
+                <a:cs typeface="Calibri" pitchFamily="34" charset="-120"/>
+              </a:rPr>
+              <a:t>Admin login for the demo:  micha / 1234</a:t>
             </a:r>
             <a:endParaRPr lang="en-US" sz="1500" dirty="0"/>
           </a:p>
@@ -1665,7 +1704,7 @@
           <a:bodyPr wrap="square" rtlCol="0" anchor="ctr"/>
           <a:lstStyle/>
           <a:p>
-            <a:pPr rtl="1" algn="r" indent="0" marL="0">
+            <a:pPr algn="l" indent="0" marL="0">
               <a:buNone/>
             </a:pPr>
             <a:r>
@@ -1677,7 +1716,7 @@
                 <a:ea typeface="Arial" pitchFamily="34" charset="-122"/>
                 <a:cs typeface="Arial" pitchFamily="34" charset="-120"/>
               </a:rPr>
-              <a:t>בעיות ידועות — גילוי נאות</a:t>
+              <a:t>Known Issues — Honest Disclosure</a:t>
             </a:r>
             <a:endParaRPr lang="en-US" sz="3400" dirty="0"/>
           </a:p>
@@ -1704,33 +1743,131 @@
           <a:bodyPr wrap="square" rtlCol="0" anchor="ctr"/>
           <a:lstStyle/>
           <a:p>
-            <a:pPr rtl="1" algn="r" indent="0" marL="0">
-              <a:buNone/>
-            </a:pPr>
-            <a:r>
-              <a:rPr lang="en-US" sz="1500" i="1" dirty="0">
+            <a:pPr algn="l" indent="0" marL="0">
+              <a:buNone/>
+            </a:pPr>
+            <a:r>
+              <a:rPr lang="en-US" sz="1400" i="1" dirty="0">
                 <a:solidFill>
                   <a:srgbClr val="64748B"/>
+                </a:solidFill>
+                <a:latin typeface="Calibri" pitchFamily="34" charset="0"/>
+                <a:ea typeface="Calibri" pitchFamily="34" charset="-122"/>
+                <a:cs typeface="Calibri" pitchFamily="34" charset="-120"/>
+              </a:rPr>
+              <a:t>An issue discovered during the defense that was not declared here costs points — so everything is here, in the open.</a:t>
+            </a:r>
+            <a:endParaRPr lang="en-US" sz="1400" dirty="0"/>
+          </a:p>
+        </p:txBody>
+      </p:sp>
+      <p:sp>
+        <p:nvSpPr>
+          <p:cNvPr id="4" name="Shape 2"/>
+          <p:cNvSpPr/>
+          <p:nvPr/>
+        </p:nvSpPr>
+        <p:spPr>
+          <a:xfrm>
+            <a:off x="502920" y="1737360"/>
+            <a:ext cx="256032" cy="256032"/>
+          </a:xfrm>
+          <a:prstGeom prst="ellipse">
+            <a:avLst/>
+          </a:prstGeom>
+          <a:solidFill>
+            <a:srgbClr val="DC2626"/>
+          </a:solidFill>
+          <a:ln/>
+        </p:spPr>
+      </p:sp>
+      <p:sp>
+        <p:nvSpPr>
+          <p:cNvPr id="5" name="Text 3"/>
+          <p:cNvSpPr/>
+          <p:nvPr/>
+        </p:nvSpPr>
+        <p:spPr>
+          <a:xfrm>
+            <a:off x="914400" y="1691640"/>
+            <a:ext cx="10607040" cy="365760"/>
+          </a:xfrm>
+          <a:prstGeom prst="rect">
+            <a:avLst/>
+          </a:prstGeom>
+          <a:noFill/>
+          <a:ln/>
+        </p:spPr>
+        <p:txBody>
+          <a:bodyPr wrap="square" lIns="0" tIns="0" rIns="0" bIns="0" rtlCol="0" anchor="ctr"/>
+          <a:lstStyle/>
+          <a:p>
+            <a:pPr algn="l" indent="0" marL="0">
+              <a:buNone/>
+            </a:pPr>
+            <a:r>
+              <a:rPr lang="en-US" sz="1600" b="1" dirty="0">
+                <a:solidFill>
+                  <a:srgbClr val="0F172A"/>
                 </a:solidFill>
                 <a:latin typeface="Arial" pitchFamily="34" charset="0"/>
                 <a:ea typeface="Arial" pitchFamily="34" charset="-122"/>
                 <a:cs typeface="Arial" pitchFamily="34" charset="-120"/>
               </a:rPr>
-              <a:t>אי-גילוי של בעיה שתתגלה בהגנה יוריד ניקוד — לכן הכול כאן, בגלוי.</a:t>
-            </a:r>
-            <a:endParaRPr lang="en-US" sz="1500" dirty="0"/>
-          </a:p>
-        </p:txBody>
-      </p:sp>
-      <p:sp>
-        <p:nvSpPr>
-          <p:cNvPr id="4" name="Shape 2"/>
-          <p:cNvSpPr/>
-          <p:nvPr/>
-        </p:nvSpPr>
-        <p:spPr>
-          <a:xfrm>
-            <a:off x="11292840" y="1783080"/>
+              <a:t>Render Free "sleeps"</a:t>
+            </a:r>
+            <a:endParaRPr lang="en-US" sz="1600" dirty="0"/>
+          </a:p>
+        </p:txBody>
+      </p:sp>
+      <p:sp>
+        <p:nvSpPr>
+          <p:cNvPr id="6" name="Text 4"/>
+          <p:cNvSpPr/>
+          <p:nvPr/>
+        </p:nvSpPr>
+        <p:spPr>
+          <a:xfrm>
+            <a:off x="914400" y="2039112"/>
+            <a:ext cx="10607040" cy="502920"/>
+          </a:xfrm>
+          <a:prstGeom prst="rect">
+            <a:avLst/>
+          </a:prstGeom>
+          <a:noFill/>
+          <a:ln/>
+        </p:spPr>
+        <p:txBody>
+          <a:bodyPr wrap="square" lIns="0" tIns="0" rIns="0" bIns="0" rtlCol="0" anchor="ctr"/>
+          <a:lstStyle/>
+          <a:p>
+            <a:pPr algn="l" indent="0" marL="0">
+              <a:buNone/>
+            </a:pPr>
+            <a:r>
+              <a:rPr lang="en-US" sz="1300" dirty="0">
+                <a:solidFill>
+                  <a:srgbClr val="334155"/>
+                </a:solidFill>
+                <a:latin typeface="Calibri" pitchFamily="34" charset="0"/>
+                <a:ea typeface="Calibri" pitchFamily="34" charset="-122"/>
+                <a:cs typeface="Calibri" pitchFamily="34" charset="-120"/>
+              </a:rPr>
+              <a:t>After ~15 min of inactivity the first API request is slow (~30s). Workaround: open /api/health a minute before the demo.</a:t>
+            </a:r>
+            <a:endParaRPr lang="en-US" sz="1300" dirty="0"/>
+          </a:p>
+        </p:txBody>
+      </p:sp>
+      <p:sp>
+        <p:nvSpPr>
+          <p:cNvPr id="7" name="Shape 5"/>
+          <p:cNvSpPr/>
+          <p:nvPr/>
+        </p:nvSpPr>
+        <p:spPr>
+          <a:xfrm>
+            <a:off x="502920" y="2679192"/>
             <a:ext cx="256032" cy="256032"/>
           </a:xfrm>
           <a:prstGeom prst="ellipse">
@@ -1744,14 +1881,14 @@
       </p:sp>
       <p:sp>
         <p:nvSpPr>
-          <p:cNvPr id="5" name="Text 3"/>
-          <p:cNvSpPr/>
-          <p:nvPr/>
-        </p:nvSpPr>
-        <p:spPr>
-          <a:xfrm>
-            <a:off x="6035040" y="1737360"/>
-            <a:ext cx="5120640" cy="365760"/>
+          <p:cNvPr id="8" name="Text 6"/>
+          <p:cNvSpPr/>
+          <p:nvPr/>
+        </p:nvSpPr>
+        <p:spPr>
+          <a:xfrm>
+            <a:off x="914400" y="2633472"/>
+            <a:ext cx="10607040" cy="365760"/>
           </a:xfrm>
           <a:prstGeom prst="rect">
             <a:avLst/>
@@ -1763,7 +1900,7 @@
           <a:bodyPr wrap="square" lIns="0" tIns="0" rIns="0" bIns="0" rtlCol="0" anchor="ctr"/>
           <a:lstStyle/>
           <a:p>
-            <a:pPr rtl="1" algn="r" indent="0" marL="0">
+            <a:pPr algn="l" indent="0" marL="0">
               <a:buNone/>
             </a:pPr>
             <a:r>
@@ -1775,7 +1912,7 @@
                 <a:ea typeface="Arial" pitchFamily="34" charset="-122"/>
                 <a:cs typeface="Arial" pitchFamily="34" charset="-120"/>
               </a:rPr>
-              <a:t>Render Free "נרדם"</a:t>
+              <a:t>SQLite is not persistent in the free cloud</a:t>
             </a:r>
             <a:endParaRPr lang="en-US" sz="1600" dirty="0"/>
           </a:p>
@@ -1783,14 +1920,14 @@
       </p:sp>
       <p:sp>
         <p:nvSpPr>
-          <p:cNvPr id="6" name="Text 4"/>
-          <p:cNvSpPr/>
-          <p:nvPr/>
-        </p:nvSpPr>
-        <p:spPr>
-          <a:xfrm>
-            <a:off x="457200" y="2103120"/>
-            <a:ext cx="10698480" cy="502920"/>
+          <p:cNvPr id="9" name="Text 7"/>
+          <p:cNvSpPr/>
+          <p:nvPr/>
+        </p:nvSpPr>
+        <p:spPr>
+          <a:xfrm>
+            <a:off x="914400" y="2980944"/>
+            <a:ext cx="10607040" cy="502920"/>
           </a:xfrm>
           <a:prstGeom prst="rect">
             <a:avLst/>
@@ -1802,19 +1939,117 @@
           <a:bodyPr wrap="square" lIns="0" tIns="0" rIns="0" bIns="0" rtlCol="0" anchor="ctr"/>
           <a:lstStyle/>
           <a:p>
-            <a:pPr rtl="1" algn="r" indent="0" marL="0">
+            <a:pPr algn="l" indent="0" marL="0">
               <a:buNone/>
             </a:pPr>
             <a:r>
               <a:rPr lang="en-US" sz="1300" dirty="0">
                 <a:solidFill>
                   <a:srgbClr val="334155"/>
+                </a:solidFill>
+                <a:latin typeface="Calibri" pitchFamily="34" charset="0"/>
+                <a:ea typeface="Calibri" pitchFamily="34" charset="-122"/>
+                <a:cs typeface="Calibri" pitchFamily="34" charset="-120"/>
+              </a:rPr>
+              <a:t>Every deploy re-seeds the data (the 50 demo devices return). Locally everything persists.</a:t>
+            </a:r>
+            <a:endParaRPr lang="en-US" sz="1300" dirty="0"/>
+          </a:p>
+        </p:txBody>
+      </p:sp>
+      <p:sp>
+        <p:nvSpPr>
+          <p:cNvPr id="10" name="Shape 8"/>
+          <p:cNvSpPr/>
+          <p:nvPr/>
+        </p:nvSpPr>
+        <p:spPr>
+          <a:xfrm>
+            <a:off x="502920" y="3621024"/>
+            <a:ext cx="256032" cy="256032"/>
+          </a:xfrm>
+          <a:prstGeom prst="ellipse">
+            <a:avLst/>
+          </a:prstGeom>
+          <a:solidFill>
+            <a:srgbClr val="DC2626"/>
+          </a:solidFill>
+          <a:ln/>
+        </p:spPr>
+      </p:sp>
+      <p:sp>
+        <p:nvSpPr>
+          <p:cNvPr id="11" name="Text 9"/>
+          <p:cNvSpPr/>
+          <p:nvPr/>
+        </p:nvSpPr>
+        <p:spPr>
+          <a:xfrm>
+            <a:off x="914400" y="3575304"/>
+            <a:ext cx="10607040" cy="365760"/>
+          </a:xfrm>
+          <a:prstGeom prst="rect">
+            <a:avLst/>
+          </a:prstGeom>
+          <a:noFill/>
+          <a:ln/>
+        </p:spPr>
+        <p:txBody>
+          <a:bodyPr wrap="square" lIns="0" tIns="0" rIns="0" bIns="0" rtlCol="0" anchor="ctr"/>
+          <a:lstStyle/>
+          <a:p>
+            <a:pPr algn="l" indent="0" marL="0">
+              <a:buNone/>
+            </a:pPr>
+            <a:r>
+              <a:rPr lang="en-US" sz="1600" b="1" dirty="0">
+                <a:solidFill>
+                  <a:srgbClr val="0F172A"/>
                 </a:solidFill>
                 <a:latin typeface="Arial" pitchFamily="34" charset="0"/>
                 <a:ea typeface="Arial" pitchFamily="34" charset="-122"/>
                 <a:cs typeface="Arial" pitchFamily="34" charset="-120"/>
               </a:rPr>
-              <a:t>אחרי ~15 דק׳ חוסר פעילות הבקשה הראשונה ל-API איטית (~30 שנ׳). מעקף: פותחים /api/health דקה מראש.</a:t>
+              <a:t>Local MongoDB</a:t>
+            </a:r>
+            <a:endParaRPr lang="en-US" sz="1600" dirty="0"/>
+          </a:p>
+        </p:txBody>
+      </p:sp>
+      <p:sp>
+        <p:nvSpPr>
+          <p:cNvPr id="12" name="Text 10"/>
+          <p:cNvSpPr/>
+          <p:nvPr/>
+        </p:nvSpPr>
+        <p:spPr>
+          <a:xfrm>
+            <a:off x="914400" y="3922776"/>
+            <a:ext cx="10607040" cy="502920"/>
+          </a:xfrm>
+          <a:prstGeom prst="rect">
+            <a:avLst/>
+          </a:prstGeom>
+          <a:noFill/>
+          <a:ln/>
+        </p:spPr>
+        <p:txBody>
+          <a:bodyPr wrap="square" lIns="0" tIns="0" rIns="0" bIns="0" rtlCol="0" anchor="ctr"/>
+          <a:lstStyle/>
+          <a:p>
+            <a:pPr algn="l" indent="0" marL="0">
+              <a:buNone/>
+            </a:pPr>
+            <a:r>
+              <a:rPr lang="en-US" sz="1300" dirty="0">
+                <a:solidFill>
+                  <a:srgbClr val="334155"/>
+                </a:solidFill>
+                <a:latin typeface="Calibri" pitchFamily="34" charset="0"/>
+                <a:ea typeface="Calibri" pitchFamily="34" charset="-122"/>
+                <a:cs typeface="Calibri" pitchFamily="34" charset="-120"/>
+              </a:rPr>
+              <a:t>Runs with a persistent local data directory; deleting server/data resets to demo data. In the cloud — Atlas.</a:t>
             </a:r>
             <a:endParaRPr lang="en-US" sz="1300" dirty="0"/>
           </a:p>
@@ -1822,13 +2057,13 @@
       </p:sp>
       <p:sp>
         <p:nvSpPr>
-          <p:cNvPr id="7" name="Shape 5"/>
-          <p:cNvSpPr/>
-          <p:nvPr/>
-        </p:nvSpPr>
-        <p:spPr>
-          <a:xfrm>
-            <a:off x="11292840" y="2715768"/>
+          <p:cNvPr id="13" name="Shape 11"/>
+          <p:cNvSpPr/>
+          <p:nvPr/>
+        </p:nvSpPr>
+        <p:spPr>
+          <a:xfrm>
+            <a:off x="502920" y="4562856"/>
             <a:ext cx="256032" cy="256032"/>
           </a:xfrm>
           <a:prstGeom prst="ellipse">
@@ -1842,14 +2077,14 @@
       </p:sp>
       <p:sp>
         <p:nvSpPr>
-          <p:cNvPr id="8" name="Text 6"/>
-          <p:cNvSpPr/>
-          <p:nvPr/>
-        </p:nvSpPr>
-        <p:spPr>
-          <a:xfrm>
-            <a:off x="6035040" y="2670048"/>
-            <a:ext cx="5120640" cy="365760"/>
+          <p:cNvPr id="14" name="Text 12"/>
+          <p:cNvSpPr/>
+          <p:nvPr/>
+        </p:nvSpPr>
+        <p:spPr>
+          <a:xfrm>
+            <a:off x="914400" y="4517136"/>
+            <a:ext cx="10607040" cy="365760"/>
           </a:xfrm>
           <a:prstGeom prst="rect">
             <a:avLst/>
@@ -1861,7 +2096,7 @@
           <a:bodyPr wrap="square" lIns="0" tIns="0" rIns="0" bIns="0" rtlCol="0" anchor="ctr"/>
           <a:lstStyle/>
           <a:p>
-            <a:pPr rtl="1" algn="r" indent="0" marL="0">
+            <a:pPr algn="l" indent="0" marL="0">
               <a:buNone/>
             </a:pPr>
             <a:r>
@@ -1873,7 +2108,7 @@
                 <a:ea typeface="Arial" pitchFamily="34" charset="-122"/>
                 <a:cs typeface="Arial" pitchFamily="34" charset="-120"/>
               </a:rPr>
-              <a:t>SQLite בענן אינו מתמיד</a:t>
+              <a:t>Routing service (OSRM)</a:t>
             </a:r>
             <a:endParaRPr lang="en-US" sz="1600" dirty="0"/>
           </a:p>
@@ -1881,14 +2116,14 @@
       </p:sp>
       <p:sp>
         <p:nvSpPr>
-          <p:cNvPr id="9" name="Text 7"/>
-          <p:cNvSpPr/>
-          <p:nvPr/>
-        </p:nvSpPr>
-        <p:spPr>
-          <a:xfrm>
-            <a:off x="457200" y="3035808"/>
-            <a:ext cx="10698480" cy="502920"/>
+          <p:cNvPr id="15" name="Text 13"/>
+          <p:cNvSpPr/>
+          <p:nvPr/>
+        </p:nvSpPr>
+        <p:spPr>
+          <a:xfrm>
+            <a:off x="914400" y="4864608"/>
+            <a:ext cx="10607040" cy="502920"/>
           </a:xfrm>
           <a:prstGeom prst="rect">
             <a:avLst/>
@@ -1900,19 +2135,117 @@
           <a:bodyPr wrap="square" lIns="0" tIns="0" rIns="0" bIns="0" rtlCol="0" anchor="ctr"/>
           <a:lstStyle/>
           <a:p>
-            <a:pPr rtl="1" algn="r" indent="0" marL="0">
+            <a:pPr algn="l" indent="0" marL="0">
               <a:buNone/>
             </a:pPr>
             <a:r>
               <a:rPr lang="en-US" sz="1300" dirty="0">
                 <a:solidFill>
                   <a:srgbClr val="334155"/>
+                </a:solidFill>
+                <a:latin typeface="Calibri" pitchFamily="34" charset="0"/>
+                <a:ea typeface="Calibri" pitchFamily="34" charset="-122"/>
+                <a:cs typeface="Calibri" pitchFamily="34" charset="-120"/>
+              </a:rPr>
+              <a:t>A free third-party dependency; on failure the UI shows an approximate straight line with a notice.</a:t>
+            </a:r>
+            <a:endParaRPr lang="en-US" sz="1300" dirty="0"/>
+          </a:p>
+        </p:txBody>
+      </p:sp>
+      <p:sp>
+        <p:nvSpPr>
+          <p:cNvPr id="16" name="Shape 14"/>
+          <p:cNvSpPr/>
+          <p:nvPr/>
+        </p:nvSpPr>
+        <p:spPr>
+          <a:xfrm>
+            <a:off x="502920" y="5504688"/>
+            <a:ext cx="256032" cy="256032"/>
+          </a:xfrm>
+          <a:prstGeom prst="ellipse">
+            <a:avLst/>
+          </a:prstGeom>
+          <a:solidFill>
+            <a:srgbClr val="DC2626"/>
+          </a:solidFill>
+          <a:ln/>
+        </p:spPr>
+      </p:sp>
+      <p:sp>
+        <p:nvSpPr>
+          <p:cNvPr id="17" name="Text 15"/>
+          <p:cNvSpPr/>
+          <p:nvPr/>
+        </p:nvSpPr>
+        <p:spPr>
+          <a:xfrm>
+            <a:off x="914400" y="5458968"/>
+            <a:ext cx="10607040" cy="365760"/>
+          </a:xfrm>
+          <a:prstGeom prst="rect">
+            <a:avLst/>
+          </a:prstGeom>
+          <a:noFill/>
+          <a:ln/>
+        </p:spPr>
+        <p:txBody>
+          <a:bodyPr wrap="square" lIns="0" tIns="0" rIns="0" bIns="0" rtlCol="0" anchor="ctr"/>
+          <a:lstStyle/>
+          <a:p>
+            <a:pPr algn="l" indent="0" marL="0">
+              <a:buNone/>
+            </a:pPr>
+            <a:r>
+              <a:rPr lang="en-US" sz="1600" b="1" dirty="0">
+                <a:solidFill>
+                  <a:srgbClr val="0F172A"/>
                 </a:solidFill>
                 <a:latin typeface="Arial" pitchFamily="34" charset="0"/>
                 <a:ea typeface="Arial" pitchFamily="34" charset="-122"/>
                 <a:cs typeface="Arial" pitchFamily="34" charset="-120"/>
               </a:rPr>
-              <a:t>בכל Deploy הנתונים נזרעים מחדש (50 מכשירי הדמו חוזרים). מקומית הכול נשמר.</a:t>
+              <a:t>Real SMS/Push are not sent</a:t>
+            </a:r>
+            <a:endParaRPr lang="en-US" sz="1600" dirty="0"/>
+          </a:p>
+        </p:txBody>
+      </p:sp>
+      <p:sp>
+        <p:nvSpPr>
+          <p:cNvPr id="18" name="Text 16"/>
+          <p:cNvSpPr/>
+          <p:nvPr/>
+        </p:nvSpPr>
+        <p:spPr>
+          <a:xfrm>
+            <a:off x="914400" y="5806440"/>
+            <a:ext cx="10607040" cy="502920"/>
+          </a:xfrm>
+          <a:prstGeom prst="rect">
+            <a:avLst/>
+          </a:prstGeom>
+          <a:noFill/>
+          <a:ln/>
+        </p:spPr>
+        <p:txBody>
+          <a:bodyPr wrap="square" lIns="0" tIns="0" rIns="0" bIns="0" rtlCol="0" anchor="ctr"/>
+          <a:lstStyle/>
+          <a:p>
+            <a:pPr algn="l" indent="0" marL="0">
+              <a:buNone/>
+            </a:pPr>
+            <a:r>
+              <a:rPr lang="en-US" sz="1300" dirty="0">
+                <a:solidFill>
+                  <a:srgbClr val="334155"/>
+                </a:solidFill>
+                <a:latin typeface="Calibri" pitchFamily="34" charset="0"/>
+                <a:ea typeface="Calibri" pitchFamily="34" charset="-122"/>
+                <a:cs typeface="Calibri" pitchFamily="34" charset="-120"/>
+              </a:rPr>
+              <a:t>Simulated in the simulator and recorded in the alert log (real SMS is never free and is not required).</a:t>
             </a:r>
             <a:endParaRPr lang="en-US" sz="1300" dirty="0"/>
           </a:p>
@@ -1920,34 +2253,14 @@
       </p:sp>
       <p:sp>
         <p:nvSpPr>
-          <p:cNvPr id="10" name="Shape 8"/>
-          <p:cNvSpPr/>
-          <p:nvPr/>
-        </p:nvSpPr>
-        <p:spPr>
-          <a:xfrm>
-            <a:off x="11292840" y="3648456"/>
-            <a:ext cx="256032" cy="256032"/>
-          </a:xfrm>
-          <a:prstGeom prst="ellipse">
-            <a:avLst/>
-          </a:prstGeom>
-          <a:solidFill>
-            <a:srgbClr val="DC2626"/>
-          </a:solidFill>
-          <a:ln/>
-        </p:spPr>
-      </p:sp>
-      <p:sp>
-        <p:nvSpPr>
-          <p:cNvPr id="11" name="Text 9"/>
-          <p:cNvSpPr/>
-          <p:nvPr/>
-        </p:nvSpPr>
-        <p:spPr>
-          <a:xfrm>
-            <a:off x="6035040" y="3602736"/>
-            <a:ext cx="5120640" cy="365760"/>
+          <p:cNvPr id="19" name="Text 17"/>
+          <p:cNvSpPr/>
+          <p:nvPr/>
+        </p:nvSpPr>
+        <p:spPr>
+          <a:xfrm>
+            <a:off x="8138160" y="6419088"/>
+            <a:ext cx="3657600" cy="320040"/>
           </a:xfrm>
           <a:prstGeom prst="rect">
             <a:avLst/>
@@ -1959,281 +2272,7 @@
           <a:bodyPr wrap="square" lIns="0" tIns="0" rIns="0" bIns="0" rtlCol="0" anchor="ctr"/>
           <a:lstStyle/>
           <a:p>
-            <a:pPr rtl="1" algn="r" indent="0" marL="0">
-              <a:buNone/>
-            </a:pPr>
-            <a:r>
-              <a:rPr lang="en-US" sz="1600" b="1" dirty="0">
-                <a:solidFill>
-                  <a:srgbClr val="0F172A"/>
-                </a:solidFill>
-                <a:latin typeface="Arial" pitchFamily="34" charset="0"/>
-                <a:ea typeface="Arial" pitchFamily="34" charset="-122"/>
-                <a:cs typeface="Arial" pitchFamily="34" charset="-120"/>
-              </a:rPr>
-              <a:t>MongoDB מקומי</a:t>
-            </a:r>
-            <a:endParaRPr lang="en-US" sz="1600" dirty="0"/>
-          </a:p>
-        </p:txBody>
-      </p:sp>
-      <p:sp>
-        <p:nvSpPr>
-          <p:cNvPr id="12" name="Text 10"/>
-          <p:cNvSpPr/>
-          <p:nvPr/>
-        </p:nvSpPr>
-        <p:spPr>
-          <a:xfrm>
-            <a:off x="457200" y="3968496"/>
-            <a:ext cx="10698480" cy="502920"/>
-          </a:xfrm>
-          <a:prstGeom prst="rect">
-            <a:avLst/>
-          </a:prstGeom>
-          <a:noFill/>
-          <a:ln/>
-        </p:spPr>
-        <p:txBody>
-          <a:bodyPr wrap="square" lIns="0" tIns="0" rIns="0" bIns="0" rtlCol="0" anchor="ctr"/>
-          <a:lstStyle/>
-          <a:p>
-            <a:pPr rtl="1" algn="r" indent="0" marL="0">
-              <a:buNone/>
-            </a:pPr>
-            <a:r>
-              <a:rPr lang="en-US" sz="1300" dirty="0">
-                <a:solidFill>
-                  <a:srgbClr val="334155"/>
-                </a:solidFill>
-                <a:latin typeface="Arial" pitchFamily="34" charset="0"/>
-                <a:ea typeface="Arial" pitchFamily="34" charset="-122"/>
-                <a:cs typeface="Arial" pitchFamily="34" charset="-120"/>
-              </a:rPr>
-              <a:t>רץ עם תיקיית נתונים מתמידה; מחיקת server/data מאפסת לנתוני הדמו. בענן — Atlas.</a:t>
-            </a:r>
-            <a:endParaRPr lang="en-US" sz="1300" dirty="0"/>
-          </a:p>
-        </p:txBody>
-      </p:sp>
-      <p:sp>
-        <p:nvSpPr>
-          <p:cNvPr id="13" name="Shape 11"/>
-          <p:cNvSpPr/>
-          <p:nvPr/>
-        </p:nvSpPr>
-        <p:spPr>
-          <a:xfrm>
-            <a:off x="11292840" y="4581144"/>
-            <a:ext cx="256032" cy="256032"/>
-          </a:xfrm>
-          <a:prstGeom prst="ellipse">
-            <a:avLst/>
-          </a:prstGeom>
-          <a:solidFill>
-            <a:srgbClr val="DC2626"/>
-          </a:solidFill>
-          <a:ln/>
-        </p:spPr>
-      </p:sp>
-      <p:sp>
-        <p:nvSpPr>
-          <p:cNvPr id="14" name="Text 12"/>
-          <p:cNvSpPr/>
-          <p:nvPr/>
-        </p:nvSpPr>
-        <p:spPr>
-          <a:xfrm>
-            <a:off x="6035040" y="4535424"/>
-            <a:ext cx="5120640" cy="365760"/>
-          </a:xfrm>
-          <a:prstGeom prst="rect">
-            <a:avLst/>
-          </a:prstGeom>
-          <a:noFill/>
-          <a:ln/>
-        </p:spPr>
-        <p:txBody>
-          <a:bodyPr wrap="square" lIns="0" tIns="0" rIns="0" bIns="0" rtlCol="0" anchor="ctr"/>
-          <a:lstStyle/>
-          <a:p>
-            <a:pPr rtl="1" algn="r" indent="0" marL="0">
-              <a:buNone/>
-            </a:pPr>
-            <a:r>
-              <a:rPr lang="en-US" sz="1600" b="1" dirty="0">
-                <a:solidFill>
-                  <a:srgbClr val="0F172A"/>
-                </a:solidFill>
-                <a:latin typeface="Arial" pitchFamily="34" charset="0"/>
-                <a:ea typeface="Arial" pitchFamily="34" charset="-122"/>
-                <a:cs typeface="Arial" pitchFamily="34" charset="-120"/>
-              </a:rPr>
-              <a:t>שירות הניתוב (OSRM)</a:t>
-            </a:r>
-            <a:endParaRPr lang="en-US" sz="1600" dirty="0"/>
-          </a:p>
-        </p:txBody>
-      </p:sp>
-      <p:sp>
-        <p:nvSpPr>
-          <p:cNvPr id="15" name="Text 13"/>
-          <p:cNvSpPr/>
-          <p:nvPr/>
-        </p:nvSpPr>
-        <p:spPr>
-          <a:xfrm>
-            <a:off x="457200" y="4901184"/>
-            <a:ext cx="10698480" cy="502920"/>
-          </a:xfrm>
-          <a:prstGeom prst="rect">
-            <a:avLst/>
-          </a:prstGeom>
-          <a:noFill/>
-          <a:ln/>
-        </p:spPr>
-        <p:txBody>
-          <a:bodyPr wrap="square" lIns="0" tIns="0" rIns="0" bIns="0" rtlCol="0" anchor="ctr"/>
-          <a:lstStyle/>
-          <a:p>
-            <a:pPr rtl="1" algn="r" indent="0" marL="0">
-              <a:buNone/>
-            </a:pPr>
-            <a:r>
-              <a:rPr lang="en-US" sz="1300" dirty="0">
-                <a:solidFill>
-                  <a:srgbClr val="334155"/>
-                </a:solidFill>
-                <a:latin typeface="Arial" pitchFamily="34" charset="0"/>
-                <a:ea typeface="Arial" pitchFamily="34" charset="-122"/>
-                <a:cs typeface="Arial" pitchFamily="34" charset="-120"/>
-              </a:rPr>
-              <a:t>תלוי בצד-שלישי חינמי; בעת כשל מוצג קו מסלול משוער עם הודעה.</a:t>
-            </a:r>
-            <a:endParaRPr lang="en-US" sz="1300" dirty="0"/>
-          </a:p>
-        </p:txBody>
-      </p:sp>
-      <p:sp>
-        <p:nvSpPr>
-          <p:cNvPr id="16" name="Shape 14"/>
-          <p:cNvSpPr/>
-          <p:nvPr/>
-        </p:nvSpPr>
-        <p:spPr>
-          <a:xfrm>
-            <a:off x="11292840" y="5513832"/>
-            <a:ext cx="256032" cy="256032"/>
-          </a:xfrm>
-          <a:prstGeom prst="ellipse">
-            <a:avLst/>
-          </a:prstGeom>
-          <a:solidFill>
-            <a:srgbClr val="DC2626"/>
-          </a:solidFill>
-          <a:ln/>
-        </p:spPr>
-      </p:sp>
-      <p:sp>
-        <p:nvSpPr>
-          <p:cNvPr id="17" name="Text 15"/>
-          <p:cNvSpPr/>
-          <p:nvPr/>
-        </p:nvSpPr>
-        <p:spPr>
-          <a:xfrm>
-            <a:off x="6035040" y="5468112"/>
-            <a:ext cx="5120640" cy="365760"/>
-          </a:xfrm>
-          <a:prstGeom prst="rect">
-            <a:avLst/>
-          </a:prstGeom>
-          <a:noFill/>
-          <a:ln/>
-        </p:spPr>
-        <p:txBody>
-          <a:bodyPr wrap="square" lIns="0" tIns="0" rIns="0" bIns="0" rtlCol="0" anchor="ctr"/>
-          <a:lstStyle/>
-          <a:p>
-            <a:pPr rtl="1" algn="r" indent="0" marL="0">
-              <a:buNone/>
-            </a:pPr>
-            <a:r>
-              <a:rPr lang="en-US" sz="1600" b="1" dirty="0">
-                <a:solidFill>
-                  <a:srgbClr val="0F172A"/>
-                </a:solidFill>
-                <a:latin typeface="Arial" pitchFamily="34" charset="0"/>
-                <a:ea typeface="Arial" pitchFamily="34" charset="-122"/>
-                <a:cs typeface="Arial" pitchFamily="34" charset="-120"/>
-              </a:rPr>
-              <a:t>SMS/Push אמיתיים</a:t>
-            </a:r>
-            <a:endParaRPr lang="en-US" sz="1600" dirty="0"/>
-          </a:p>
-        </p:txBody>
-      </p:sp>
-      <p:sp>
-        <p:nvSpPr>
-          <p:cNvPr id="18" name="Text 16"/>
-          <p:cNvSpPr/>
-          <p:nvPr/>
-        </p:nvSpPr>
-        <p:spPr>
-          <a:xfrm>
-            <a:off x="457200" y="5833872"/>
-            <a:ext cx="10698480" cy="502920"/>
-          </a:xfrm>
-          <a:prstGeom prst="rect">
-            <a:avLst/>
-          </a:prstGeom>
-          <a:noFill/>
-          <a:ln/>
-        </p:spPr>
-        <p:txBody>
-          <a:bodyPr wrap="square" lIns="0" tIns="0" rIns="0" bIns="0" rtlCol="0" anchor="ctr"/>
-          <a:lstStyle/>
-          <a:p>
-            <a:pPr rtl="1" algn="r" indent="0" marL="0">
-              <a:buNone/>
-            </a:pPr>
-            <a:r>
-              <a:rPr lang="en-US" sz="1300" dirty="0">
-                <a:solidFill>
-                  <a:srgbClr val="334155"/>
-                </a:solidFill>
-                <a:latin typeface="Arial" pitchFamily="34" charset="0"/>
-                <a:ea typeface="Arial" pitchFamily="34" charset="-122"/>
-                <a:cs typeface="Arial" pitchFamily="34" charset="-120"/>
-              </a:rPr>
-              <a:t>מדומים בסימולטור ומתועדים ביומן ההתראות (שליחת SMS אמת אינה חינמית ואינה נדרשת).</a:t>
-            </a:r>
-            <a:endParaRPr lang="en-US" sz="1300" dirty="0"/>
-          </a:p>
-        </p:txBody>
-      </p:sp>
-      <p:sp>
-        <p:nvSpPr>
-          <p:cNvPr id="19" name="Text 17"/>
-          <p:cNvSpPr/>
-          <p:nvPr/>
-        </p:nvSpPr>
-        <p:spPr>
-          <a:xfrm>
-            <a:off x="365760" y="6419088"/>
-            <a:ext cx="3657600" cy="320040"/>
-          </a:xfrm>
-          <a:prstGeom prst="rect">
-            <a:avLst/>
-          </a:prstGeom>
-          <a:noFill/>
-          <a:ln/>
-        </p:spPr>
-        <p:txBody>
-          <a:bodyPr wrap="square" lIns="0" tIns="0" rIns="0" bIns="0" rtlCol="0" anchor="ctr"/>
-          <a:lstStyle/>
-          <a:p>
-            <a:pPr rtl="1" algn="l" indent="0" marL="0">
+            <a:pPr algn="r" indent="0" marL="0">
               <a:buNone/>
             </a:pPr>
             <a:r>
@@ -2241,11 +2280,11 @@
                 <a:solidFill>
                   <a:srgbClr val="64748B"/>
                 </a:solidFill>
-                <a:latin typeface="Arial" pitchFamily="34" charset="0"/>
-                <a:ea typeface="Arial" pitchFamily="34" charset="-122"/>
-                <a:cs typeface="Arial" pitchFamily="34" charset="-120"/>
-              </a:rPr>
-              <a:t>דפי-נט · שקף 2</a:t>
+                <a:latin typeface="Calibri" pitchFamily="34" charset="0"/>
+                <a:ea typeface="Calibri" pitchFamily="34" charset="-122"/>
+                <a:cs typeface="Calibri" pitchFamily="34" charset="-120"/>
+              </a:rPr>
+              <a:t>DefiNet · slide 2</a:t>
             </a:r>
             <a:endParaRPr lang="en-US" sz="900" dirty="0"/>
           </a:p>
@@ -2304,7 +2343,7 @@
           <a:bodyPr wrap="square" rtlCol="0" anchor="ctr"/>
           <a:lstStyle/>
           <a:p>
-            <a:pPr rtl="1" algn="r" indent="0" marL="0">
+            <a:pPr algn="l" indent="0" marL="0">
               <a:buNone/>
             </a:pPr>
             <a:r>
@@ -2316,7 +2355,7 @@
                 <a:ea typeface="Arial" pitchFamily="34" charset="-122"/>
                 <a:cs typeface="Arial" pitchFamily="34" charset="-120"/>
               </a:rPr>
-              <a:t>הארכיטקטורה</a:t>
+              <a:t>Architecture</a:t>
             </a:r>
             <a:endParaRPr lang="en-US" sz="3400" dirty="0"/>
           </a:p>
@@ -2330,12 +2369,12 @@
         </p:nvSpPr>
         <p:spPr>
           <a:xfrm>
-            <a:off x="8412480" y="1371600"/>
-            <a:ext cx="3200400" cy="2194560"/>
+            <a:off x="548640" y="1371600"/>
+            <a:ext cx="3200400" cy="2286000"/>
           </a:xfrm>
           <a:prstGeom prst="roundRect">
             <a:avLst>
-              <a:gd name="adj" fmla="val 5000"/>
+              <a:gd name="adj" fmla="val 4800"/>
             </a:avLst>
           </a:prstGeom>
           <a:solidFill>
@@ -2357,7 +2396,7 @@
         </p:nvSpPr>
         <p:spPr>
           <a:xfrm>
-            <a:off x="8412480" y="1508760"/>
+            <a:off x="548640" y="1508760"/>
             <a:ext cx="3200400" cy="457200"/>
           </a:xfrm>
           <a:prstGeom prst="rect">
@@ -2370,7 +2409,7 @@
           <a:bodyPr wrap="square" rtlCol="0" anchor="ctr"/>
           <a:lstStyle/>
           <a:p>
-            <a:pPr rtl="1" algn="ctr" indent="0" marL="0">
+            <a:pPr algn="ctr" indent="0" marL="0">
               <a:buNone/>
             </a:pPr>
             <a:r>
@@ -2396,8 +2435,8 @@
         </p:nvSpPr>
         <p:spPr>
           <a:xfrm>
-            <a:off x="8549640" y="2011680"/>
-            <a:ext cx="2926080" cy="1463040"/>
+            <a:off x="685800" y="2011680"/>
+            <a:ext cx="2926080" cy="1554480"/>
           </a:xfrm>
           <a:prstGeom prst="rect">
             <a:avLst/>
@@ -2420,11 +2459,11 @@
                 <a:solidFill>
                   <a:srgbClr val="CBD5E1"/>
                 </a:solidFill>
-                <a:latin typeface="Arial" pitchFamily="34" charset="0"/>
-                <a:ea typeface="Arial" pitchFamily="34" charset="-122"/>
-                <a:cs typeface="Arial" pitchFamily="34" charset="-120"/>
-              </a:rPr>
-              <a:t>Vercel · פורט 3000</a:t>
+                <a:latin typeface="Calibri" pitchFamily="34" charset="0"/>
+                <a:ea typeface="Calibri" pitchFamily="34" charset="-122"/>
+                <a:cs typeface="Calibri" pitchFamily="34" charset="-120"/>
+              </a:rPr>
+              <a:t>Vercel · port 3000</a:t>
             </a:r>
             <a:endParaRPr lang="en-US" sz="1200" dirty="0"/>
           </a:p>
@@ -2440,11 +2479,11 @@
                 <a:solidFill>
                   <a:srgbClr val="CBD5E1"/>
                 </a:solidFill>
-                <a:latin typeface="Arial" pitchFamily="34" charset="0"/>
-                <a:ea typeface="Arial" pitchFamily="34" charset="-122"/>
-                <a:cs typeface="Arial" pitchFamily="34" charset="-120"/>
-              </a:rPr>
-              <a:t>שיווק (CMS)</a:t>
+                <a:latin typeface="Calibri" pitchFamily="34" charset="0"/>
+                <a:ea typeface="Calibri" pitchFamily="34" charset="-122"/>
+                <a:cs typeface="Calibri" pitchFamily="34" charset="-120"/>
+              </a:rPr>
+              <a:t>Marketing pages (CMS)</a:t>
             </a:r>
             <a:endParaRPr lang="en-US" sz="1200" dirty="0"/>
           </a:p>
@@ -2460,11 +2499,11 @@
                 <a:solidFill>
                   <a:srgbClr val="CBD5E1"/>
                 </a:solidFill>
-                <a:latin typeface="Arial" pitchFamily="34" charset="0"/>
-                <a:ea typeface="Arial" pitchFamily="34" charset="-122"/>
-                <a:cs typeface="Arial" pitchFamily="34" charset="-120"/>
-              </a:rPr>
-              <a:t>סימולטור (Leaflet)</a:t>
+                <a:latin typeface="Calibri" pitchFamily="34" charset="0"/>
+                <a:ea typeface="Calibri" pitchFamily="34" charset="-122"/>
+                <a:cs typeface="Calibri" pitchFamily="34" charset="-120"/>
+              </a:rPr>
+              <a:t>Map simulator (Leaflet)</a:t>
             </a:r>
             <a:endParaRPr lang="en-US" sz="1200" dirty="0"/>
           </a:p>
@@ -2480,11 +2519,11 @@
                 <a:solidFill>
                   <a:srgbClr val="CBD5E1"/>
                 </a:solidFill>
-                <a:latin typeface="Arial" pitchFamily="34" charset="0"/>
-                <a:ea typeface="Arial" pitchFamily="34" charset="-122"/>
-                <a:cs typeface="Arial" pitchFamily="34" charset="-120"/>
-              </a:rPr>
-              <a:t>פאנל ניהול + אנליטיקה</a:t>
+                <a:latin typeface="Calibri" pitchFamily="34" charset="0"/>
+                <a:ea typeface="Calibri" pitchFamily="34" charset="-122"/>
+                <a:cs typeface="Calibri" pitchFamily="34" charset="-120"/>
+              </a:rPr>
+              <a:t>Admin panel + analytics</a:t>
             </a:r>
             <a:endParaRPr lang="en-US" sz="1200" dirty="0"/>
           </a:p>
@@ -2498,12 +2537,12 @@
         </p:nvSpPr>
         <p:spPr>
           <a:xfrm>
-            <a:off x="4480560" y="1371600"/>
-            <a:ext cx="3657600" cy="2194560"/>
+            <a:off x="4297680" y="1371600"/>
+            <a:ext cx="3657600" cy="2286000"/>
           </a:xfrm>
           <a:prstGeom prst="roundRect">
             <a:avLst>
-              <a:gd name="adj" fmla="val 5000"/>
+              <a:gd name="adj" fmla="val 4800"/>
             </a:avLst>
           </a:prstGeom>
           <a:solidFill>
@@ -2525,7 +2564,7 @@
         </p:nvSpPr>
         <p:spPr>
           <a:xfrm>
-            <a:off x="4480560" y="1508760"/>
+            <a:off x="4297680" y="1508760"/>
             <a:ext cx="3657600" cy="457200"/>
           </a:xfrm>
           <a:prstGeom prst="rect">
@@ -2538,7 +2577,7 @@
           <a:bodyPr wrap="square" rtlCol="0" anchor="ctr"/>
           <a:lstStyle/>
           <a:p>
-            <a:pPr rtl="1" algn="ctr" indent="0" marL="0">
+            <a:pPr algn="ctr" indent="0" marL="0">
               <a:buNone/>
             </a:pPr>
             <a:r>
@@ -2564,8 +2603,8 @@
         </p:nvSpPr>
         <p:spPr>
           <a:xfrm>
-            <a:off x="4617720" y="2011680"/>
-            <a:ext cx="3383280" cy="1463040"/>
+            <a:off x="4434840" y="2011680"/>
+            <a:ext cx="3383280" cy="1554480"/>
           </a:xfrm>
           <a:prstGeom prst="rect">
             <a:avLst/>
@@ -2588,11 +2627,11 @@
                 <a:solidFill>
                   <a:srgbClr val="CBD5E1"/>
                 </a:solidFill>
-                <a:latin typeface="Arial" pitchFamily="34" charset="0"/>
-                <a:ea typeface="Arial" pitchFamily="34" charset="-122"/>
-                <a:cs typeface="Arial" pitchFamily="34" charset="-120"/>
-              </a:rPr>
-              <a:t>Render · פורט 4000</a:t>
+                <a:latin typeface="Calibri" pitchFamily="34" charset="0"/>
+                <a:ea typeface="Calibri" pitchFamily="34" charset="-122"/>
+                <a:cs typeface="Calibri" pitchFamily="34" charset="-120"/>
+              </a:rPr>
+              <a:t>Render · port 4000</a:t>
             </a:r>
             <a:endParaRPr lang="en-US" sz="1200" dirty="0"/>
           </a:p>
@@ -2608,11 +2647,11 @@
                 <a:solidFill>
                   <a:srgbClr val="CBD5E1"/>
                 </a:solidFill>
-                <a:latin typeface="Arial" pitchFamily="34" charset="0"/>
-                <a:ea typeface="Arial" pitchFamily="34" charset="-122"/>
-                <a:cs typeface="Arial" pitchFamily="34" charset="-120"/>
-              </a:rPr>
-              <a:t>JWT + Refresh Rotation</a:t>
+                <a:latin typeface="Calibri" pitchFamily="34" charset="0"/>
+                <a:ea typeface="Calibri" pitchFamily="34" charset="-122"/>
+                <a:cs typeface="Calibri" pitchFamily="34" charset="-120"/>
+              </a:rPr>
+              <a:t>JWT + refresh rotation</a:t>
             </a:r>
             <a:endParaRPr lang="en-US" sz="1200" dirty="0"/>
           </a:p>
@@ -2628,11 +2667,11 @@
                 <a:solidFill>
                   <a:srgbClr val="CBD5E1"/>
                 </a:solidFill>
-                <a:latin typeface="Arial" pitchFamily="34" charset="0"/>
-                <a:ea typeface="Arial" pitchFamily="34" charset="-122"/>
-                <a:cs typeface="Arial" pitchFamily="34" charset="-120"/>
-              </a:rPr>
-              <a:t>מנוע אירועים · Geo-fencing</a:t>
+                <a:latin typeface="Calibri" pitchFamily="34" charset="0"/>
+                <a:ea typeface="Calibri" pitchFamily="34" charset="-122"/>
+                <a:cs typeface="Calibri" pitchFamily="34" charset="-120"/>
+              </a:rPr>
+              <a:t>Incident engine · geo-fencing</a:t>
             </a:r>
             <a:endParaRPr lang="en-US" sz="1200" dirty="0"/>
           </a:p>
@@ -2646,12 +2685,12 @@
         </p:nvSpPr>
         <p:spPr>
           <a:xfrm>
-            <a:off x="548640" y="1371600"/>
-            <a:ext cx="3657600" cy="2194560"/>
+            <a:off x="8503920" y="1371600"/>
+            <a:ext cx="3108960" cy="2286000"/>
           </a:xfrm>
           <a:prstGeom prst="roundRect">
             <a:avLst>
-              <a:gd name="adj" fmla="val 5000"/>
+              <a:gd name="adj" fmla="val 4800"/>
             </a:avLst>
           </a:prstGeom>
           <a:solidFill>
@@ -2673,8 +2712,8 @@
         </p:nvSpPr>
         <p:spPr>
           <a:xfrm>
-            <a:off x="548640" y="1508760"/>
-            <a:ext cx="3657600" cy="457200"/>
+            <a:off x="8503920" y="1508760"/>
+            <a:ext cx="3108960" cy="457200"/>
           </a:xfrm>
           <a:prstGeom prst="rect">
             <a:avLst/>
@@ -2686,7 +2725,7 @@
           <a:bodyPr wrap="square" rtlCol="0" anchor="ctr"/>
           <a:lstStyle/>
           <a:p>
-            <a:pPr rtl="1" algn="ctr" indent="0" marL="0">
+            <a:pPr algn="ctr" indent="0" marL="0">
               <a:buNone/>
             </a:pPr>
             <a:r>
@@ -2698,7 +2737,7 @@
                 <a:ea typeface="Arial" pitchFamily="34" charset="-122"/>
                 <a:cs typeface="Arial" pitchFamily="34" charset="-120"/>
               </a:rPr>
-              <a:t>שני מסדי נתונים</a:t>
+              <a:t>Two databases</a:t>
             </a:r>
             <a:endParaRPr lang="en-US" sz="1700" dirty="0"/>
           </a:p>
@@ -2712,8 +2751,8 @@
         </p:nvSpPr>
         <p:spPr>
           <a:xfrm>
-            <a:off x="685800" y="2011680"/>
-            <a:ext cx="3383280" cy="1463040"/>
+            <a:off x="8641080" y="2011680"/>
+            <a:ext cx="2834640" cy="1554480"/>
           </a:xfrm>
           <a:prstGeom prst="rect">
             <a:avLst/>
@@ -2736,9 +2775,9 @@
                 <a:solidFill>
                   <a:srgbClr val="CBD5E1"/>
                 </a:solidFill>
-                <a:latin typeface="Arial" pitchFamily="34" charset="0"/>
-                <a:ea typeface="Arial" pitchFamily="34" charset="-122"/>
-                <a:cs typeface="Arial" pitchFamily="34" charset="-120"/>
+                <a:latin typeface="Calibri" pitchFamily="34" charset="0"/>
+                <a:ea typeface="Calibri" pitchFamily="34" charset="-122"/>
+                <a:cs typeface="Calibri" pitchFamily="34" charset="-120"/>
               </a:rPr>
               <a:t>SQLite (SQL): users, devices,</a:t>
             </a:r>
@@ -2756,9 +2795,9 @@
                 <a:solidFill>
                   <a:srgbClr val="CBD5E1"/>
                 </a:solidFill>
-                <a:latin typeface="Arial" pitchFamily="34" charset="0"/>
-                <a:ea typeface="Arial" pitchFamily="34" charset="-122"/>
-                <a:cs typeface="Arial" pitchFamily="34" charset="-120"/>
+                <a:latin typeface="Calibri" pitchFamily="34" charset="0"/>
+                <a:ea typeface="Calibri" pitchFamily="34" charset="-122"/>
+                <a:cs typeface="Calibri" pitchFamily="34" charset="-120"/>
               </a:rPr>
               <a:t>admins, refresh_tokens</a:t>
             </a:r>
@@ -2776,9 +2815,9 @@
                 <a:solidFill>
                   <a:srgbClr val="CBD5E1"/>
                 </a:solidFill>
-                <a:latin typeface="Arial" pitchFamily="34" charset="0"/>
-                <a:ea typeface="Arial" pitchFamily="34" charset="-122"/>
-                <a:cs typeface="Arial" pitchFamily="34" charset="-120"/>
+                <a:latin typeface="Calibri" pitchFamily="34" charset="0"/>
+                <a:ea typeface="Calibri" pitchFamily="34" charset="-122"/>
+                <a:cs typeface="Calibri" pitchFamily="34" charset="-120"/>
               </a:rPr>
               <a:t>MongoDB (NoSQL): incidents,</a:t>
             </a:r>
@@ -2796,9 +2835,9 @@
                 <a:solidFill>
                   <a:srgbClr val="CBD5E1"/>
                 </a:solidFill>
-                <a:latin typeface="Arial" pitchFamily="34" charset="0"/>
-                <a:ea typeface="Arial" pitchFamily="34" charset="-122"/>
-                <a:cs typeface="Arial" pitchFamily="34" charset="-120"/>
+                <a:latin typeface="Calibri" pitchFamily="34" charset="0"/>
+                <a:ea typeface="Calibri" pitchFamily="34" charset="-122"/>
+                <a:cs typeface="Calibri" pitchFamily="34" charset="-120"/>
               </a:rPr>
               <a:t>content, alerts, telemetry</a:t>
             </a:r>
@@ -2814,7 +2853,7 @@
         </p:nvSpPr>
         <p:spPr>
           <a:xfrm>
-            <a:off x="7955280" y="2194560"/>
+            <a:off x="3794760" y="2240280"/>
             <a:ext cx="457200" cy="548640"/>
           </a:xfrm>
           <a:prstGeom prst="rect">
@@ -2835,11 +2874,11 @@
                 <a:solidFill>
                   <a:srgbClr val="64748B"/>
                 </a:solidFill>
-                <a:latin typeface="Arial" pitchFamily="34" charset="0"/>
-                <a:ea typeface="Arial" pitchFamily="34" charset="-122"/>
-                <a:cs typeface="Arial" pitchFamily="34" charset="-120"/>
-              </a:rPr>
-              <a:t>◄</a:t>
+                <a:latin typeface="Calibri" pitchFamily="34" charset="0"/>
+                <a:ea typeface="Calibri" pitchFamily="34" charset="-122"/>
+                <a:cs typeface="Calibri" pitchFamily="34" charset="-120"/>
+              </a:rPr>
+              <a:t>►</a:t>
             </a:r>
             <a:endParaRPr lang="en-US" sz="2400" dirty="0"/>
           </a:p>
@@ -2853,7 +2892,7 @@
         </p:nvSpPr>
         <p:spPr>
           <a:xfrm>
-            <a:off x="4023360" y="2194560"/>
+            <a:off x="8001000" y="2240280"/>
             <a:ext cx="457200" cy="548640"/>
           </a:xfrm>
           <a:prstGeom prst="rect">
@@ -2874,11 +2913,11 @@
                 <a:solidFill>
                   <a:srgbClr val="64748B"/>
                 </a:solidFill>
-                <a:latin typeface="Arial" pitchFamily="34" charset="0"/>
-                <a:ea typeface="Arial" pitchFamily="34" charset="-122"/>
-                <a:cs typeface="Arial" pitchFamily="34" charset="-120"/>
-              </a:rPr>
-              <a:t>◄</a:t>
+                <a:latin typeface="Calibri" pitchFamily="34" charset="0"/>
+                <a:ea typeface="Calibri" pitchFamily="34" charset="-122"/>
+                <a:cs typeface="Calibri" pitchFamily="34" charset="-120"/>
+              </a:rPr>
+              <a:t>►</a:t>
             </a:r>
             <a:endParaRPr lang="en-US" sz="2400" dirty="0"/>
           </a:p>
@@ -2892,8 +2931,8 @@
         </p:nvSpPr>
         <p:spPr>
           <a:xfrm>
-            <a:off x="548640" y="3931920"/>
-            <a:ext cx="11064240" cy="1280160"/>
+            <a:off x="548640" y="3977640"/>
+            <a:ext cx="11064240" cy="1188720"/>
           </a:xfrm>
           <a:prstGeom prst="rect">
             <a:avLst/>
@@ -2905,7 +2944,7 @@
           <a:bodyPr wrap="square" rtlCol="0" anchor="t"/>
           <a:lstStyle/>
           <a:p>
-            <a:pPr algn="r" indent="0" marL="0">
+            <a:pPr algn="l" indent="0" marL="0">
               <a:spcAft>
                 <a:spcPts val="600"/>
               </a:spcAft>
@@ -2916,16 +2955,16 @@
                 <a:solidFill>
                   <a:srgbClr val="E2E8F0"/>
                 </a:solidFill>
-                <a:latin typeface="Arial" pitchFamily="34" charset="0"/>
-                <a:ea typeface="Arial" pitchFamily="34" charset="-122"/>
-                <a:cs typeface="Arial" pitchFamily="34" charset="-120"/>
-              </a:rPr>
-              <a:t>שני שרתים · שני מסדי נתונים · שלושה ערוצי מיקום: סלולר · LoRa 433MHz (Meshtastic) · לוויין MAGNUS (Iridium — עדיפות ל-MAGNUS)</a:t>
+                <a:latin typeface="Calibri" pitchFamily="34" charset="0"/>
+                <a:ea typeface="Calibri" pitchFamily="34" charset="-122"/>
+                <a:cs typeface="Calibri" pitchFamily="34" charset="-120"/>
+              </a:rPr>
+              <a:t>Two servers · two databases · three location channels: cellular · LoRa 433MHz (Meshtastic) · MAGNUS satellite (Iridium — preferred when both exist)</a:t>
             </a:r>
             <a:endParaRPr lang="en-US" sz="1400" dirty="0"/>
           </a:p>
           <a:p>
-            <a:pPr algn="r" indent="0" marL="0">
+            <a:pPr algn="l" indent="0" marL="0">
               <a:buNone/>
             </a:pPr>
             <a:r>
@@ -2933,11 +2972,11 @@
                 <a:solidFill>
                   <a:srgbClr val="94A3B8"/>
                 </a:solidFill>
-                <a:latin typeface="Arial" pitchFamily="34" charset="0"/>
-                <a:ea typeface="Arial" pitchFamily="34" charset="-122"/>
-                <a:cs typeface="Arial" pitchFamily="34" charset="-120"/>
-              </a:rPr>
-              <a:t>העדפת ערוצים בחירום: תמיד קודם 101 ו-«איפה דפי?» — דפי-נט משלימה ולא מחליפה.</a:t>
+                <a:latin typeface="Calibri" pitchFamily="34" charset="0"/>
+                <a:ea typeface="Calibri" pitchFamily="34" charset="-122"/>
+                <a:cs typeface="Calibri" pitchFamily="34" charset="-120"/>
+              </a:rPr>
+              <a:t>Official channels first: 101 and "Where is Defi" — DefiNet complements them, never replaces them.</a:t>
             </a:r>
             <a:endParaRPr lang="en-US" sz="1400" dirty="0"/>
           </a:p>
@@ -2964,7 +3003,7 @@
           <a:bodyPr wrap="square" rtlCol="0" anchor="ctr"/>
           <a:lstStyle/>
           <a:p>
-            <a:pPr rtl="1" algn="r" indent="0" marL="0">
+            <a:pPr algn="l" indent="0" marL="0">
               <a:buNone/>
             </a:pPr>
             <a:r>
@@ -2972,11 +3011,11 @@
                 <a:solidFill>
                   <a:srgbClr val="059669"/>
                 </a:solidFill>
-                <a:latin typeface="Arial" pitchFamily="34" charset="0"/>
-                <a:ea typeface="Arial" pitchFamily="34" charset="-122"/>
-                <a:cs typeface="Arial" pitchFamily="34" charset="-120"/>
-              </a:rPr>
-              <a:t>בונוס (5 נק׳): מסך הדרכת החייאה עם מטרונום 110BPM · דשבורד אנליטיקת זמני תגובה</a:t>
+                <a:latin typeface="Calibri" pitchFamily="34" charset="0"/>
+                <a:ea typeface="Calibri" pitchFamily="34" charset="-122"/>
+                <a:cs typeface="Calibri" pitchFamily="34" charset="-120"/>
+              </a:rPr>
+              <a:t>Bonus (5 pts): CPR guidance screen with a 110 BPM metronome · response-time analytics dashboard</a:t>
             </a:r>
             <a:endParaRPr lang="en-US" sz="1300" dirty="0"/>
           </a:p>
@@ -2990,7 +3029,7 @@
         </p:nvSpPr>
         <p:spPr>
           <a:xfrm>
-            <a:off x="365760" y="6419088"/>
+            <a:off x="8138160" y="6419088"/>
             <a:ext cx="3657600" cy="320040"/>
           </a:xfrm>
           <a:prstGeom prst="rect">
@@ -3003,7 +3042,7 @@
           <a:bodyPr wrap="square" lIns="0" tIns="0" rIns="0" bIns="0" rtlCol="0" anchor="ctr"/>
           <a:lstStyle/>
           <a:p>
-            <a:pPr rtl="1" algn="l" indent="0" marL="0">
+            <a:pPr algn="r" indent="0" marL="0">
               <a:buNone/>
             </a:pPr>
             <a:r>
@@ -3011,11 +3050,11 @@
                 <a:solidFill>
                   <a:srgbClr val="64748B"/>
                 </a:solidFill>
-                <a:latin typeface="Arial" pitchFamily="34" charset="0"/>
-                <a:ea typeface="Arial" pitchFamily="34" charset="-122"/>
-                <a:cs typeface="Arial" pitchFamily="34" charset="-120"/>
-              </a:rPr>
-              <a:t>דפי-נט · שקף 3</a:t>
+                <a:latin typeface="Calibri" pitchFamily="34" charset="0"/>
+                <a:ea typeface="Calibri" pitchFamily="34" charset="-122"/>
+                <a:cs typeface="Calibri" pitchFamily="34" charset="-120"/>
+              </a:rPr>
+              <a:t>DefiNet · slide 3</a:t>
             </a:r>
             <a:endParaRPr lang="en-US" sz="900" dirty="0"/>
           </a:p>
@@ -3074,7 +3113,7 @@
           <a:bodyPr wrap="square" rtlCol="0" anchor="ctr"/>
           <a:lstStyle/>
           <a:p>
-            <a:pPr rtl="1" algn="r" indent="0" marL="0">
+            <a:pPr algn="l" indent="0" marL="0">
               <a:buNone/>
             </a:pPr>
             <a:r>
@@ -3086,7 +3125,7 @@
                 <a:ea typeface="Arial" pitchFamily="34" charset="-122"/>
                 <a:cs typeface="Arial" pitchFamily="34" charset="-120"/>
               </a:rPr>
-              <a:t>דוגמה: מנוע האירועים (Geo-fencing + דירוג)</a:t>
+              <a:t>Code sample: the incident engine (geo-fencing + ranking)</a:t>
             </a:r>
             <a:endParaRPr lang="en-US" sz="2800" dirty="0"/>
           </a:p>
@@ -3113,7 +3152,7 @@
           <a:bodyPr wrap="square" rtlCol="0" anchor="ctr"/>
           <a:lstStyle/>
           <a:p>
-            <a:pPr rtl="1" algn="r" indent="0" marL="0">
+            <a:pPr algn="l" indent="0" marL="0">
               <a:buNone/>
             </a:pPr>
             <a:r>
@@ -3121,11 +3160,11 @@
                 <a:solidFill>
                   <a:srgbClr val="64748B"/>
                 </a:solidFill>
-                <a:latin typeface="Arial" pitchFamily="34" charset="0"/>
-                <a:ea typeface="Arial" pitchFamily="34" charset="-122"/>
-                <a:cs typeface="Arial" pitchFamily="34" charset="-120"/>
-              </a:rPr>
-              <a:t>server/src/routes/incidents.js — מה שקורה בכל קריאת מצוקה</a:t>
+                <a:latin typeface="Calibri" pitchFamily="34" charset="0"/>
+                <a:ea typeface="Calibri" pitchFamily="34" charset="-122"/>
+                <a:cs typeface="Calibri" pitchFamily="34" charset="-120"/>
+              </a:rPr>
+              <a:t>server/src/routes/incidents.js — what happens on every distress call</a:t>
             </a:r>
             <a:endParaRPr lang="en-US" sz="1400" dirty="0"/>
           </a:p>
@@ -3140,11 +3179,11 @@
         <p:spPr>
           <a:xfrm>
             <a:off x="457200" y="1508760"/>
-            <a:ext cx="11247120" cy="3063240"/>
+            <a:ext cx="11247120" cy="2999232"/>
           </a:xfrm>
           <a:prstGeom prst="roundRect">
             <a:avLst>
-              <a:gd name="adj" fmla="val 2388"/>
+              <a:gd name="adj" fmla="val 2439"/>
             </a:avLst>
           </a:prstGeom>
           <a:solidFill>
@@ -3161,8 +3200,8 @@
         </p:nvSpPr>
         <p:spPr>
           <a:xfrm>
-            <a:off x="685800" y="1645920"/>
-            <a:ext cx="10789920" cy="2834640"/>
+            <a:off x="685800" y="1627632"/>
+            <a:ext cx="10789920" cy="2816352"/>
           </a:xfrm>
           <a:prstGeom prst="rect">
             <a:avLst/>
@@ -3181,7 +3220,7 @@
               <a:buNone/>
             </a:pPr>
             <a:r>
-              <a:rPr lang="en-US" sz="1350" dirty="0">
+              <a:rPr lang="en-US" sz="1300" dirty="0">
                 <a:solidFill>
                   <a:srgbClr val="6EE7B7"/>
                 </a:solidFill>
@@ -3189,9 +3228,9 @@
                 <a:ea typeface="Courier New" pitchFamily="34" charset="-122"/>
                 <a:cs typeface="Courier New" pitchFamily="34" charset="-120"/>
               </a:rPr>
-              <a:t>// 1. פיזור אקראי של כל 50 המכשירים סביב האירוע (דרישה 9)</a:t>
-            </a:r>
-            <a:endParaRPr lang="en-US" sz="1350" dirty="0"/>
+              <a:t>// 1. Random scatter of all 50 devices around the incident (requirement 9)</a:t>
+            </a:r>
+            <a:endParaRPr lang="en-US" sz="1300" dirty="0"/>
           </a:p>
           <a:p>
             <a:pPr algn="l" indent="0" marL="0">
@@ -3201,7 +3240,7 @@
               <a:buNone/>
             </a:pPr>
             <a:r>
-              <a:rPr lang="en-US" sz="1350" dirty="0">
+              <a:rPr lang="en-US" sz="1300" dirty="0">
                 <a:solidFill>
                   <a:srgbClr val="6EE7B7"/>
                 </a:solidFill>
@@ -3211,7 +3250,7 @@
               </a:rPr>
               <a:t>const scattered = rows.map((row) =&gt; {</a:t>
             </a:r>
-            <a:endParaRPr lang="en-US" sz="1350" dirty="0"/>
+            <a:endParaRPr lang="en-US" sz="1300" dirty="0"/>
           </a:p>
           <a:p>
             <a:pPr algn="l" indent="0" marL="0">
@@ -3221,7 +3260,7 @@
               <a:buNone/>
             </a:pPr>
             <a:r>
-              <a:rPr lang="en-US" sz="1350" dirty="0">
+              <a:rPr lang="en-US" sz="1300" dirty="0">
                 <a:solidFill>
                   <a:srgbClr val="6EE7B7"/>
                 </a:solidFill>
@@ -3231,7 +3270,7 @@
               </a:rPr>
               <a:t>  const pos = scatterAround(lat, lng, radiusM * cfg.scatterFactor);</a:t>
             </a:r>
-            <a:endParaRPr lang="en-US" sz="1350" dirty="0"/>
+            <a:endParaRPr lang="en-US" sz="1300" dirty="0"/>
           </a:p>
           <a:p>
             <a:pPr algn="l" indent="0" marL="0">
@@ -3241,7 +3280,7 @@
               <a:buNone/>
             </a:pPr>
             <a:r>
-              <a:rPr lang="en-US" sz="1350" dirty="0">
+              <a:rPr lang="en-US" sz="1300" dirty="0">
                 <a:solidFill>
                   <a:srgbClr val="6EE7B7"/>
                 </a:solidFill>
@@ -3251,7 +3290,7 @@
               </a:rPr>
               <a:t>  const distanceM = haversineM(lat, lng, pos.lat, pos.lng);</a:t>
             </a:r>
-            <a:endParaRPr lang="en-US" sz="1350" dirty="0"/>
+            <a:endParaRPr lang="en-US" sz="1300" dirty="0"/>
           </a:p>
           <a:p>
             <a:pPr algn="l" indent="0" marL="0">
@@ -3261,7 +3300,7 @@
               <a:buNone/>
             </a:pPr>
             <a:r>
-              <a:rPr lang="en-US" sz="1350" dirty="0">
+              <a:rPr lang="en-US" sz="1300" dirty="0">
                 <a:solidFill>
                   <a:srgbClr val="6EE7B7"/>
                 </a:solidFill>
@@ -3271,7 +3310,7 @@
               </a:rPr>
               <a:t>  return { row, pos, distanceM, inRadius: distanceM &lt;= radiusM };</a:t>
             </a:r>
-            <a:endParaRPr lang="en-US" sz="1350" dirty="0"/>
+            <a:endParaRPr lang="en-US" sz="1300" dirty="0"/>
           </a:p>
           <a:p>
             <a:pPr algn="l" indent="0" marL="0">
@@ -3281,7 +3320,7 @@
               <a:buNone/>
             </a:pPr>
             <a:r>
-              <a:rPr lang="en-US" sz="1350" dirty="0">
+              <a:rPr lang="en-US" sz="1300" dirty="0">
                 <a:solidFill>
                   <a:srgbClr val="6EE7B7"/>
                 </a:solidFill>
@@ -3291,7 +3330,7 @@
               </a:rPr>
               <a:t>});</a:t>
             </a:r>
-            <a:endParaRPr lang="en-US" sz="1350" dirty="0"/>
+            <a:endParaRPr lang="en-US" sz="1300" dirty="0"/>
           </a:p>
           <a:p>
             <a:pPr algn="l" indent="0" marL="0">
@@ -3301,7 +3340,7 @@
               <a:buNone/>
             </a:pPr>
             <a:r>
-              <a:rPr lang="en-US" sz="1350" dirty="0">
+              <a:rPr lang="en-US" sz="1300" dirty="0">
                 <a:solidFill>
                   <a:srgbClr val="6EE7B7"/>
                 </a:solidFill>
@@ -3309,9 +3348,9 @@
                 <a:ea typeface="Courier New" pitchFamily="34" charset="-122"/>
                 <a:cs typeface="Courier New" pitchFamily="34" charset="-120"/>
               </a:rPr>
-              <a:t>// 2. דירוג: בתוך הרדיוס תחילה, שידור טרי לפני ישן, ואז המרחק</a:t>
-            </a:r>
-            <a:endParaRPr lang="en-US" sz="1350" dirty="0"/>
+              <a:t>// 2. Ranking: in-radius first, fresh transmission before stale, then distance</a:t>
+            </a:r>
+            <a:endParaRPr lang="en-US" sz="1300" dirty="0"/>
           </a:p>
           <a:p>
             <a:pPr algn="l" indent="0" marL="0">
@@ -3321,7 +3360,7 @@
               <a:buNone/>
             </a:pPr>
             <a:r>
-              <a:rPr lang="en-US" sz="1350" dirty="0">
+              <a:rPr lang="en-US" sz="1300" dirty="0">
                 <a:solidFill>
                   <a:srgbClr val="6EE7B7"/>
                 </a:solidFill>
@@ -3331,7 +3370,7 @@
               </a:rPr>
               <a:t>sorted.sort((a, b) =&gt; {</a:t>
             </a:r>
-            <a:endParaRPr lang="en-US" sz="1350" dirty="0"/>
+            <a:endParaRPr lang="en-US" sz="1300" dirty="0"/>
           </a:p>
           <a:p>
             <a:pPr algn="l" indent="0" marL="0">
@@ -3341,7 +3380,7 @@
               <a:buNone/>
             </a:pPr>
             <a:r>
-              <a:rPr lang="en-US" sz="1350" dirty="0">
+              <a:rPr lang="en-US" sz="1300" dirty="0">
                 <a:solidFill>
                   <a:srgbClr val="6EE7B7"/>
                 </a:solidFill>
@@ -3351,7 +3390,7 @@
               </a:rPr>
               <a:t>  if (a.inRadius !== b.inRadius) return a.inRadius ? -1 : 1;</a:t>
             </a:r>
-            <a:endParaRPr lang="en-US" sz="1350" dirty="0"/>
+            <a:endParaRPr lang="en-US" sz="1300" dirty="0"/>
           </a:p>
           <a:p>
             <a:pPr algn="l" indent="0" marL="0">
@@ -3361,7 +3400,7 @@
               <a:buNone/>
             </a:pPr>
             <a:r>
-              <a:rPr lang="en-US" sz="1350" dirty="0">
+              <a:rPr lang="en-US" sz="1300" dirty="0">
                 <a:solidFill>
                   <a:srgbClr val="6EE7B7"/>
                 </a:solidFill>
@@ -3371,7 +3410,7 @@
               </a:rPr>
               <a:t>  if (a.fresh   !== b.fresh)     return a.fresh   ? -1 : 1;</a:t>
             </a:r>
-            <a:endParaRPr lang="en-US" sz="1350" dirty="0"/>
+            <a:endParaRPr lang="en-US" sz="1300" dirty="0"/>
           </a:p>
           <a:p>
             <a:pPr algn="l" indent="0" marL="0">
@@ -3381,7 +3420,7 @@
               <a:buNone/>
             </a:pPr>
             <a:r>
-              <a:rPr lang="en-US" sz="1350" dirty="0">
+              <a:rPr lang="en-US" sz="1300" dirty="0">
                 <a:solidFill>
                   <a:srgbClr val="6EE7B7"/>
                 </a:solidFill>
@@ -3391,7 +3430,7 @@
               </a:rPr>
               <a:t>  return a.distanceM - b.distanceM;</a:t>
             </a:r>
-            <a:endParaRPr lang="en-US" sz="1350" dirty="0"/>
+            <a:endParaRPr lang="en-US" sz="1300" dirty="0"/>
           </a:p>
           <a:p>
             <a:pPr algn="l" indent="0" marL="0">
@@ -3401,7 +3440,7 @@
               <a:buNone/>
             </a:pPr>
             <a:r>
-              <a:rPr lang="en-US" sz="1350" dirty="0">
+              <a:rPr lang="en-US" sz="1300" dirty="0">
                 <a:solidFill>
                   <a:srgbClr val="6EE7B7"/>
                 </a:solidFill>
@@ -3411,7 +3450,7 @@
               </a:rPr>
               <a:t>});</a:t>
             </a:r>
-            <a:endParaRPr lang="en-US" sz="1350" dirty="0"/>
+            <a:endParaRPr lang="en-US" sz="1300" dirty="0"/>
           </a:p>
         </p:txBody>
       </p:sp>
@@ -3423,8 +3462,8 @@
         </p:nvSpPr>
         <p:spPr>
           <a:xfrm>
-            <a:off x="457200" y="4754880"/>
-            <a:ext cx="11247120" cy="1280160"/>
+            <a:off x="457200" y="4736592"/>
+            <a:ext cx="11247120" cy="1463040"/>
           </a:xfrm>
           <a:prstGeom prst="rect">
             <a:avLst/>
@@ -3436,72 +3475,72 @@
           <a:bodyPr wrap="square" rtlCol="0" anchor="t"/>
           <a:lstStyle/>
           <a:p>
+            <a:pPr algn="l" indent="0" marL="0">
+              <a:buNone/>
+            </a:pPr>
+            <a:r>
+              <a:rPr lang="en-US" sz="1400" b="1" dirty="0">
+                <a:solidFill>
+                  <a:srgbClr val="0F172A"/>
+                </a:solidFill>
+                <a:latin typeface="Calibri" pitchFamily="34" charset="0"/>
+                <a:ea typeface="Calibri" pitchFamily="34" charset="-122"/>
+                <a:cs typeface="Calibri" pitchFamily="34" charset="-120"/>
+              </a:rPr>
+              <a:t>Defense points:  </a:t>
+            </a:r>
+            <a:pPr algn="l" indent="0" marL="0">
+              <a:buNone/>
+            </a:pPr>
+            <a:r>
+              <a:rPr lang="en-US" sz="1400" dirty="0">
+                <a:solidFill>
+                  <a:srgbClr val="334155"/>
+                </a:solidFill>
+                <a:latin typeface="Calibri" pitchFamily="34" charset="0"/>
+                <a:ea typeface="Calibri" pitchFamily="34" charset="-122"/>
+                <a:cs typeface="Calibri" pitchFamily="34" charset="-120"/>
+              </a:rPr>
+              <a:t>the haversine formula and meters→degrees conversion · uniform disk sampling (r = R·√U) · a stable three-key sort · only in-radius candidates receive a rank and a dispatch.</a:t>
+            </a:r>
+            <a:endParaRPr lang="en-US" sz="1400" dirty="0"/>
+          </a:p>
+        </p:txBody>
+      </p:sp>
+      <p:sp>
+        <p:nvSpPr>
+          <p:cNvPr id="7" name="Text 5"/>
+          <p:cNvSpPr/>
+          <p:nvPr/>
+        </p:nvSpPr>
+        <p:spPr>
+          <a:xfrm>
+            <a:off x="8138160" y="6419088"/>
+            <a:ext cx="3657600" cy="320040"/>
+          </a:xfrm>
+          <a:prstGeom prst="rect">
+            <a:avLst/>
+          </a:prstGeom>
+          <a:noFill/>
+          <a:ln/>
+        </p:spPr>
+        <p:txBody>
+          <a:bodyPr wrap="square" lIns="0" tIns="0" rIns="0" bIns="0" rtlCol="0" anchor="ctr"/>
+          <a:lstStyle/>
+          <a:p>
             <a:pPr algn="r" indent="0" marL="0">
               <a:buNone/>
             </a:pPr>
             <a:r>
-              <a:rPr lang="en-US" sz="1400" b="1" dirty="0">
-                <a:solidFill>
-                  <a:srgbClr val="0F172A"/>
-                </a:solidFill>
-                <a:latin typeface="Arial" pitchFamily="34" charset="0"/>
-                <a:ea typeface="Arial" pitchFamily="34" charset="-122"/>
-                <a:cs typeface="Arial" pitchFamily="34" charset="-120"/>
-              </a:rPr>
-              <a:t>נקודות להגנה: </a:t>
-            </a:r>
-            <a:pPr algn="r" indent="0" marL="0">
-              <a:buNone/>
-            </a:pPr>
-            <a:r>
-              <a:rPr lang="en-US" sz="1400" dirty="0">
-                <a:solidFill>
-                  <a:srgbClr val="334155"/>
-                </a:solidFill>
-                <a:latin typeface="Arial" pitchFamily="34" charset="0"/>
-                <a:ea typeface="Arial" pitchFamily="34" charset="-122"/>
-                <a:cs typeface="Arial" pitchFamily="34" charset="-120"/>
-              </a:rPr>
-              <a:t>נוסחת haversine ומעבר מטרים→מעלות · פיזור אחיד בדיסק (r = R·√U) · מיון יציב בשלושה מפתחות · רק מועמדים בתוך הרדיוס מקבלים דירוג והזנקה.</a:t>
-            </a:r>
-            <a:endParaRPr lang="en-US" sz="1400" dirty="0"/>
-          </a:p>
-        </p:txBody>
-      </p:sp>
-      <p:sp>
-        <p:nvSpPr>
-          <p:cNvPr id="7" name="Text 5"/>
-          <p:cNvSpPr/>
-          <p:nvPr/>
-        </p:nvSpPr>
-        <p:spPr>
-          <a:xfrm>
-            <a:off x="365760" y="6419088"/>
-            <a:ext cx="3657600" cy="320040"/>
-          </a:xfrm>
-          <a:prstGeom prst="rect">
-            <a:avLst/>
-          </a:prstGeom>
-          <a:noFill/>
-          <a:ln/>
-        </p:spPr>
-        <p:txBody>
-          <a:bodyPr wrap="square" lIns="0" tIns="0" rIns="0" bIns="0" rtlCol="0" anchor="ctr"/>
-          <a:lstStyle/>
-          <a:p>
-            <a:pPr rtl="1" algn="l" indent="0" marL="0">
-              <a:buNone/>
-            </a:pPr>
-            <a:r>
               <a:rPr lang="en-US" sz="900" dirty="0">
                 <a:solidFill>
                   <a:srgbClr val="64748B"/>
                 </a:solidFill>
-                <a:latin typeface="Arial" pitchFamily="34" charset="0"/>
-                <a:ea typeface="Arial" pitchFamily="34" charset="-122"/>
-                <a:cs typeface="Arial" pitchFamily="34" charset="-120"/>
-              </a:rPr>
-              <a:t>דפי-נט · שקף 4</a:t>
+                <a:latin typeface="Calibri" pitchFamily="34" charset="0"/>
+                <a:ea typeface="Calibri" pitchFamily="34" charset="-122"/>
+                <a:cs typeface="Calibri" pitchFamily="34" charset="-120"/>
+              </a:rPr>
+              <a:t>DefiNet · slide 4</a:t>
             </a:r>
             <a:endParaRPr lang="en-US" sz="900" dirty="0"/>
           </a:p>
@@ -3560,7 +3599,7 @@
           <a:bodyPr wrap="square" rtlCol="0" anchor="ctr"/>
           <a:lstStyle/>
           <a:p>
-            <a:pPr rtl="1" algn="r" indent="0" marL="0">
+            <a:pPr algn="l" indent="0" marL="0">
               <a:buNone/>
             </a:pPr>
             <a:r>
@@ -3572,7 +3611,7 @@
                 <a:ea typeface="Arial" pitchFamily="34" charset="-122"/>
                 <a:cs typeface="Arial" pitchFamily="34" charset="-120"/>
               </a:rPr>
-              <a:t>דוגמה: JWT עם Refresh Rotation</a:t>
+              <a:t>Code sample: JWT with refresh rotation</a:t>
             </a:r>
             <a:endParaRPr lang="en-US" sz="2800" dirty="0"/>
           </a:p>
@@ -3599,7 +3638,7 @@
           <a:bodyPr wrap="square" rtlCol="0" anchor="ctr"/>
           <a:lstStyle/>
           <a:p>
-            <a:pPr rtl="1" algn="r" indent="0" marL="0">
+            <a:pPr algn="l" indent="0" marL="0">
               <a:buNone/>
             </a:pPr>
             <a:r>
@@ -3607,11 +3646,11 @@
                 <a:solidFill>
                   <a:srgbClr val="64748B"/>
                 </a:solidFill>
-                <a:latin typeface="Arial" pitchFamily="34" charset="0"/>
-                <a:ea typeface="Arial" pitchFamily="34" charset="-122"/>
-                <a:cs typeface="Arial" pitchFamily="34" charset="-120"/>
-              </a:rPr>
-              <a:t>server/src/routes/auth.js — כל טוקן רענון הוא חד-פעמי</a:t>
+                <a:latin typeface="Calibri" pitchFamily="34" charset="0"/>
+                <a:ea typeface="Calibri" pitchFamily="34" charset="-122"/>
+                <a:cs typeface="Calibri" pitchFamily="34" charset="-120"/>
+              </a:rPr>
+              <a:t>server/src/routes/auth.js — every refresh token is single-use</a:t>
             </a:r>
             <a:endParaRPr lang="en-US" sz="1400" dirty="0"/>
           </a:p>
@@ -3626,11 +3665,11 @@
         <p:spPr>
           <a:xfrm>
             <a:off x="457200" y="1508760"/>
-            <a:ext cx="11247120" cy="2743200"/>
+            <a:ext cx="11247120" cy="2551176"/>
           </a:xfrm>
           <a:prstGeom prst="roundRect">
             <a:avLst>
-              <a:gd name="adj" fmla="val 2667"/>
+              <a:gd name="adj" fmla="val 2867"/>
             </a:avLst>
           </a:prstGeom>
           <a:solidFill>
@@ -3647,8 +3686,8 @@
         </p:nvSpPr>
         <p:spPr>
           <a:xfrm>
-            <a:off x="685800" y="1645920"/>
-            <a:ext cx="10789920" cy="2514600"/>
+            <a:off x="685800" y="1627632"/>
+            <a:ext cx="10789920" cy="2368296"/>
           </a:xfrm>
           <a:prstGeom prst="rect">
             <a:avLst/>
@@ -3667,7 +3706,7 @@
               <a:buNone/>
             </a:pPr>
             <a:r>
-              <a:rPr lang="en-US" sz="1350" dirty="0">
+              <a:rPr lang="en-US" sz="1300" dirty="0">
                 <a:solidFill>
                   <a:srgbClr val="6EE7B7"/>
                 </a:solidFill>
@@ -3677,7 +3716,7 @@
               </a:rPr>
               <a:t>router.post('/refresh', (req, res) =&gt; {</a:t>
             </a:r>
-            <a:endParaRPr lang="en-US" sz="1350" dirty="0"/>
+            <a:endParaRPr lang="en-US" sz="1300" dirty="0"/>
           </a:p>
           <a:p>
             <a:pPr algn="l" indent="0" marL="0">
@@ -3687,7 +3726,7 @@
               <a:buNone/>
             </a:pPr>
             <a:r>
-              <a:rPr lang="en-US" sz="1350" dirty="0">
+              <a:rPr lang="en-US" sz="1300" dirty="0">
                 <a:solidFill>
                   <a:srgbClr val="6EE7B7"/>
                 </a:solidFill>
@@ -3695,9 +3734,9 @@
                 <a:ea typeface="Courier New" pitchFamily="34" charset="-122"/>
                 <a:cs typeface="Courier New" pitchFamily="34" charset="-120"/>
               </a:rPr>
-              <a:t>  const session = verifyRefreshCookie(req);   // JWT + jti חי ב-DB</a:t>
-            </a:r>
-            <a:endParaRPr lang="en-US" sz="1350" dirty="0"/>
+              <a:t>  const session = verifyRefreshCookie(req);   // JWT + live jti row in the DB</a:t>
+            </a:r>
+            <a:endParaRPr lang="en-US" sz="1300" dirty="0"/>
           </a:p>
           <a:p>
             <a:pPr algn="l" indent="0" marL="0">
@@ -3707,7 +3746,7 @@
               <a:buNone/>
             </a:pPr>
             <a:r>
-              <a:rPr lang="en-US" sz="1350" dirty="0">
+              <a:rPr lang="en-US" sz="1300" dirty="0">
                 <a:solidFill>
                   <a:srgbClr val="6EE7B7"/>
                 </a:solidFill>
@@ -3717,7 +3756,7 @@
               </a:rPr>
               <a:t>  if (!session) return res.status(401).json({ error: 'unauthorized' });</a:t>
             </a:r>
-            <a:endParaRPr lang="en-US" sz="1350" dirty="0"/>
+            <a:endParaRPr lang="en-US" sz="1300" dirty="0"/>
           </a:p>
           <a:p>
             <a:pPr algn="l" indent="0" marL="0">
@@ -3727,7 +3766,7 @@
               <a:buNone/>
             </a:pPr>
             <a:r>
-              <a:rPr lang="en-US" sz="1350" dirty="0">
+              <a:rPr lang="en-US" sz="1300" dirty="0">
                 <a:solidFill>
                   <a:srgbClr val="6EE7B7"/>
                 </a:solidFill>
@@ -3737,7 +3776,7 @@
               </a:rPr>
               <a:t>  db.transaction(() =&gt; {</a:t>
             </a:r>
-            <a:endParaRPr lang="en-US" sz="1350" dirty="0"/>
+            <a:endParaRPr lang="en-US" sz="1300" dirty="0"/>
           </a:p>
           <a:p>
             <a:pPr algn="l" indent="0" marL="0">
@@ -3747,7 +3786,7 @@
               <a:buNone/>
             </a:pPr>
             <a:r>
-              <a:rPr lang="en-US" sz="1350" dirty="0">
+              <a:rPr lang="en-US" sz="1300" dirty="0">
                 <a:solidFill>
                   <a:srgbClr val="6EE7B7"/>
                 </a:solidFill>
@@ -3757,7 +3796,7 @@
               </a:rPr>
               <a:t>    db.prepare('UPDATE refresh_tokens SET revoked=1 WHERE jti=?')</a:t>
             </a:r>
-            <a:endParaRPr lang="en-US" sz="1350" dirty="0"/>
+            <a:endParaRPr lang="en-US" sz="1300" dirty="0"/>
           </a:p>
           <a:p>
             <a:pPr algn="l" indent="0" marL="0">
@@ -3767,7 +3806,7 @@
               <a:buNone/>
             </a:pPr>
             <a:r>
-              <a:rPr lang="en-US" sz="1350" dirty="0">
+              <a:rPr lang="en-US" sz="1300" dirty="0">
                 <a:solidFill>
                   <a:srgbClr val="6EE7B7"/>
                 </a:solidFill>
@@ -3775,9 +3814,9 @@
                 <a:ea typeface="Courier New" pitchFamily="34" charset="-122"/>
                 <a:cs typeface="Courier New" pitchFamily="34" charset="-120"/>
               </a:rPr>
-              <a:t>      .run(session.jti);                       // מבטלים את הישן</a:t>
-            </a:r>
-            <a:endParaRPr lang="en-US" sz="1350" dirty="0"/>
+              <a:t>      .run(session.jti);                       // revoke the old token</a:t>
+            </a:r>
+            <a:endParaRPr lang="en-US" sz="1300" dirty="0"/>
           </a:p>
           <a:p>
             <a:pPr algn="l" indent="0" marL="0">
@@ -3787,7 +3826,7 @@
               <a:buNone/>
             </a:pPr>
             <a:r>
-              <a:rPr lang="en-US" sz="1350" dirty="0">
+              <a:rPr lang="en-US" sz="1300" dirty="0">
                 <a:solidFill>
                   <a:srgbClr val="6EE7B7"/>
                 </a:solidFill>
@@ -3795,9 +3834,9 @@
                 <a:ea typeface="Courier New" pitchFamily="34" charset="-122"/>
                 <a:cs typeface="Courier New" pitchFamily="34" charset="-120"/>
               </a:rPr>
-              <a:t>    issueRefreshToken(res, session.username);  // jti חדש + עוגייה</a:t>
-            </a:r>
-            <a:endParaRPr lang="en-US" sz="1350" dirty="0"/>
+              <a:t>    issueRefreshToken(res, session.username);  // new jti + new cookie</a:t>
+            </a:r>
+            <a:endParaRPr lang="en-US" sz="1300" dirty="0"/>
           </a:p>
           <a:p>
             <a:pPr algn="l" indent="0" marL="0">
@@ -3807,7 +3846,7 @@
               <a:buNone/>
             </a:pPr>
             <a:r>
-              <a:rPr lang="en-US" sz="1350" dirty="0">
+              <a:rPr lang="en-US" sz="1300" dirty="0">
                 <a:solidFill>
                   <a:srgbClr val="6EE7B7"/>
                 </a:solidFill>
@@ -3817,7 +3856,7 @@
               </a:rPr>
               <a:t>  })();</a:t>
             </a:r>
-            <a:endParaRPr lang="en-US" sz="1350" dirty="0"/>
+            <a:endParaRPr lang="en-US" sz="1300" dirty="0"/>
           </a:p>
           <a:p>
             <a:pPr algn="l" indent="0" marL="0">
@@ -3827,7 +3866,7 @@
               <a:buNone/>
             </a:pPr>
             <a:r>
-              <a:rPr lang="en-US" sz="1350" dirty="0">
+              <a:rPr lang="en-US" sz="1300" dirty="0">
                 <a:solidFill>
                   <a:srgbClr val="6EE7B7"/>
                 </a:solidFill>
@@ -3837,7 +3876,7 @@
               </a:rPr>
               <a:t>  res.json({ accessToken: signAccessToken(session.username) });</a:t>
             </a:r>
-            <a:endParaRPr lang="en-US" sz="1350" dirty="0"/>
+            <a:endParaRPr lang="en-US" sz="1300" dirty="0"/>
           </a:p>
           <a:p>
             <a:pPr algn="l" indent="0" marL="0">
@@ -3847,7 +3886,7 @@
               <a:buNone/>
             </a:pPr>
             <a:r>
-              <a:rPr lang="en-US" sz="1350" dirty="0">
+              <a:rPr lang="en-US" sz="1300" dirty="0">
                 <a:solidFill>
                   <a:srgbClr val="6EE7B7"/>
                 </a:solidFill>
@@ -3857,7 +3896,7 @@
               </a:rPr>
               <a:t>});</a:t>
             </a:r>
-            <a:endParaRPr lang="en-US" sz="1350" dirty="0"/>
+            <a:endParaRPr lang="en-US" sz="1300" dirty="0"/>
           </a:p>
         </p:txBody>
       </p:sp>
@@ -3869,8 +3908,8 @@
         </p:nvSpPr>
         <p:spPr>
           <a:xfrm>
-            <a:off x="457200" y="4434840"/>
-            <a:ext cx="11247120" cy="1554480"/>
+            <a:off x="457200" y="4288536"/>
+            <a:ext cx="11247120" cy="1463040"/>
           </a:xfrm>
           <a:prstGeom prst="rect">
             <a:avLst/>
@@ -3882,72 +3921,72 @@
           <a:bodyPr wrap="square" rtlCol="0" anchor="t"/>
           <a:lstStyle/>
           <a:p>
+            <a:pPr algn="l" indent="0" marL="0">
+              <a:buNone/>
+            </a:pPr>
+            <a:r>
+              <a:rPr lang="en-US" sz="1400" b="1" dirty="0">
+                <a:solidFill>
+                  <a:srgbClr val="0F172A"/>
+                </a:solidFill>
+                <a:latin typeface="Calibri" pitchFamily="34" charset="0"/>
+                <a:ea typeface="Calibri" pitchFamily="34" charset="-122"/>
+                <a:cs typeface="Calibri" pitchFamily="34" charset="-120"/>
+              </a:rPr>
+              <a:t>Defense points:  </a:t>
+            </a:r>
+            <a:pPr algn="l" indent="0" marL="0">
+              <a:buNone/>
+            </a:pPr>
+            <a:r>
+              <a:rPr lang="en-US" sz="1400" dirty="0">
+                <a:solidFill>
+                  <a:srgbClr val="334155"/>
+                </a:solidFill>
+                <a:latin typeface="Calibri" pitchFamily="34" charset="0"/>
+                <a:ea typeface="Calibri" pitchFamily="34" charset="-122"/>
+                <a:cs typeface="Calibri" pitchFamily="34" charset="-120"/>
+              </a:rPr>
+              <a:t>short access token (15 min, in memory) vs long refresh token (7 days, httpOnly cookie) · rotation → a stolen cookie dies on first reuse · on the client, refreshAccessToken is single-flight so concurrent calls cannot kill the session.</a:t>
+            </a:r>
+            <a:endParaRPr lang="en-US" sz="1400" dirty="0"/>
+          </a:p>
+        </p:txBody>
+      </p:sp>
+      <p:sp>
+        <p:nvSpPr>
+          <p:cNvPr id="7" name="Text 5"/>
+          <p:cNvSpPr/>
+          <p:nvPr/>
+        </p:nvSpPr>
+        <p:spPr>
+          <a:xfrm>
+            <a:off x="8138160" y="6419088"/>
+            <a:ext cx="3657600" cy="320040"/>
+          </a:xfrm>
+          <a:prstGeom prst="rect">
+            <a:avLst/>
+          </a:prstGeom>
+          <a:noFill/>
+          <a:ln/>
+        </p:spPr>
+        <p:txBody>
+          <a:bodyPr wrap="square" lIns="0" tIns="0" rIns="0" bIns="0" rtlCol="0" anchor="ctr"/>
+          <a:lstStyle/>
+          <a:p>
             <a:pPr algn="r" indent="0" marL="0">
               <a:buNone/>
             </a:pPr>
             <a:r>
-              <a:rPr lang="en-US" sz="1400" b="1" dirty="0">
-                <a:solidFill>
-                  <a:srgbClr val="0F172A"/>
-                </a:solidFill>
-                <a:latin typeface="Arial" pitchFamily="34" charset="0"/>
-                <a:ea typeface="Arial" pitchFamily="34" charset="-122"/>
-                <a:cs typeface="Arial" pitchFamily="34" charset="-120"/>
-              </a:rPr>
-              <a:t>נקודות להגנה: </a:t>
-            </a:r>
-            <a:pPr algn="r" indent="0" marL="0">
-              <a:buNone/>
-            </a:pPr>
-            <a:r>
-              <a:rPr lang="en-US" sz="1400" dirty="0">
-                <a:solidFill>
-                  <a:srgbClr val="334155"/>
-                </a:solidFill>
-                <a:latin typeface="Arial" pitchFamily="34" charset="0"/>
-                <a:ea typeface="Arial" pitchFamily="34" charset="-122"/>
-                <a:cs typeface="Arial" pitchFamily="34" charset="-120"/>
-              </a:rPr>
-              <a:t>Access token קצר (15 דק׳, בזיכרון) מול Refresh ארוך (7 ימים, עוגיית httpOnly) · רוטציה → עוגייה גנובה מתה בשימוש חוזר · בצד הלקוח refreshAccessToken הוא single-flight כדי שקריאות מקבילות לא יפילו את הסשן.</a:t>
-            </a:r>
-            <a:endParaRPr lang="en-US" sz="1400" dirty="0"/>
-          </a:p>
-        </p:txBody>
-      </p:sp>
-      <p:sp>
-        <p:nvSpPr>
-          <p:cNvPr id="7" name="Text 5"/>
-          <p:cNvSpPr/>
-          <p:nvPr/>
-        </p:nvSpPr>
-        <p:spPr>
-          <a:xfrm>
-            <a:off x="365760" y="6419088"/>
-            <a:ext cx="3657600" cy="320040"/>
-          </a:xfrm>
-          <a:prstGeom prst="rect">
-            <a:avLst/>
-          </a:prstGeom>
-          <a:noFill/>
-          <a:ln/>
-        </p:spPr>
-        <p:txBody>
-          <a:bodyPr wrap="square" lIns="0" tIns="0" rIns="0" bIns="0" rtlCol="0" anchor="ctr"/>
-          <a:lstStyle/>
-          <a:p>
-            <a:pPr rtl="1" algn="l" indent="0" marL="0">
-              <a:buNone/>
-            </a:pPr>
-            <a:r>
               <a:rPr lang="en-US" sz="900" dirty="0">
                 <a:solidFill>
                   <a:srgbClr val="64748B"/>
                 </a:solidFill>
-                <a:latin typeface="Arial" pitchFamily="34" charset="0"/>
-                <a:ea typeface="Arial" pitchFamily="34" charset="-122"/>
-                <a:cs typeface="Arial" pitchFamily="34" charset="-120"/>
-              </a:rPr>
-              <a:t>דפי-נט · שקף 5</a:t>
+                <a:latin typeface="Calibri" pitchFamily="34" charset="0"/>
+                <a:ea typeface="Calibri" pitchFamily="34" charset="-122"/>
+                <a:cs typeface="Calibri" pitchFamily="34" charset="-120"/>
+              </a:rPr>
+              <a:t>DefiNet · slide 5</a:t>
             </a:r>
             <a:endParaRPr lang="en-US" sz="900" dirty="0"/>
           </a:p>
@@ -4006,11 +4045,11 @@
           <a:bodyPr wrap="square" rtlCol="0" anchor="ctr"/>
           <a:lstStyle/>
           <a:p>
-            <a:pPr rtl="1" algn="r" indent="0" marL="0">
-              <a:buNone/>
-            </a:pPr>
-            <a:r>
-              <a:rPr lang="en-US" sz="3000" b="1" dirty="0">
+            <a:pPr algn="l" indent="0" marL="0">
+              <a:buNone/>
+            </a:pPr>
+            <a:r>
+              <a:rPr lang="en-US" sz="2800" b="1" dirty="0">
                 <a:solidFill>
                   <a:srgbClr val="FFFFFF"/>
                 </a:solidFill>
@@ -4018,26 +4057,65 @@
                 <a:ea typeface="Arial" pitchFamily="34" charset="-122"/>
                 <a:cs typeface="Arial" pitchFamily="34" charset="-120"/>
               </a:rPr>
-              <a:t>הזנקה היברידית + הסימולטור</a:t>
-            </a:r>
-            <a:endParaRPr lang="en-US" sz="3000" dirty="0"/>
-          </a:p>
-        </p:txBody>
-      </p:sp>
-      <p:sp>
-        <p:nvSpPr>
-          <p:cNvPr id="3" name="Shape 1"/>
-          <p:cNvSpPr/>
-          <p:nvPr/>
-        </p:nvSpPr>
-        <p:spPr>
-          <a:xfrm>
-            <a:off x="457200" y="1280160"/>
-            <a:ext cx="11247120" cy="1463040"/>
+              <a:t>The hybrid alert + the simulator</a:t>
+            </a:r>
+            <a:endParaRPr lang="en-US" sz="2800" dirty="0"/>
+          </a:p>
+        </p:txBody>
+      </p:sp>
+      <p:sp>
+        <p:nvSpPr>
+          <p:cNvPr id="3" name="Text 1"/>
+          <p:cNvSpPr/>
+          <p:nvPr/>
+        </p:nvSpPr>
+        <p:spPr>
+          <a:xfrm>
+            <a:off x="457200" y="1051560"/>
+            <a:ext cx="11247120" cy="365760"/>
+          </a:xfrm>
+          <a:prstGeom prst="rect">
+            <a:avLst/>
+          </a:prstGeom>
+          <a:noFill/>
+          <a:ln/>
+        </p:spPr>
+        <p:txBody>
+          <a:bodyPr wrap="square" rtlCol="0" anchor="ctr"/>
+          <a:lstStyle/>
+          <a:p>
+            <a:pPr algn="l" indent="0" marL="0">
+              <a:buNone/>
+            </a:pPr>
+            <a:r>
+              <a:rPr lang="en-US" sz="1400" dirty="0">
+                <a:solidFill>
+                  <a:srgbClr val="94A3B8"/>
+                </a:solidFill>
+                <a:latin typeface="Calibri" pitchFamily="34" charset="0"/>
+                <a:ea typeface="Calibri" pitchFamily="34" charset="-122"/>
+                <a:cs typeface="Calibri" pitchFamily="34" charset="-120"/>
+              </a:rPr>
+              <a:t>server/src/routes/incidents.js — two channels in parallel for every in-radius candidate</a:t>
+            </a:r>
+            <a:endParaRPr lang="en-US" sz="1400" dirty="0"/>
+          </a:p>
+        </p:txBody>
+      </p:sp>
+      <p:sp>
+        <p:nvSpPr>
+          <p:cNvPr id="4" name="Shape 2"/>
+          <p:cNvSpPr/>
+          <p:nvPr/>
+        </p:nvSpPr>
+        <p:spPr>
+          <a:xfrm>
+            <a:off x="457200" y="1508760"/>
+            <a:ext cx="11247120" cy="1207008"/>
           </a:xfrm>
           <a:prstGeom prst="roundRect">
             <a:avLst>
-              <a:gd name="adj" fmla="val 5000"/>
+              <a:gd name="adj" fmla="val 6061"/>
             </a:avLst>
           </a:prstGeom>
           <a:solidFill>
@@ -4048,14 +4126,14 @@
       </p:sp>
       <p:sp>
         <p:nvSpPr>
-          <p:cNvPr id="4" name="Text 2"/>
-          <p:cNvSpPr/>
-          <p:nvPr/>
-        </p:nvSpPr>
-        <p:spPr>
-          <a:xfrm>
-            <a:off x="685800" y="1417320"/>
-            <a:ext cx="10789920" cy="1234440"/>
+          <p:cNvPr id="5" name="Text 3"/>
+          <p:cNvSpPr/>
+          <p:nvPr/>
+        </p:nvSpPr>
+        <p:spPr>
+          <a:xfrm>
+            <a:off x="685800" y="1627632"/>
+            <a:ext cx="10789920" cy="1024128"/>
           </a:xfrm>
           <a:prstGeom prst="rect">
             <a:avLst/>
@@ -4069,12 +4147,12 @@
           <a:p>
             <a:pPr algn="l" indent="0" marL="0">
               <a:spcAft>
-                <a:spcPts val="300"/>
+                <a:spcPts val="200"/>
               </a:spcAft>
               <a:buNone/>
             </a:pPr>
             <a:r>
-              <a:rPr lang="en-US" sz="1350" dirty="0">
+              <a:rPr lang="en-US" sz="1300" dirty="0">
                 <a:solidFill>
                   <a:srgbClr val="6EE7B7"/>
                 </a:solidFill>
@@ -4082,19 +4160,19 @@
                 <a:ea typeface="Courier New" pitchFamily="34" charset="-122"/>
                 <a:cs typeface="Courier New" pitchFamily="34" charset="-120"/>
               </a:rPr>
-              <a:t>logs.push({ type: 'incident_push', ... });   // סלולר: Push</a:t>
-            </a:r>
-            <a:endParaRPr lang="en-US" sz="1350" dirty="0"/>
+              <a:t>logs.push({ type: 'incident_push', ... });   // cellular: Push</a:t>
+            </a:r>
+            <a:endParaRPr lang="en-US" sz="1300" dirty="0"/>
           </a:p>
           <a:p>
             <a:pPr algn="l" indent="0" marL="0">
               <a:spcAft>
-                <a:spcPts val="300"/>
+                <a:spcPts val="200"/>
               </a:spcAft>
               <a:buNone/>
             </a:pPr>
             <a:r>
-              <a:rPr lang="en-US" sz="1350" dirty="0">
+              <a:rPr lang="en-US" sz="1300" dirty="0">
                 <a:solidFill>
                   <a:srgbClr val="6EE7B7"/>
                 </a:solidFill>
@@ -4102,19 +4180,19 @@
                 <a:ea typeface="Courier New" pitchFamily="34" charset="-122"/>
                 <a:cs typeface="Courier New" pitchFamily="34" charset="-120"/>
               </a:rPr>
-              <a:t>logs.push({ type: 'incident_sms',  ... });   // סלולר: SMS</a:t>
-            </a:r>
-            <a:endParaRPr lang="en-US" sz="1350" dirty="0"/>
+              <a:t>logs.push({ type: 'incident_sms',  ... });   // cellular: SMS (name, phone, location)</a:t>
+            </a:r>
+            <a:endParaRPr lang="en-US" sz="1300" dirty="0"/>
           </a:p>
           <a:p>
             <a:pPr algn="l" indent="0" marL="0">
               <a:spcAft>
-                <a:spcPts val="300"/>
+                <a:spcPts val="200"/>
               </a:spcAft>
               <a:buNone/>
             </a:pPr>
             <a:r>
-              <a:rPr lang="en-US" sz="1350" dirty="0">
+              <a:rPr lang="en-US" sz="1300" dirty="0">
                 <a:solidFill>
                   <a:srgbClr val="6EE7B7"/>
                 </a:solidFill>
@@ -4124,17 +4202,17 @@
               </a:rPr>
               <a:t>if (c.hasLora)</a:t>
             </a:r>
-            <a:endParaRPr lang="en-US" sz="1350" dirty="0"/>
+            <a:endParaRPr lang="en-US" sz="1300" dirty="0"/>
           </a:p>
           <a:p>
             <a:pPr algn="l" indent="0" marL="0">
               <a:spcAft>
-                <a:spcPts val="300"/>
+                <a:spcPts val="200"/>
               </a:spcAft>
               <a:buNone/>
             </a:pPr>
             <a:r>
-              <a:rPr lang="en-US" sz="1350" dirty="0">
+              <a:rPr lang="en-US" sz="1300" dirty="0">
                 <a:solidFill>
                   <a:srgbClr val="6EE7B7"/>
                 </a:solidFill>
@@ -4142,22 +4220,136 @@
                 <a:ea typeface="Courier New" pitchFamily="34" charset="-122"/>
                 <a:cs typeface="Courier New" pitchFamily="34" charset="-120"/>
               </a:rPr>
-              <a:t>  logs.push({ type: 'incident_lora_downlink', ... }); // צפצוף+הבהוב</a:t>
-            </a:r>
-            <a:endParaRPr lang="en-US" sz="1350" dirty="0"/>
-          </a:p>
-        </p:txBody>
-      </p:sp>
-      <p:sp>
-        <p:nvSpPr>
-          <p:cNvPr id="5" name="Text 3"/>
-          <p:cNvSpPr/>
-          <p:nvPr/>
-        </p:nvSpPr>
-        <p:spPr>
-          <a:xfrm>
-            <a:off x="457200" y="2880360"/>
-            <a:ext cx="11247120" cy="640080"/>
+              <a:t>  logs.push({ type: 'incident_lora_downlink', ... }); // LoRa: beep + flash</a:t>
+            </a:r>
+            <a:endParaRPr lang="en-US" sz="1300" dirty="0"/>
+          </a:p>
+        </p:txBody>
+      </p:sp>
+      <p:sp>
+        <p:nvSpPr>
+          <p:cNvPr id="6" name="Text 4"/>
+          <p:cNvSpPr/>
+          <p:nvPr/>
+        </p:nvSpPr>
+        <p:spPr>
+          <a:xfrm>
+            <a:off x="457200" y="2944368"/>
+            <a:ext cx="11247120" cy="1463040"/>
+          </a:xfrm>
+          <a:prstGeom prst="rect">
+            <a:avLst/>
+          </a:prstGeom>
+          <a:noFill/>
+          <a:ln/>
+        </p:spPr>
+        <p:txBody>
+          <a:bodyPr wrap="square" rtlCol="0" anchor="t"/>
+          <a:lstStyle/>
+          <a:p>
+            <a:pPr algn="l" indent="0" marL="0">
+              <a:buNone/>
+            </a:pPr>
+            <a:r>
+              <a:rPr lang="en-US" sz="1400" b="1" dirty="0">
+                <a:solidFill>
+                  <a:srgbClr val="059669"/>
+                </a:solidFill>
+                <a:latin typeface="Calibri" pitchFamily="34" charset="0"/>
+                <a:ea typeface="Calibri" pitchFamily="34" charset="-122"/>
+                <a:cs typeface="Calibri" pitchFamily="34" charset="-120"/>
+              </a:rPr>
+              <a:t>Defense points:  </a:t>
+            </a:r>
+            <a:pPr algn="l" indent="0" marL="0">
+              <a:buNone/>
+            </a:pPr>
+            <a:r>
+              <a:rPr lang="en-US" sz="1400" dirty="0">
+                <a:solidFill>
+                  <a:srgbClr val="CBD5E1"/>
+                </a:solidFill>
+                <a:latin typeface="Calibri" pitchFamily="34" charset="0"/>
+                <a:ea typeface="Calibri" pitchFamily="34" charset="-122"/>
+                <a:cs typeface="Calibri" pitchFamily="34" charset="-120"/>
+              </a:rPr>
+              <a:t>client side: routing via OSRM cycling → a real bike route (requirement 10), the volunteer is animated along it, and breadcrumbs are POSTed to the dispatch center every 2 seconds.</a:t>
+            </a:r>
+            <a:endParaRPr lang="en-US" sz="1400" dirty="0"/>
+          </a:p>
+        </p:txBody>
+      </p:sp>
+      <p:sp>
+        <p:nvSpPr>
+          <p:cNvPr id="7" name="Text 5"/>
+          <p:cNvSpPr/>
+          <p:nvPr/>
+        </p:nvSpPr>
+        <p:spPr>
+          <a:xfrm>
+            <a:off x="8138160" y="6419088"/>
+            <a:ext cx="3657600" cy="320040"/>
+          </a:xfrm>
+          <a:prstGeom prst="rect">
+            <a:avLst/>
+          </a:prstGeom>
+          <a:noFill/>
+          <a:ln/>
+        </p:spPr>
+        <p:txBody>
+          <a:bodyPr wrap="square" lIns="0" tIns="0" rIns="0" bIns="0" rtlCol="0" anchor="ctr"/>
+          <a:lstStyle/>
+          <a:p>
+            <a:pPr algn="r" indent="0" marL="0">
+              <a:buNone/>
+            </a:pPr>
+            <a:r>
+              <a:rPr lang="en-US" sz="900" dirty="0">
+                <a:solidFill>
+                  <a:srgbClr val="64748B"/>
+                </a:solidFill>
+                <a:latin typeface="Calibri" pitchFamily="34" charset="0"/>
+                <a:ea typeface="Calibri" pitchFamily="34" charset="-122"/>
+                <a:cs typeface="Calibri" pitchFamily="34" charset="-120"/>
+              </a:rPr>
+              <a:t>DefiNet · slide 6</a:t>
+            </a:r>
+            <a:endParaRPr lang="en-US" sz="900" dirty="0"/>
+          </a:p>
+        </p:txBody>
+      </p:sp>
+      <p:sp>
+        <p:nvSpPr>
+          <p:cNvPr id="9" name="Shape 6"/>
+          <p:cNvSpPr/>
+          <p:nvPr/>
+        </p:nvSpPr>
+        <p:spPr>
+          <a:xfrm>
+            <a:off x="548640" y="4206240"/>
+            <a:ext cx="2628900" cy="1463040"/>
+          </a:xfrm>
+          <a:prstGeom prst="roundRect">
+            <a:avLst>
+              <a:gd name="adj" fmla="val 6250"/>
+            </a:avLst>
+          </a:prstGeom>
+          <a:solidFill>
+            <a:srgbClr val="1E293B"/>
+          </a:solidFill>
+          <a:ln/>
+        </p:spPr>
+      </p:sp>
+      <p:sp>
+        <p:nvSpPr>
+          <p:cNvPr id="10" name="Text 7"/>
+          <p:cNvSpPr/>
+          <p:nvPr/>
+        </p:nvSpPr>
+        <p:spPr>
+          <a:xfrm>
+            <a:off x="548640" y="4343400"/>
+            <a:ext cx="2628900" cy="777240"/>
           </a:xfrm>
           <a:prstGeom prst="rect">
             <a:avLst/>
@@ -4169,38 +4361,77 @@
           <a:bodyPr wrap="square" rtlCol="0" anchor="ctr"/>
           <a:lstStyle/>
           <a:p>
-            <a:pPr rtl="1" algn="r" indent="0" marL="0">
-              <a:buNone/>
-            </a:pPr>
-            <a:r>
-              <a:rPr lang="en-US" sz="1400" dirty="0">
-                <a:solidFill>
-                  <a:srgbClr val="CBD5E1"/>
+            <a:pPr algn="ctr" indent="0" marL="0">
+              <a:buNone/>
+            </a:pPr>
+            <a:r>
+              <a:rPr lang="en-US" sz="4000" b="1" dirty="0">
+                <a:solidFill>
+                  <a:srgbClr val="059669"/>
                 </a:solidFill>
                 <a:latin typeface="Arial" pitchFamily="34" charset="0"/>
                 <a:ea typeface="Arial" pitchFamily="34" charset="-122"/>
                 <a:cs typeface="Arial" pitchFamily="34" charset="-120"/>
               </a:rPr>
-              <a:t>בצד הלקוח: ניקוד המסלול מול OSRM cycling → מסלול אופניים אמיתי (דרישה 10), אנימציית מתנדב, ופירורי-לחם למוקד כל 2 שנ׳.</a:t>
-            </a:r>
-            <a:endParaRPr lang="en-US" sz="1400" dirty="0"/>
-          </a:p>
-        </p:txBody>
-      </p:sp>
-      <p:sp>
-        <p:nvSpPr>
-          <p:cNvPr id="6" name="Shape 4"/>
-          <p:cNvSpPr/>
-          <p:nvPr/>
-        </p:nvSpPr>
-        <p:spPr>
-          <a:xfrm>
-            <a:off x="548640" y="3840480"/>
-            <a:ext cx="2628900" cy="1554480"/>
+              <a:t>100%</a:t>
+            </a:r>
+            <a:endParaRPr lang="en-US" sz="4000" dirty="0"/>
+          </a:p>
+        </p:txBody>
+      </p:sp>
+      <p:sp>
+        <p:nvSpPr>
+          <p:cNvPr id="11" name="Text 8"/>
+          <p:cNvSpPr/>
+          <p:nvPr/>
+        </p:nvSpPr>
+        <p:spPr>
+          <a:xfrm>
+            <a:off x="640080" y="5120640"/>
+            <a:ext cx="2446020" cy="457200"/>
+          </a:xfrm>
+          <a:prstGeom prst="rect">
+            <a:avLst/>
+          </a:prstGeom>
+          <a:noFill/>
+          <a:ln/>
+        </p:spPr>
+        <p:txBody>
+          <a:bodyPr wrap="square" rtlCol="0" anchor="ctr"/>
+          <a:lstStyle/>
+          <a:p>
+            <a:pPr algn="ctr" indent="0" marL="0">
+              <a:buNone/>
+            </a:pPr>
+            <a:r>
+              <a:rPr lang="en-US" sz="1200" dirty="0">
+                <a:solidFill>
+                  <a:srgbClr val="CBD5E1"/>
+                </a:solidFill>
+                <a:latin typeface="Calibri" pitchFamily="34" charset="0"/>
+                <a:ea typeface="Calibri" pitchFamily="34" charset="-122"/>
+                <a:cs typeface="Calibri" pitchFamily="34" charset="-120"/>
+              </a:rPr>
+              <a:t>requirements coverage</a:t>
+            </a:r>
+            <a:endParaRPr lang="en-US" sz="1200" dirty="0"/>
+          </a:p>
+        </p:txBody>
+      </p:sp>
+      <p:sp>
+        <p:nvSpPr>
+          <p:cNvPr id="12" name="Shape 9"/>
+          <p:cNvSpPr/>
+          <p:nvPr/>
+        </p:nvSpPr>
+        <p:spPr>
+          <a:xfrm>
+            <a:off x="3360420" y="4206240"/>
+            <a:ext cx="2628900" cy="1463040"/>
           </a:xfrm>
           <a:prstGeom prst="roundRect">
             <a:avLst>
-              <a:gd name="adj" fmla="val 5882"/>
+              <a:gd name="adj" fmla="val 6250"/>
             </a:avLst>
           </a:prstGeom>
           <a:solidFill>
@@ -4211,14 +4442,14 @@
       </p:sp>
       <p:sp>
         <p:nvSpPr>
-          <p:cNvPr id="7" name="Text 5"/>
-          <p:cNvSpPr/>
-          <p:nvPr/>
-        </p:nvSpPr>
-        <p:spPr>
-          <a:xfrm>
-            <a:off x="548640" y="4023360"/>
-            <a:ext cx="2628900" cy="822960"/>
+          <p:cNvPr id="13" name="Text 10"/>
+          <p:cNvSpPr/>
+          <p:nvPr/>
+        </p:nvSpPr>
+        <p:spPr>
+          <a:xfrm>
+            <a:off x="3360420" y="4343400"/>
+            <a:ext cx="2628900" cy="777240"/>
           </a:xfrm>
           <a:prstGeom prst="rect">
             <a:avLst/>
@@ -4234,7 +4465,7 @@
               <a:buNone/>
             </a:pPr>
             <a:r>
-              <a:rPr lang="en-US" sz="4200" b="1" dirty="0">
+              <a:rPr lang="en-US" sz="4000" b="1" dirty="0">
                 <a:solidFill>
                   <a:srgbClr val="059669"/>
                 </a:solidFill>
@@ -4242,21 +4473,21 @@
                 <a:ea typeface="Arial" pitchFamily="34" charset="-122"/>
                 <a:cs typeface="Arial" pitchFamily="34" charset="-120"/>
               </a:rPr>
-              <a:t>100%</a:t>
-            </a:r>
-            <a:endParaRPr lang="en-US" sz="4200" dirty="0"/>
-          </a:p>
-        </p:txBody>
-      </p:sp>
-      <p:sp>
-        <p:nvSpPr>
-          <p:cNvPr id="8" name="Text 6"/>
-          <p:cNvSpPr/>
-          <p:nvPr/>
-        </p:nvSpPr>
-        <p:spPr>
-          <a:xfrm>
-            <a:off x="640080" y="4846320"/>
+              <a:t>2</a:t>
+            </a:r>
+            <a:endParaRPr lang="en-US" sz="4000" dirty="0"/>
+          </a:p>
+        </p:txBody>
+      </p:sp>
+      <p:sp>
+        <p:nvSpPr>
+          <p:cNvPr id="14" name="Text 11"/>
+          <p:cNvSpPr/>
+          <p:nvPr/>
+        </p:nvSpPr>
+        <p:spPr>
+          <a:xfrm>
+            <a:off x="3451860" y="5120640"/>
             <a:ext cx="2446020" cy="457200"/>
           </a:xfrm>
           <a:prstGeom prst="rect">
@@ -4269,19 +4500,119 @@
           <a:bodyPr wrap="square" rtlCol="0" anchor="ctr"/>
           <a:lstStyle/>
           <a:p>
-            <a:pPr rtl="1" algn="ctr" indent="0" marL="0">
+            <a:pPr algn="ctr" indent="0" marL="0">
               <a:buNone/>
             </a:pPr>
             <a:r>
               <a:rPr lang="en-US" sz="1200" dirty="0">
                 <a:solidFill>
                   <a:srgbClr val="CBD5E1"/>
+                </a:solidFill>
+                <a:latin typeface="Calibri" pitchFamily="34" charset="0"/>
+                <a:ea typeface="Calibri" pitchFamily="34" charset="-122"/>
+                <a:cs typeface="Calibri" pitchFamily="34" charset="-120"/>
+              </a:rPr>
+              <a:t>databases (SQL + NoSQL)</a:t>
+            </a:r>
+            <a:endParaRPr lang="en-US" sz="1200" dirty="0"/>
+          </a:p>
+        </p:txBody>
+      </p:sp>
+      <p:sp>
+        <p:nvSpPr>
+          <p:cNvPr id="15" name="Shape 12"/>
+          <p:cNvSpPr/>
+          <p:nvPr/>
+        </p:nvSpPr>
+        <p:spPr>
+          <a:xfrm>
+            <a:off x="6172200" y="4206240"/>
+            <a:ext cx="2628900" cy="1463040"/>
+          </a:xfrm>
+          <a:prstGeom prst="roundRect">
+            <a:avLst>
+              <a:gd name="adj" fmla="val 6250"/>
+            </a:avLst>
+          </a:prstGeom>
+          <a:solidFill>
+            <a:srgbClr val="1E293B"/>
+          </a:solidFill>
+          <a:ln/>
+        </p:spPr>
+      </p:sp>
+      <p:sp>
+        <p:nvSpPr>
+          <p:cNvPr id="16" name="Text 13"/>
+          <p:cNvSpPr/>
+          <p:nvPr/>
+        </p:nvSpPr>
+        <p:spPr>
+          <a:xfrm>
+            <a:off x="6172200" y="4343400"/>
+            <a:ext cx="2628900" cy="777240"/>
+          </a:xfrm>
+          <a:prstGeom prst="rect">
+            <a:avLst/>
+          </a:prstGeom>
+          <a:noFill/>
+          <a:ln/>
+        </p:spPr>
+        <p:txBody>
+          <a:bodyPr wrap="square" rtlCol="0" anchor="ctr"/>
+          <a:lstStyle/>
+          <a:p>
+            <a:pPr algn="ctr" indent="0" marL="0">
+              <a:buNone/>
+            </a:pPr>
+            <a:r>
+              <a:rPr lang="en-US" sz="4000" b="1" dirty="0">
+                <a:solidFill>
+                  <a:srgbClr val="059669"/>
                 </a:solidFill>
                 <a:latin typeface="Arial" pitchFamily="34" charset="0"/>
                 <a:ea typeface="Arial" pitchFamily="34" charset="-122"/>
                 <a:cs typeface="Arial" pitchFamily="34" charset="-120"/>
               </a:rPr>
-              <a:t>כיסוי דרישות</a:t>
+              <a:t>2</a:t>
+            </a:r>
+            <a:endParaRPr lang="en-US" sz="4000" dirty="0"/>
+          </a:p>
+        </p:txBody>
+      </p:sp>
+      <p:sp>
+        <p:nvSpPr>
+          <p:cNvPr id="17" name="Text 14"/>
+          <p:cNvSpPr/>
+          <p:nvPr/>
+        </p:nvSpPr>
+        <p:spPr>
+          <a:xfrm>
+            <a:off x="6263640" y="5120640"/>
+            <a:ext cx="2446020" cy="457200"/>
+          </a:xfrm>
+          <a:prstGeom prst="rect">
+            <a:avLst/>
+          </a:prstGeom>
+          <a:noFill/>
+          <a:ln/>
+        </p:spPr>
+        <p:txBody>
+          <a:bodyPr wrap="square" rtlCol="0" anchor="ctr"/>
+          <a:lstStyle/>
+          <a:p>
+            <a:pPr algn="ctr" indent="0" marL="0">
+              <a:buNone/>
+            </a:pPr>
+            <a:r>
+              <a:rPr lang="en-US" sz="1200" dirty="0">
+                <a:solidFill>
+                  <a:srgbClr val="CBD5E1"/>
+                </a:solidFill>
+                <a:latin typeface="Calibri" pitchFamily="34" charset="0"/>
+                <a:ea typeface="Calibri" pitchFamily="34" charset="-122"/>
+                <a:cs typeface="Calibri" pitchFamily="34" charset="-120"/>
+              </a:rPr>
+              <a:t>servers (Express + Next.js)</a:t>
             </a:r>
             <a:endParaRPr lang="en-US" sz="1200" dirty="0"/>
           </a:p>
@@ -4289,18 +4620,18 @@
       </p:sp>
       <p:sp>
         <p:nvSpPr>
-          <p:cNvPr id="9" name="Shape 7"/>
-          <p:cNvSpPr/>
-          <p:nvPr/>
-        </p:nvSpPr>
-        <p:spPr>
-          <a:xfrm>
-            <a:off x="3360420" y="3840480"/>
-            <a:ext cx="2628900" cy="1554480"/>
+          <p:cNvPr id="18" name="Shape 15"/>
+          <p:cNvSpPr/>
+          <p:nvPr/>
+        </p:nvSpPr>
+        <p:spPr>
+          <a:xfrm>
+            <a:off x="8983980" y="4206240"/>
+            <a:ext cx="2628900" cy="1463040"/>
           </a:xfrm>
           <a:prstGeom prst="roundRect">
             <a:avLst>
-              <a:gd name="adj" fmla="val 5882"/>
+              <a:gd name="adj" fmla="val 6250"/>
             </a:avLst>
           </a:prstGeom>
           <a:solidFill>
@@ -4311,14 +4642,14 @@
       </p:sp>
       <p:sp>
         <p:nvSpPr>
-          <p:cNvPr id="10" name="Text 8"/>
-          <p:cNvSpPr/>
-          <p:nvPr/>
-        </p:nvSpPr>
-        <p:spPr>
-          <a:xfrm>
-            <a:off x="3360420" y="4023360"/>
-            <a:ext cx="2628900" cy="822960"/>
+          <p:cNvPr id="19" name="Text 16"/>
+          <p:cNvSpPr/>
+          <p:nvPr/>
+        </p:nvSpPr>
+        <p:spPr>
+          <a:xfrm>
+            <a:off x="8983980" y="4343400"/>
+            <a:ext cx="2628900" cy="777240"/>
           </a:xfrm>
           <a:prstGeom prst="rect">
             <a:avLst/>
@@ -4334,7 +4665,7 @@
               <a:buNone/>
             </a:pPr>
             <a:r>
-              <a:rPr lang="en-US" sz="4200" b="1" dirty="0">
+              <a:rPr lang="en-US" sz="4000" b="1" dirty="0">
                 <a:solidFill>
                   <a:srgbClr val="059669"/>
                 </a:solidFill>
@@ -4342,21 +4673,21 @@
                 <a:ea typeface="Arial" pitchFamily="34" charset="-122"/>
                 <a:cs typeface="Arial" pitchFamily="34" charset="-120"/>
               </a:rPr>
-              <a:t>2</a:t>
-            </a:r>
-            <a:endParaRPr lang="en-US" sz="4200" dirty="0"/>
-          </a:p>
-        </p:txBody>
-      </p:sp>
-      <p:sp>
-        <p:nvSpPr>
-          <p:cNvPr id="11" name="Text 9"/>
-          <p:cNvSpPr/>
-          <p:nvPr/>
-        </p:nvSpPr>
-        <p:spPr>
-          <a:xfrm>
-            <a:off x="3451860" y="4846320"/>
+              <a:t>+2</a:t>
+            </a:r>
+            <a:endParaRPr lang="en-US" sz="4000" dirty="0"/>
+          </a:p>
+        </p:txBody>
+      </p:sp>
+      <p:sp>
+        <p:nvSpPr>
+          <p:cNvPr id="20" name="Text 17"/>
+          <p:cNvSpPr/>
+          <p:nvPr/>
+        </p:nvSpPr>
+        <p:spPr>
+          <a:xfrm>
+            <a:off x="9075420" y="5120640"/>
             <a:ext cx="2446020" cy="457200"/>
           </a:xfrm>
           <a:prstGeom prst="rect">
@@ -4369,299 +4700,60 @@
           <a:bodyPr wrap="square" rtlCol="0" anchor="ctr"/>
           <a:lstStyle/>
           <a:p>
-            <a:pPr rtl="1" algn="ctr" indent="0" marL="0">
+            <a:pPr algn="ctr" indent="0" marL="0">
               <a:buNone/>
             </a:pPr>
             <a:r>
               <a:rPr lang="en-US" sz="1200" dirty="0">
                 <a:solidFill>
                   <a:srgbClr val="CBD5E1"/>
+                </a:solidFill>
+                <a:latin typeface="Calibri" pitchFamily="34" charset="0"/>
+                <a:ea typeface="Calibri" pitchFamily="34" charset="-122"/>
+                <a:cs typeface="Calibri" pitchFamily="34" charset="-120"/>
+              </a:rPr>
+              <a:t>bonus features</a:t>
+            </a:r>
+            <a:endParaRPr lang="en-US" sz="1200" dirty="0"/>
+          </a:p>
+        </p:txBody>
+      </p:sp>
+      <p:sp>
+        <p:nvSpPr>
+          <p:cNvPr id="21" name="Text 18"/>
+          <p:cNvSpPr/>
+          <p:nvPr/>
+        </p:nvSpPr>
+        <p:spPr>
+          <a:xfrm>
+            <a:off x="457200" y="5806440"/>
+            <a:ext cx="11247120" cy="457200"/>
+          </a:xfrm>
+          <a:prstGeom prst="rect">
+            <a:avLst/>
+          </a:prstGeom>
+          <a:noFill/>
+          <a:ln/>
+        </p:spPr>
+        <p:txBody>
+          <a:bodyPr wrap="square" rtlCol="0" anchor="ctr"/>
+          <a:lstStyle/>
+          <a:p>
+            <a:pPr algn="l" indent="0" marL="0">
+              <a:buNone/>
+            </a:pPr>
+            <a:r>
+              <a:rPr lang="en-US" sz="1700" b="1" i="1" dirty="0">
+                <a:solidFill>
+                  <a:srgbClr val="F87171"/>
                 </a:solidFill>
                 <a:latin typeface="Arial" pitchFamily="34" charset="0"/>
                 <a:ea typeface="Arial" pitchFamily="34" charset="-122"/>
                 <a:cs typeface="Arial" pitchFamily="34" charset="-120"/>
               </a:rPr>
-              <a:t>מסדי נתונים (SQL+NoSQL)</a:t>
-            </a:r>
-            <a:endParaRPr lang="en-US" sz="1200" dirty="0"/>
-          </a:p>
-        </p:txBody>
-      </p:sp>
-      <p:sp>
-        <p:nvSpPr>
-          <p:cNvPr id="12" name="Shape 10"/>
-          <p:cNvSpPr/>
-          <p:nvPr/>
-        </p:nvSpPr>
-        <p:spPr>
-          <a:xfrm>
-            <a:off x="6172200" y="3840480"/>
-            <a:ext cx="2628900" cy="1554480"/>
-          </a:xfrm>
-          <a:prstGeom prst="roundRect">
-            <a:avLst>
-              <a:gd name="adj" fmla="val 5882"/>
-            </a:avLst>
-          </a:prstGeom>
-          <a:solidFill>
-            <a:srgbClr val="1E293B"/>
-          </a:solidFill>
-          <a:ln/>
-        </p:spPr>
-      </p:sp>
-      <p:sp>
-        <p:nvSpPr>
-          <p:cNvPr id="13" name="Text 11"/>
-          <p:cNvSpPr/>
-          <p:nvPr/>
-        </p:nvSpPr>
-        <p:spPr>
-          <a:xfrm>
-            <a:off x="6172200" y="4023360"/>
-            <a:ext cx="2628900" cy="822960"/>
-          </a:xfrm>
-          <a:prstGeom prst="rect">
-            <a:avLst/>
-          </a:prstGeom>
-          <a:noFill/>
-          <a:ln/>
-        </p:spPr>
-        <p:txBody>
-          <a:bodyPr wrap="square" rtlCol="0" anchor="ctr"/>
-          <a:lstStyle/>
-          <a:p>
-            <a:pPr algn="ctr" indent="0" marL="0">
-              <a:buNone/>
-            </a:pPr>
-            <a:r>
-              <a:rPr lang="en-US" sz="4200" b="1" dirty="0">
-                <a:solidFill>
-                  <a:srgbClr val="059669"/>
-                </a:solidFill>
-                <a:latin typeface="Arial" pitchFamily="34" charset="0"/>
-                <a:ea typeface="Arial" pitchFamily="34" charset="-122"/>
-                <a:cs typeface="Arial" pitchFamily="34" charset="-120"/>
-              </a:rPr>
-              <a:t>2</a:t>
-            </a:r>
-            <a:endParaRPr lang="en-US" sz="4200" dirty="0"/>
-          </a:p>
-        </p:txBody>
-      </p:sp>
-      <p:sp>
-        <p:nvSpPr>
-          <p:cNvPr id="14" name="Text 12"/>
-          <p:cNvSpPr/>
-          <p:nvPr/>
-        </p:nvSpPr>
-        <p:spPr>
-          <a:xfrm>
-            <a:off x="6263640" y="4846320"/>
-            <a:ext cx="2446020" cy="457200"/>
-          </a:xfrm>
-          <a:prstGeom prst="rect">
-            <a:avLst/>
-          </a:prstGeom>
-          <a:noFill/>
-          <a:ln/>
-        </p:spPr>
-        <p:txBody>
-          <a:bodyPr wrap="square" rtlCol="0" anchor="ctr"/>
-          <a:lstStyle/>
-          <a:p>
-            <a:pPr rtl="1" algn="ctr" indent="0" marL="0">
-              <a:buNone/>
-            </a:pPr>
-            <a:r>
-              <a:rPr lang="en-US" sz="1200" dirty="0">
-                <a:solidFill>
-                  <a:srgbClr val="CBD5E1"/>
-                </a:solidFill>
-                <a:latin typeface="Arial" pitchFamily="34" charset="0"/>
-                <a:ea typeface="Arial" pitchFamily="34" charset="-122"/>
-                <a:cs typeface="Arial" pitchFamily="34" charset="-120"/>
-              </a:rPr>
-              <a:t>שרתים (Express+Next.js)</a:t>
-            </a:r>
-            <a:endParaRPr lang="en-US" sz="1200" dirty="0"/>
-          </a:p>
-        </p:txBody>
-      </p:sp>
-      <p:sp>
-        <p:nvSpPr>
-          <p:cNvPr id="15" name="Shape 13"/>
-          <p:cNvSpPr/>
-          <p:nvPr/>
-        </p:nvSpPr>
-        <p:spPr>
-          <a:xfrm>
-            <a:off x="8983980" y="3840480"/>
-            <a:ext cx="2628900" cy="1554480"/>
-          </a:xfrm>
-          <a:prstGeom prst="roundRect">
-            <a:avLst>
-              <a:gd name="adj" fmla="val 5882"/>
-            </a:avLst>
-          </a:prstGeom>
-          <a:solidFill>
-            <a:srgbClr val="1E293B"/>
-          </a:solidFill>
-          <a:ln/>
-        </p:spPr>
-      </p:sp>
-      <p:sp>
-        <p:nvSpPr>
-          <p:cNvPr id="16" name="Text 14"/>
-          <p:cNvSpPr/>
-          <p:nvPr/>
-        </p:nvSpPr>
-        <p:spPr>
-          <a:xfrm>
-            <a:off x="8983980" y="4023360"/>
-            <a:ext cx="2628900" cy="822960"/>
-          </a:xfrm>
-          <a:prstGeom prst="rect">
-            <a:avLst/>
-          </a:prstGeom>
-          <a:noFill/>
-          <a:ln/>
-        </p:spPr>
-        <p:txBody>
-          <a:bodyPr wrap="square" rtlCol="0" anchor="ctr"/>
-          <a:lstStyle/>
-          <a:p>
-            <a:pPr algn="ctr" indent="0" marL="0">
-              <a:buNone/>
-            </a:pPr>
-            <a:r>
-              <a:rPr lang="en-US" sz="4200" b="1" dirty="0">
-                <a:solidFill>
-                  <a:srgbClr val="059669"/>
-                </a:solidFill>
-                <a:latin typeface="Arial" pitchFamily="34" charset="0"/>
-                <a:ea typeface="Arial" pitchFamily="34" charset="-122"/>
-                <a:cs typeface="Arial" pitchFamily="34" charset="-120"/>
-              </a:rPr>
-              <a:t>+2</a:t>
-            </a:r>
-            <a:endParaRPr lang="en-US" sz="4200" dirty="0"/>
-          </a:p>
-        </p:txBody>
-      </p:sp>
-      <p:sp>
-        <p:nvSpPr>
-          <p:cNvPr id="17" name="Text 15"/>
-          <p:cNvSpPr/>
-          <p:nvPr/>
-        </p:nvSpPr>
-        <p:spPr>
-          <a:xfrm>
-            <a:off x="9075420" y="4846320"/>
-            <a:ext cx="2446020" cy="457200"/>
-          </a:xfrm>
-          <a:prstGeom prst="rect">
-            <a:avLst/>
-          </a:prstGeom>
-          <a:noFill/>
-          <a:ln/>
-        </p:spPr>
-        <p:txBody>
-          <a:bodyPr wrap="square" rtlCol="0" anchor="ctr"/>
-          <a:lstStyle/>
-          <a:p>
-            <a:pPr rtl="1" algn="ctr" indent="0" marL="0">
-              <a:buNone/>
-            </a:pPr>
-            <a:r>
-              <a:rPr lang="en-US" sz="1200" dirty="0">
-                <a:solidFill>
-                  <a:srgbClr val="CBD5E1"/>
-                </a:solidFill>
-                <a:latin typeface="Arial" pitchFamily="34" charset="0"/>
-                <a:ea typeface="Arial" pitchFamily="34" charset="-122"/>
-                <a:cs typeface="Arial" pitchFamily="34" charset="-120"/>
-              </a:rPr>
-              <a:t>רעיונות בונוס</a:t>
-            </a:r>
-            <a:endParaRPr lang="en-US" sz="1200" dirty="0"/>
-          </a:p>
-        </p:txBody>
-      </p:sp>
-      <p:sp>
-        <p:nvSpPr>
-          <p:cNvPr id="18" name="Text 16"/>
-          <p:cNvSpPr/>
-          <p:nvPr/>
-        </p:nvSpPr>
-        <p:spPr>
-          <a:xfrm>
-            <a:off x="457200" y="5669280"/>
-            <a:ext cx="11247120" cy="548640"/>
-          </a:xfrm>
-          <a:prstGeom prst="rect">
-            <a:avLst/>
-          </a:prstGeom>
-          <a:noFill/>
-          <a:ln/>
-        </p:spPr>
-        <p:txBody>
-          <a:bodyPr wrap="square" rtlCol="0" anchor="ctr"/>
-          <a:lstStyle/>
-          <a:p>
-            <a:pPr rtl="1" algn="r" indent="0" marL="0">
-              <a:buNone/>
-            </a:pPr>
-            <a:r>
-              <a:rPr lang="en-US" sz="1800" b="1" i="1" dirty="0">
-                <a:solidFill>
-                  <a:srgbClr val="F87171"/>
-                </a:solidFill>
-                <a:latin typeface="Arial" pitchFamily="34" charset="0"/>
-                <a:ea typeface="Arial" pitchFamily="34" charset="-122"/>
-                <a:cs typeface="Arial" pitchFamily="34" charset="-120"/>
-              </a:rPr>
-              <a:t>דפי-נט — כי כל דקה קובעת.</a:t>
-            </a:r>
-            <a:endParaRPr lang="en-US" sz="1800" dirty="0"/>
-          </a:p>
-        </p:txBody>
-      </p:sp>
-      <p:sp>
-        <p:nvSpPr>
-          <p:cNvPr id="19" name="Text 17"/>
-          <p:cNvSpPr/>
-          <p:nvPr/>
-        </p:nvSpPr>
-        <p:spPr>
-          <a:xfrm>
-            <a:off x="365760" y="6419088"/>
-            <a:ext cx="3657600" cy="320040"/>
-          </a:xfrm>
-          <a:prstGeom prst="rect">
-            <a:avLst/>
-          </a:prstGeom>
-          <a:noFill/>
-          <a:ln/>
-        </p:spPr>
-        <p:txBody>
-          <a:bodyPr wrap="square" lIns="0" tIns="0" rIns="0" bIns="0" rtlCol="0" anchor="ctr"/>
-          <a:lstStyle/>
-          <a:p>
-            <a:pPr rtl="1" algn="l" indent="0" marL="0">
-              <a:buNone/>
-            </a:pPr>
-            <a:r>
-              <a:rPr lang="en-US" sz="900" dirty="0">
-                <a:solidFill>
-                  <a:srgbClr val="64748B"/>
-                </a:solidFill>
-                <a:latin typeface="Arial" pitchFamily="34" charset="0"/>
-                <a:ea typeface="Arial" pitchFamily="34" charset="-122"/>
-                <a:cs typeface="Arial" pitchFamily="34" charset="-120"/>
-              </a:rPr>
-              <a:t>דפי-נט · שקף 6</a:t>
-            </a:r>
-            <a:endParaRPr lang="en-US" sz="900" dirty="0"/>
+              <a:t>DefiNet — because every minute counts.</a:t>
+            </a:r>
+            <a:endParaRPr lang="en-US" sz="1700" dirty="0"/>
           </a:p>
         </p:txBody>
       </p:sp>

</xml_diff>

<commit_message>
docs: disclose the Atlas 0.0.0.0/0 allow-list as a known issue
Render Free has no static outbound IP, so the Atlas network allow-list must
be open. Disclosed honestly in the README, the slides source and slide 2 of
the deck (undisclosed issues found at the defense cost points; disclosed
ones do not), together with the mitigations: authenticated access over TLS,
demo data only, and least-privilege DB user.

Co-Authored-By: Claude Fable 5 <noreply@anthropic.com>
</commit_message>
<xml_diff>
--- a/docs/DefiNet-Defense-Deck.pptx
+++ b/docs/DefiNet-Defense-Deck.pptx
@@ -1769,8 +1769,8 @@
         </p:nvSpPr>
         <p:spPr>
           <a:xfrm>
-            <a:off x="502920" y="1737360"/>
-            <a:ext cx="256032" cy="256032"/>
+            <a:off x="502920" y="1645920"/>
+            <a:ext cx="237744" cy="237744"/>
           </a:xfrm>
           <a:prstGeom prst="ellipse">
             <a:avLst/>
@@ -1789,8 +1789,8 @@
         </p:nvSpPr>
         <p:spPr>
           <a:xfrm>
-            <a:off x="914400" y="1691640"/>
-            <a:ext cx="10607040" cy="365760"/>
+            <a:off x="914400" y="1609344"/>
+            <a:ext cx="10607040" cy="329184"/>
           </a:xfrm>
           <a:prstGeom prst="rect">
             <a:avLst/>
@@ -1806,7 +1806,7 @@
               <a:buNone/>
             </a:pPr>
             <a:r>
-              <a:rPr lang="en-US" sz="1600" b="1" dirty="0">
+              <a:rPr lang="en-US" sz="1500" b="1" dirty="0">
                 <a:solidFill>
                   <a:srgbClr val="0F172A"/>
                 </a:solidFill>
@@ -1816,7 +1816,7 @@
               </a:rPr>
               <a:t>Render Free "sleeps"</a:t>
             </a:r>
-            <a:endParaRPr lang="en-US" sz="1600" dirty="0"/>
+            <a:endParaRPr lang="en-US" sz="1500" dirty="0"/>
           </a:p>
         </p:txBody>
       </p:sp>
@@ -1828,8 +1828,8 @@
         </p:nvSpPr>
         <p:spPr>
           <a:xfrm>
-            <a:off x="914400" y="2039112"/>
-            <a:ext cx="10607040" cy="502920"/>
+            <a:off x="914400" y="1920240"/>
+            <a:ext cx="10607040" cy="457200"/>
           </a:xfrm>
           <a:prstGeom prst="rect">
             <a:avLst/>
@@ -1845,7 +1845,7 @@
               <a:buNone/>
             </a:pPr>
             <a:r>
-              <a:rPr lang="en-US" sz="1300" dirty="0">
+              <a:rPr lang="en-US" sz="1200" dirty="0">
                 <a:solidFill>
                   <a:srgbClr val="334155"/>
                 </a:solidFill>
@@ -1855,7 +1855,7 @@
               </a:rPr>
               <a:t>After ~15 min of inactivity the first API request is slow (~30s). Workaround: open /api/health a minute before the demo.</a:t>
             </a:r>
-            <a:endParaRPr lang="en-US" sz="1300" dirty="0"/>
+            <a:endParaRPr lang="en-US" sz="1200" dirty="0"/>
           </a:p>
         </p:txBody>
       </p:sp>
@@ -1867,8 +1867,8 @@
         </p:nvSpPr>
         <p:spPr>
           <a:xfrm>
-            <a:off x="502920" y="2679192"/>
-            <a:ext cx="256032" cy="256032"/>
+            <a:off x="502920" y="2441448"/>
+            <a:ext cx="237744" cy="237744"/>
           </a:xfrm>
           <a:prstGeom prst="ellipse">
             <a:avLst/>
@@ -1887,8 +1887,8 @@
         </p:nvSpPr>
         <p:spPr>
           <a:xfrm>
-            <a:off x="914400" y="2633472"/>
-            <a:ext cx="10607040" cy="365760"/>
+            <a:off x="914400" y="2404872"/>
+            <a:ext cx="10607040" cy="329184"/>
           </a:xfrm>
           <a:prstGeom prst="rect">
             <a:avLst/>
@@ -1904,7 +1904,7 @@
               <a:buNone/>
             </a:pPr>
             <a:r>
-              <a:rPr lang="en-US" sz="1600" b="1" dirty="0">
+              <a:rPr lang="en-US" sz="1500" b="1" dirty="0">
                 <a:solidFill>
                   <a:srgbClr val="0F172A"/>
                 </a:solidFill>
@@ -1914,7 +1914,7 @@
               </a:rPr>
               <a:t>SQLite is not persistent in the free cloud</a:t>
             </a:r>
-            <a:endParaRPr lang="en-US" sz="1600" dirty="0"/>
+            <a:endParaRPr lang="en-US" sz="1500" dirty="0"/>
           </a:p>
         </p:txBody>
       </p:sp>
@@ -1926,8 +1926,8 @@
         </p:nvSpPr>
         <p:spPr>
           <a:xfrm>
-            <a:off x="914400" y="2980944"/>
-            <a:ext cx="10607040" cy="502920"/>
+            <a:off x="914400" y="2715768"/>
+            <a:ext cx="10607040" cy="457200"/>
           </a:xfrm>
           <a:prstGeom prst="rect">
             <a:avLst/>
@@ -1943,7 +1943,7 @@
               <a:buNone/>
             </a:pPr>
             <a:r>
-              <a:rPr lang="en-US" sz="1300" dirty="0">
+              <a:rPr lang="en-US" sz="1200" dirty="0">
                 <a:solidFill>
                   <a:srgbClr val="334155"/>
                 </a:solidFill>
@@ -1953,7 +1953,7 @@
               </a:rPr>
               <a:t>Every deploy re-seeds the data (the 50 demo devices return). Locally everything persists.</a:t>
             </a:r>
-            <a:endParaRPr lang="en-US" sz="1300" dirty="0"/>
+            <a:endParaRPr lang="en-US" sz="1200" dirty="0"/>
           </a:p>
         </p:txBody>
       </p:sp>
@@ -1965,8 +1965,8 @@
         </p:nvSpPr>
         <p:spPr>
           <a:xfrm>
-            <a:off x="502920" y="3621024"/>
-            <a:ext cx="256032" cy="256032"/>
+            <a:off x="502920" y="3236976"/>
+            <a:ext cx="237744" cy="237744"/>
           </a:xfrm>
           <a:prstGeom prst="ellipse">
             <a:avLst/>
@@ -1985,8 +1985,8 @@
         </p:nvSpPr>
         <p:spPr>
           <a:xfrm>
-            <a:off x="914400" y="3575304"/>
-            <a:ext cx="10607040" cy="365760"/>
+            <a:off x="914400" y="3200400"/>
+            <a:ext cx="10607040" cy="329184"/>
           </a:xfrm>
           <a:prstGeom prst="rect">
             <a:avLst/>
@@ -2002,7 +2002,7 @@
               <a:buNone/>
             </a:pPr>
             <a:r>
-              <a:rPr lang="en-US" sz="1600" b="1" dirty="0">
+              <a:rPr lang="en-US" sz="1500" b="1" dirty="0">
                 <a:solidFill>
                   <a:srgbClr val="0F172A"/>
                 </a:solidFill>
@@ -2012,7 +2012,7 @@
               </a:rPr>
               <a:t>Local MongoDB</a:t>
             </a:r>
-            <a:endParaRPr lang="en-US" sz="1600" dirty="0"/>
+            <a:endParaRPr lang="en-US" sz="1500" dirty="0"/>
           </a:p>
         </p:txBody>
       </p:sp>
@@ -2024,8 +2024,8 @@
         </p:nvSpPr>
         <p:spPr>
           <a:xfrm>
-            <a:off x="914400" y="3922776"/>
-            <a:ext cx="10607040" cy="502920"/>
+            <a:off x="914400" y="3511296"/>
+            <a:ext cx="10607040" cy="457200"/>
           </a:xfrm>
           <a:prstGeom prst="rect">
             <a:avLst/>
@@ -2041,7 +2041,7 @@
               <a:buNone/>
             </a:pPr>
             <a:r>
-              <a:rPr lang="en-US" sz="1300" dirty="0">
+              <a:rPr lang="en-US" sz="1200" dirty="0">
                 <a:solidFill>
                   <a:srgbClr val="334155"/>
                 </a:solidFill>
@@ -2051,7 +2051,7 @@
               </a:rPr>
               <a:t>Runs with a persistent local data directory; deleting server/data resets to demo data. In the cloud — Atlas.</a:t>
             </a:r>
-            <a:endParaRPr lang="en-US" sz="1300" dirty="0"/>
+            <a:endParaRPr lang="en-US" sz="1200" dirty="0"/>
           </a:p>
         </p:txBody>
       </p:sp>
@@ -2063,8 +2063,8 @@
         </p:nvSpPr>
         <p:spPr>
           <a:xfrm>
-            <a:off x="502920" y="4562856"/>
-            <a:ext cx="256032" cy="256032"/>
+            <a:off x="502920" y="4032504"/>
+            <a:ext cx="237744" cy="237744"/>
           </a:xfrm>
           <a:prstGeom prst="ellipse">
             <a:avLst/>
@@ -2083,8 +2083,8 @@
         </p:nvSpPr>
         <p:spPr>
           <a:xfrm>
-            <a:off x="914400" y="4517136"/>
-            <a:ext cx="10607040" cy="365760"/>
+            <a:off x="914400" y="3995928"/>
+            <a:ext cx="10607040" cy="329184"/>
           </a:xfrm>
           <a:prstGeom prst="rect">
             <a:avLst/>
@@ -2100,7 +2100,7 @@
               <a:buNone/>
             </a:pPr>
             <a:r>
-              <a:rPr lang="en-US" sz="1600" b="1" dirty="0">
+              <a:rPr lang="en-US" sz="1500" b="1" dirty="0">
                 <a:solidFill>
                   <a:srgbClr val="0F172A"/>
                 </a:solidFill>
@@ -2110,7 +2110,7 @@
               </a:rPr>
               <a:t>Routing service (OSRM)</a:t>
             </a:r>
-            <a:endParaRPr lang="en-US" sz="1600" dirty="0"/>
+            <a:endParaRPr lang="en-US" sz="1500" dirty="0"/>
           </a:p>
         </p:txBody>
       </p:sp>
@@ -2122,8 +2122,8 @@
         </p:nvSpPr>
         <p:spPr>
           <a:xfrm>
-            <a:off x="914400" y="4864608"/>
-            <a:ext cx="10607040" cy="502920"/>
+            <a:off x="914400" y="4306824"/>
+            <a:ext cx="10607040" cy="457200"/>
           </a:xfrm>
           <a:prstGeom prst="rect">
             <a:avLst/>
@@ -2139,7 +2139,7 @@
               <a:buNone/>
             </a:pPr>
             <a:r>
-              <a:rPr lang="en-US" sz="1300" dirty="0">
+              <a:rPr lang="en-US" sz="1200" dirty="0">
                 <a:solidFill>
                   <a:srgbClr val="334155"/>
                 </a:solidFill>
@@ -2149,7 +2149,7 @@
               </a:rPr>
               <a:t>A free third-party dependency; on failure the UI shows an approximate straight line with a notice.</a:t>
             </a:r>
-            <a:endParaRPr lang="en-US" sz="1300" dirty="0"/>
+            <a:endParaRPr lang="en-US" sz="1200" dirty="0"/>
           </a:p>
         </p:txBody>
       </p:sp>
@@ -2161,8 +2161,8 @@
         </p:nvSpPr>
         <p:spPr>
           <a:xfrm>
-            <a:off x="502920" y="5504688"/>
-            <a:ext cx="256032" cy="256032"/>
+            <a:off x="502920" y="4828032"/>
+            <a:ext cx="237744" cy="237744"/>
           </a:xfrm>
           <a:prstGeom prst="ellipse">
             <a:avLst/>
@@ -2181,8 +2181,8 @@
         </p:nvSpPr>
         <p:spPr>
           <a:xfrm>
-            <a:off x="914400" y="5458968"/>
-            <a:ext cx="10607040" cy="365760"/>
+            <a:off x="914400" y="4791456"/>
+            <a:ext cx="10607040" cy="329184"/>
           </a:xfrm>
           <a:prstGeom prst="rect">
             <a:avLst/>
@@ -2198,7 +2198,7 @@
               <a:buNone/>
             </a:pPr>
             <a:r>
-              <a:rPr lang="en-US" sz="1600" b="1" dirty="0">
+              <a:rPr lang="en-US" sz="1500" b="1" dirty="0">
                 <a:solidFill>
                   <a:srgbClr val="0F172A"/>
                 </a:solidFill>
@@ -2208,7 +2208,7 @@
               </a:rPr>
               <a:t>Real SMS/Push are not sent</a:t>
             </a:r>
-            <a:endParaRPr lang="en-US" sz="1600" dirty="0"/>
+            <a:endParaRPr lang="en-US" sz="1500" dirty="0"/>
           </a:p>
         </p:txBody>
       </p:sp>
@@ -2220,8 +2220,8 @@
         </p:nvSpPr>
         <p:spPr>
           <a:xfrm>
-            <a:off x="914400" y="5806440"/>
-            <a:ext cx="10607040" cy="502920"/>
+            <a:off x="914400" y="5102352"/>
+            <a:ext cx="10607040" cy="457200"/>
           </a:xfrm>
           <a:prstGeom prst="rect">
             <a:avLst/>
@@ -2237,7 +2237,7 @@
               <a:buNone/>
             </a:pPr>
             <a:r>
-              <a:rPr lang="en-US" sz="1300" dirty="0">
+              <a:rPr lang="en-US" sz="1200" dirty="0">
                 <a:solidFill>
                   <a:srgbClr val="334155"/>
                 </a:solidFill>
@@ -2247,13 +2247,111 @@
               </a:rPr>
               <a:t>Simulated in the simulator and recorded in the alert log (real SMS is never free and is not required).</a:t>
             </a:r>
-            <a:endParaRPr lang="en-US" sz="1300" dirty="0"/>
-          </a:p>
-        </p:txBody>
-      </p:sp>
-      <p:sp>
-        <p:nvSpPr>
-          <p:cNvPr id="19" name="Text 17"/>
+            <a:endParaRPr lang="en-US" sz="1200" dirty="0"/>
+          </a:p>
+        </p:txBody>
+      </p:sp>
+      <p:sp>
+        <p:nvSpPr>
+          <p:cNvPr id="19" name="Shape 17"/>
+          <p:cNvSpPr/>
+          <p:nvPr/>
+        </p:nvSpPr>
+        <p:spPr>
+          <a:xfrm>
+            <a:off x="502920" y="5623560"/>
+            <a:ext cx="237744" cy="237744"/>
+          </a:xfrm>
+          <a:prstGeom prst="ellipse">
+            <a:avLst/>
+          </a:prstGeom>
+          <a:solidFill>
+            <a:srgbClr val="DC2626"/>
+          </a:solidFill>
+          <a:ln/>
+        </p:spPr>
+      </p:sp>
+      <p:sp>
+        <p:nvSpPr>
+          <p:cNvPr id="20" name="Text 18"/>
+          <p:cNvSpPr/>
+          <p:nvPr/>
+        </p:nvSpPr>
+        <p:spPr>
+          <a:xfrm>
+            <a:off x="914400" y="5586984"/>
+            <a:ext cx="10607040" cy="329184"/>
+          </a:xfrm>
+          <a:prstGeom prst="rect">
+            <a:avLst/>
+          </a:prstGeom>
+          <a:noFill/>
+          <a:ln/>
+        </p:spPr>
+        <p:txBody>
+          <a:bodyPr wrap="square" lIns="0" tIns="0" rIns="0" bIns="0" rtlCol="0" anchor="ctr"/>
+          <a:lstStyle/>
+          <a:p>
+            <a:pPr algn="l" indent="0" marL="0">
+              <a:buNone/>
+            </a:pPr>
+            <a:r>
+              <a:rPr lang="en-US" sz="1500" b="1" dirty="0">
+                <a:solidFill>
+                  <a:srgbClr val="0F172A"/>
+                </a:solidFill>
+                <a:latin typeface="Arial" pitchFamily="34" charset="0"/>
+                <a:ea typeface="Arial" pitchFamily="34" charset="-122"/>
+                <a:cs typeface="Arial" pitchFamily="34" charset="-120"/>
+              </a:rPr>
+              <a:t>Database network exposure</a:t>
+            </a:r>
+            <a:endParaRPr lang="en-US" sz="1500" dirty="0"/>
+          </a:p>
+        </p:txBody>
+      </p:sp>
+      <p:sp>
+        <p:nvSpPr>
+          <p:cNvPr id="21" name="Text 19"/>
+          <p:cNvSpPr/>
+          <p:nvPr/>
+        </p:nvSpPr>
+        <p:spPr>
+          <a:xfrm>
+            <a:off x="914400" y="5897880"/>
+            <a:ext cx="10607040" cy="457200"/>
+          </a:xfrm>
+          <a:prstGeom prst="rect">
+            <a:avLst/>
+          </a:prstGeom>
+          <a:noFill/>
+          <a:ln/>
+        </p:spPr>
+        <p:txBody>
+          <a:bodyPr wrap="square" lIns="0" tIns="0" rIns="0" bIns="0" rtlCol="0" anchor="ctr"/>
+          <a:lstStyle/>
+          <a:p>
+            <a:pPr algn="l" indent="0" marL="0">
+              <a:buNone/>
+            </a:pPr>
+            <a:r>
+              <a:rPr lang="en-US" sz="1200" dirty="0">
+                <a:solidFill>
+                  <a:srgbClr val="334155"/>
+                </a:solidFill>
+                <a:latin typeface="Calibri" pitchFamily="34" charset="0"/>
+                <a:ea typeface="Calibri" pitchFamily="34" charset="-122"/>
+                <a:cs typeface="Calibri" pitchFamily="34" charset="-120"/>
+              </a:rPr>
+              <a:t>The Atlas IP allow-list is 0.0.0.0/0 — Render Free has no static outbound IP. Access stays authenticated (user + password over TLS) on demo data only; VPC peering needs paid tiers.</a:t>
+            </a:r>
+            <a:endParaRPr lang="en-US" sz="1200" dirty="0"/>
+          </a:p>
+        </p:txBody>
+      </p:sp>
+      <p:sp>
+        <p:nvSpPr>
+          <p:cNvPr id="22" name="Text 20"/>
           <p:cNvSpPr/>
           <p:nvPr/>
         </p:nvSpPr>

</xml_diff>

<commit_message>
docs: project is live — record the cloud addresses
Deployed and verified end-to-end on free tiers ($0):
  site https://development-on-web-platforms-web.vercel.app  (Vercel)
  api  https://definet-api.onrender.com                     (Render + Atlas)

Production verification passed: health/stats/config, 50-device seed from
Atlas, admin JWT login, admin-only 401 without a token, phone masking on
public endpoints vs full numbers for admin, CORS preflight scoped to the
Vercel origin with credentials, registration + Hebrew field validation +
duplicate-DevEUI 409, full incident lifecycle (5 in-radius candidates,
2 LoRa downlinks, accept -> breadcrumb -> arrived -> resolved), the
state-machine 409 guard, and cross-site refresh-token rotation with a
replayed cookie correctly rejected (401).

Cloud URLs written into README and slide 1 of the deck. Author names remain
the only placeholder.

Co-Authored-By: Claude Fable 5 <noreply@anthropic.com>
</commit_message>
<xml_diff>
--- a/docs/DefiNet-Defense-Deck.pptx
+++ b/docs/DefiNet-Defense-Deck.pptx
@@ -1628,7 +1628,27 @@
                 <a:ea typeface="Calibri" pitchFamily="34" charset="-122"/>
                 <a:cs typeface="Calibri" pitchFamily="34" charset="-120"/>
               </a:rPr>
-              <a:t>Cloud:  ____________________________________</a:t>
+              <a:t>Cloud:  development-on-web-platforms-web.vercel.app</a:t>
+            </a:r>
+            <a:endParaRPr lang="en-US" sz="1500" dirty="0"/>
+          </a:p>
+          <a:p>
+            <a:pPr algn="l" indent="0" marL="0">
+              <a:spcAft>
+                <a:spcPts val="600"/>
+              </a:spcAft>
+              <a:buNone/>
+            </a:pPr>
+            <a:r>
+              <a:rPr lang="en-US" sz="1500" dirty="0">
+                <a:solidFill>
+                  <a:srgbClr val="059669"/>
+                </a:solidFill>
+                <a:latin typeface="Calibri" pitchFamily="34" charset="0"/>
+                <a:ea typeface="Calibri" pitchFamily="34" charset="-122"/>
+                <a:cs typeface="Calibri" pitchFamily="34" charset="-120"/>
+              </a:rPr>
+              <a:t>API:  definet-api.onrender.com</a:t>
             </a:r>
             <a:endParaRPr lang="en-US" sz="1500" dirty="0"/>
           </a:p>

</xml_diff>

<commit_message>
docs: final English defense deck for submission
All English text per the submission decision, plain punctuation throughout
(no em dashes or middle dots). Same five page structure: title with student
IDs, both repos, both cloud URLs, QR and admin demo login; summary and
technologies; known issues; architecture; code samples. Every slide was
rendered to an image and inspected before shipping.

Co-Authored-By: Claude Fable 5 <noreply@anthropic.com>
</commit_message>
<xml_diff>
--- a/docs/DefiNet-Defense-Deck.pptx
+++ b/docs/DefiNet-Defense-Deck.pptx
@@ -3158,7 +3158,7 @@
           </a:bodyPr>
           <a:lstStyle/>
           <a:p>
-            <a:pPr algn="l" rtl="1">
+            <a:pPr algn="l">
               <a:lnSpc>
                 <a:spcPct val="125000"/>
               </a:lnSpc>
@@ -3173,7 +3173,7 @@
                 </a:solidFill>
                 <a:latin typeface="Arial"/>
               </a:rPr>
-              <a:t>DefiNet   (דפי-נט)</a:t>
+              <a:t>DefiNet</a:t>
             </a:r>
           </a:p>
         </p:txBody>
@@ -3200,7 +3200,7 @@
           </a:bodyPr>
           <a:lstStyle/>
           <a:p>
-            <a:pPr algn="r" rtl="1">
+            <a:pPr algn="l">
               <a:lnSpc>
                 <a:spcPct val="125000"/>
               </a:lnSpc>
@@ -3215,7 +3215,7 @@
                 </a:solidFill>
                 <a:latin typeface="Arial"/>
               </a:rPr>
-              <a:t>פרויקט סיום - קורס פיתוח בפלטפורמת WEB, סמסטר ב' 2026</a:t>
+              <a:t>Final Project | Development on Web Platforms, Semester B 2026</a:t>
             </a:r>
           </a:p>
         </p:txBody>
@@ -3228,7 +3228,7 @@
         </p:nvSpPr>
         <p:spPr>
           <a:xfrm>
-            <a:off x="4617720" y="2148840"/>
+            <a:off x="731520" y="2148840"/>
             <a:ext cx="3657600" cy="868680"/>
           </a:xfrm>
           <a:prstGeom prst="roundRect">
@@ -3276,8 +3276,8 @@
         </p:nvSpPr>
         <p:spPr>
           <a:xfrm>
-            <a:off x="4846320" y="2267712"/>
-            <a:ext cx="3200400" cy="274320"/>
+            <a:off x="960120" y="2249424"/>
+            <a:ext cx="3200400" cy="219456"/>
           </a:xfrm>
           <a:prstGeom prst="rect">
             <a:avLst/>
@@ -3290,12 +3290,12 @@
           </a:bodyPr>
           <a:lstStyle/>
           <a:p>
-            <a:pPr algn="r" rtl="1">
+            <a:pPr algn="l">
               <a:lnSpc>
                 <a:spcPct val="125000"/>
               </a:lnSpc>
               <a:spcAft>
-                <a:spcPts val="200"/>
+                <a:spcPts val="0"/>
               </a:spcAft>
             </a:pPr>
             <a:r>
@@ -3305,7 +3305,7 @@
                 </a:solidFill>
                 <a:latin typeface="Arial"/>
               </a:rPr>
-              <a:t>מגיש</a:t>
+              <a:t>Submitted by</a:t>
             </a:r>
           </a:p>
         </p:txBody>
@@ -3318,8 +3318,8 @@
         </p:nvSpPr>
         <p:spPr>
           <a:xfrm>
-            <a:off x="4846320" y="2487168"/>
-            <a:ext cx="3200400" cy="292608"/>
+            <a:off x="960120" y="2468880"/>
+            <a:ext cx="3200400" cy="274320"/>
           </a:xfrm>
           <a:prstGeom prst="rect">
             <a:avLst/>
@@ -3332,7 +3332,7 @@
           </a:bodyPr>
           <a:lstStyle/>
           <a:p>
-            <a:pPr algn="r" rtl="1">
+            <a:pPr algn="l">
               <a:lnSpc>
                 <a:spcPct val="125000"/>
               </a:lnSpc>
@@ -3347,7 +3347,7 @@
                 </a:solidFill>
                 <a:latin typeface="Arial"/>
               </a:rPr>
-              <a:t>דולפין ורשב</a:t>
+              <a:t>Maayan Sandak</a:t>
             </a:r>
           </a:p>
         </p:txBody>
@@ -3360,8 +3360,8 @@
         </p:nvSpPr>
         <p:spPr>
           <a:xfrm>
-            <a:off x="4846320" y="2761488"/>
-            <a:ext cx="3200400" cy="237744"/>
+            <a:off x="960120" y="2743200"/>
+            <a:ext cx="3200400" cy="219456"/>
           </a:xfrm>
           <a:prstGeom prst="rect">
             <a:avLst/>
@@ -3374,7 +3374,7 @@
           </a:bodyPr>
           <a:lstStyle/>
           <a:p>
-            <a:pPr algn="l" rtl="0">
+            <a:pPr algn="l">
               <a:lnSpc>
                 <a:spcPct val="125000"/>
               </a:lnSpc>
@@ -3389,7 +3389,7 @@
                 </a:solidFill>
                 <a:latin typeface="Arial"/>
               </a:rPr>
-              <a:t>315853101</a:t>
+              <a:t>ID 207182585</a:t>
             </a:r>
           </a:p>
         </p:txBody>
@@ -3402,7 +3402,7 @@
         </p:nvSpPr>
         <p:spPr>
           <a:xfrm>
-            <a:off x="731520" y="2148840"/>
+            <a:off x="4617720" y="2148840"/>
             <a:ext cx="3657600" cy="868680"/>
           </a:xfrm>
           <a:prstGeom prst="roundRect">
@@ -3450,8 +3450,8 @@
         </p:nvSpPr>
         <p:spPr>
           <a:xfrm>
-            <a:off x="960120" y="2267712"/>
-            <a:ext cx="3200400" cy="274320"/>
+            <a:off x="4846320" y="2249424"/>
+            <a:ext cx="3200400" cy="219456"/>
           </a:xfrm>
           <a:prstGeom prst="rect">
             <a:avLst/>
@@ -3464,12 +3464,12 @@
           </a:bodyPr>
           <a:lstStyle/>
           <a:p>
-            <a:pPr algn="r" rtl="1">
+            <a:pPr algn="l">
               <a:lnSpc>
                 <a:spcPct val="125000"/>
               </a:lnSpc>
               <a:spcAft>
-                <a:spcPts val="200"/>
+                <a:spcPts val="0"/>
               </a:spcAft>
             </a:pPr>
             <a:r>
@@ -3479,7 +3479,7 @@
                 </a:solidFill>
                 <a:latin typeface="Arial"/>
               </a:rPr>
-              <a:t>מגישה</a:t>
+              <a:t>Submitted by</a:t>
             </a:r>
           </a:p>
         </p:txBody>
@@ -3492,8 +3492,8 @@
         </p:nvSpPr>
         <p:spPr>
           <a:xfrm>
-            <a:off x="960120" y="2487168"/>
-            <a:ext cx="3200400" cy="292608"/>
+            <a:off x="4846320" y="2468880"/>
+            <a:ext cx="3200400" cy="274320"/>
           </a:xfrm>
           <a:prstGeom prst="rect">
             <a:avLst/>
@@ -3506,7 +3506,7 @@
           </a:bodyPr>
           <a:lstStyle/>
           <a:p>
-            <a:pPr algn="r" rtl="1">
+            <a:pPr algn="l">
               <a:lnSpc>
                 <a:spcPct val="125000"/>
               </a:lnSpc>
@@ -3521,7 +3521,7 @@
                 </a:solidFill>
                 <a:latin typeface="Arial"/>
               </a:rPr>
-              <a:t>מעיין סנדק</a:t>
+              <a:t>Dolfin Varshev</a:t>
             </a:r>
           </a:p>
         </p:txBody>
@@ -3534,8 +3534,8 @@
         </p:nvSpPr>
         <p:spPr>
           <a:xfrm>
-            <a:off x="960120" y="2761488"/>
-            <a:ext cx="3200400" cy="237744"/>
+            <a:off x="4846320" y="2743200"/>
+            <a:ext cx="3200400" cy="219456"/>
           </a:xfrm>
           <a:prstGeom prst="rect">
             <a:avLst/>
@@ -3548,7 +3548,7 @@
           </a:bodyPr>
           <a:lstStyle/>
           <a:p>
-            <a:pPr algn="l" rtl="0">
+            <a:pPr algn="l">
               <a:lnSpc>
                 <a:spcPct val="125000"/>
               </a:lnSpc>
@@ -3563,7 +3563,7 @@
                 </a:solidFill>
                 <a:latin typeface="Arial"/>
               </a:rPr>
-              <a:t>207182585</a:t>
+              <a:t>ID 315853101</a:t>
             </a:r>
           </a:p>
         </p:txBody>
@@ -3624,7 +3624,7 @@
         </p:nvSpPr>
         <p:spPr>
           <a:xfrm>
-            <a:off x="8220456" y="3200400"/>
+            <a:off x="731520" y="3200400"/>
             <a:ext cx="54864" cy="566928"/>
           </a:xfrm>
           <a:prstGeom prst="rect">
@@ -3668,7 +3668,7 @@
         </p:nvSpPr>
         <p:spPr>
           <a:xfrm>
-            <a:off x="914400" y="3246120"/>
+            <a:off x="960120" y="3246120"/>
             <a:ext cx="7132320" cy="237744"/>
           </a:xfrm>
           <a:prstGeom prst="rect">
@@ -3682,7 +3682,7 @@
           </a:bodyPr>
           <a:lstStyle/>
           <a:p>
-            <a:pPr algn="r" rtl="1">
+            <a:pPr algn="l">
               <a:lnSpc>
                 <a:spcPct val="125000"/>
               </a:lnSpc>
@@ -3697,7 +3697,7 @@
                 </a:solidFill>
                 <a:latin typeface="Arial"/>
               </a:rPr>
-              <a:t>האתר בענן</a:t>
+              <a:t>Live Site</a:t>
             </a:r>
           </a:p>
         </p:txBody>
@@ -3710,7 +3710,7 @@
         </p:nvSpPr>
         <p:spPr>
           <a:xfrm>
-            <a:off x="914400" y="3493008"/>
+            <a:off x="960120" y="3493008"/>
             <a:ext cx="7132320" cy="237744"/>
           </a:xfrm>
           <a:prstGeom prst="rect">
@@ -3724,7 +3724,7 @@
           </a:bodyPr>
           <a:lstStyle/>
           <a:p>
-            <a:pPr algn="l" rtl="0">
+            <a:pPr algn="l">
               <a:lnSpc>
                 <a:spcPct val="125000"/>
               </a:lnSpc>
@@ -3800,7 +3800,7 @@
         </p:nvSpPr>
         <p:spPr>
           <a:xfrm>
-            <a:off x="8220456" y="3858768"/>
+            <a:off x="731520" y="3858768"/>
             <a:ext cx="54864" cy="566928"/>
           </a:xfrm>
           <a:prstGeom prst="rect">
@@ -3844,7 +3844,7 @@
         </p:nvSpPr>
         <p:spPr>
           <a:xfrm>
-            <a:off x="914400" y="3904487"/>
+            <a:off x="960120" y="3904487"/>
             <a:ext cx="7132320" cy="237744"/>
           </a:xfrm>
           <a:prstGeom prst="rect">
@@ -3858,7 +3858,7 @@
           </a:bodyPr>
           <a:lstStyle/>
           <a:p>
-            <a:pPr algn="r" rtl="1">
+            <a:pPr algn="l">
               <a:lnSpc>
                 <a:spcPct val="125000"/>
               </a:lnSpc>
@@ -3873,7 +3873,7 @@
                 </a:solidFill>
                 <a:latin typeface="Arial"/>
               </a:rPr>
-              <a:t>API בענן</a:t>
+              <a:t>Live API</a:t>
             </a:r>
           </a:p>
         </p:txBody>
@@ -3886,7 +3886,7 @@
         </p:nvSpPr>
         <p:spPr>
           <a:xfrm>
-            <a:off x="914400" y="4151376"/>
+            <a:off x="960120" y="4151376"/>
             <a:ext cx="7132320" cy="237744"/>
           </a:xfrm>
           <a:prstGeom prst="rect">
@@ -3900,7 +3900,7 @@
           </a:bodyPr>
           <a:lstStyle/>
           <a:p>
-            <a:pPr algn="l" rtl="0">
+            <a:pPr algn="l">
               <a:lnSpc>
                 <a:spcPct val="125000"/>
               </a:lnSpc>
@@ -3976,7 +3976,7 @@
         </p:nvSpPr>
         <p:spPr>
           <a:xfrm>
-            <a:off x="8220456" y="4517136"/>
+            <a:off x="731520" y="4517136"/>
             <a:ext cx="54864" cy="566928"/>
           </a:xfrm>
           <a:prstGeom prst="rect">
@@ -4020,7 +4020,7 @@
         </p:nvSpPr>
         <p:spPr>
           <a:xfrm>
-            <a:off x="914400" y="4562855"/>
+            <a:off x="960120" y="4562855"/>
             <a:ext cx="7132320" cy="237744"/>
           </a:xfrm>
           <a:prstGeom prst="rect">
@@ -4034,7 +4034,7 @@
           </a:bodyPr>
           <a:lstStyle/>
           <a:p>
-            <a:pPr algn="r" rtl="1">
+            <a:pPr algn="l">
               <a:lnSpc>
                 <a:spcPct val="125000"/>
               </a:lnSpc>
@@ -4049,7 +4049,7 @@
                 </a:solidFill>
                 <a:latin typeface="Arial"/>
               </a:rPr>
-              <a:t>GitHub - מעיין סנדק</a:t>
+              <a:t>GitHub, Maayan Sandak</a:t>
             </a:r>
           </a:p>
         </p:txBody>
@@ -4062,7 +4062,7 @@
         </p:nvSpPr>
         <p:spPr>
           <a:xfrm>
-            <a:off x="914400" y="4809744"/>
+            <a:off x="960120" y="4809744"/>
             <a:ext cx="7132320" cy="237744"/>
           </a:xfrm>
           <a:prstGeom prst="rect">
@@ -4076,7 +4076,7 @@
           </a:bodyPr>
           <a:lstStyle/>
           <a:p>
-            <a:pPr algn="l" rtl="0">
+            <a:pPr algn="l">
               <a:lnSpc>
                 <a:spcPct val="125000"/>
               </a:lnSpc>
@@ -4152,7 +4152,7 @@
         </p:nvSpPr>
         <p:spPr>
           <a:xfrm>
-            <a:off x="8220456" y="5175503"/>
+            <a:off x="731520" y="5175503"/>
             <a:ext cx="54864" cy="566928"/>
           </a:xfrm>
           <a:prstGeom prst="rect">
@@ -4196,7 +4196,7 @@
         </p:nvSpPr>
         <p:spPr>
           <a:xfrm>
-            <a:off x="914400" y="5221223"/>
+            <a:off x="960120" y="5221223"/>
             <a:ext cx="7132320" cy="237744"/>
           </a:xfrm>
           <a:prstGeom prst="rect">
@@ -4210,7 +4210,7 @@
           </a:bodyPr>
           <a:lstStyle/>
           <a:p>
-            <a:pPr algn="r" rtl="1">
+            <a:pPr algn="l">
               <a:lnSpc>
                 <a:spcPct val="125000"/>
               </a:lnSpc>
@@ -4225,7 +4225,7 @@
                 </a:solidFill>
                 <a:latin typeface="Arial"/>
               </a:rPr>
-              <a:t>GitHub - דולפין ורשב</a:t>
+              <a:t>GitHub, Dolfin Varshev</a:t>
             </a:r>
           </a:p>
         </p:txBody>
@@ -4238,7 +4238,7 @@
         </p:nvSpPr>
         <p:spPr>
           <a:xfrm>
-            <a:off x="914400" y="5468112"/>
+            <a:off x="960120" y="5468112"/>
             <a:ext cx="7132320" cy="237744"/>
           </a:xfrm>
           <a:prstGeom prst="rect">
@@ -4252,7 +4252,7 @@
           </a:bodyPr>
           <a:lstStyle/>
           <a:p>
-            <a:pPr algn="l" rtl="0">
+            <a:pPr algn="l">
               <a:lnSpc>
                 <a:spcPct val="125000"/>
               </a:lnSpc>
@@ -4328,7 +4328,7 @@
         </p:nvSpPr>
         <p:spPr>
           <a:xfrm>
-            <a:off x="914400" y="5998463"/>
+            <a:off x="960120" y="5998463"/>
             <a:ext cx="7178040" cy="274320"/>
           </a:xfrm>
           <a:prstGeom prst="rect">
@@ -4342,7 +4342,7 @@
           </a:bodyPr>
           <a:lstStyle/>
           <a:p>
-            <a:pPr algn="r" rtl="1">
+            <a:pPr algn="l">
               <a:lnSpc>
                 <a:spcPct val="125000"/>
               </a:lnSpc>
@@ -4357,7 +4357,7 @@
                 </a:solidFill>
                 <a:latin typeface="Arial"/>
               </a:rPr>
-              <a:t>כניסת מנהל להדגמה:  micha / 1234   (מוצג גם במסך ההתחברות, לפי דרישת הפרויקט)</a:t>
+              <a:t>Admin demo login: micha / 1234 (shown on the login screen, as the project spec requires)</a:t>
             </a:r>
           </a:p>
         </p:txBody>
@@ -4456,7 +4456,7 @@
           </a:bodyPr>
           <a:lstStyle/>
           <a:p>
-            <a:pPr algn="ctr" rtl="0">
+            <a:pPr algn="ctr">
               <a:lnSpc>
                 <a:spcPct val="125000"/>
               </a:lnSpc>
@@ -4484,8 +4484,8 @@
         </p:nvSpPr>
         <p:spPr>
           <a:xfrm>
-            <a:off x="9052560" y="4983480"/>
-            <a:ext cx="2514600" cy="1188720"/>
+            <a:off x="9052560" y="4937760"/>
+            <a:ext cx="2514600" cy="1280160"/>
           </a:xfrm>
           <a:prstGeom prst="rect">
             <a:avLst/>
@@ -4498,7 +4498,7 @@
           </a:bodyPr>
           <a:lstStyle/>
           <a:p>
-            <a:pPr algn="r" rtl="1">
+            <a:pPr algn="l">
               <a:lnSpc>
                 <a:spcPct val="130000"/>
               </a:lnSpc>
@@ -4507,13 +4507,13 @@
               </a:spcAft>
             </a:pPr>
             <a:r>
-              <a:rPr sz="1100" b="0">
+              <a:rPr sz="1050" b="0">
                 <a:solidFill>
                   <a:srgbClr val="5A6673"/>
                 </a:solidFill>
                 <a:latin typeface="Arial"/>
               </a:rPr>
-              <a:t>מערכת WEB למיפוי דפיברילטורים נייחים וניידים, ניהול מתנדבים וסימולציית קריאת מצוקה בזמן אמת.</a:t>
+              <a:t>A web system that maps stationary and mobile defibrillators, manages volunteers and runs a real time distress call simulation.</a:t>
             </a:r>
           </a:p>
         </p:txBody>
@@ -4526,7 +4526,7 @@
         </p:nvSpPr>
         <p:spPr>
           <a:xfrm>
-            <a:off x="548640" y="6400800"/>
+            <a:off x="548640" y="6446520"/>
             <a:ext cx="3657600" cy="274320"/>
           </a:xfrm>
           <a:prstGeom prst="rect">
@@ -4540,7 +4540,7 @@
           </a:bodyPr>
           <a:lstStyle/>
           <a:p>
-            <a:pPr algn="l" rtl="0">
+            <a:pPr algn="l">
               <a:lnSpc>
                 <a:spcPct val="125000"/>
               </a:lnSpc>
@@ -4555,7 +4555,7 @@
                 </a:solidFill>
                 <a:latin typeface="Arial"/>
               </a:rPr>
-              <a:t>DefiNet - WEB 2026</a:t>
+              <a:t>DefiNet | WEB 2026</a:t>
             </a:r>
           </a:p>
         </p:txBody>
@@ -4568,7 +4568,7 @@
         </p:nvSpPr>
         <p:spPr>
           <a:xfrm>
-            <a:off x="10728655" y="6400800"/>
+            <a:off x="10728655" y="6446520"/>
             <a:ext cx="914400" cy="274320"/>
           </a:xfrm>
           <a:prstGeom prst="rect">
@@ -4582,7 +4582,7 @@
           </a:bodyPr>
           <a:lstStyle/>
           <a:p>
-            <a:pPr algn="r" rtl="0">
+            <a:pPr algn="r">
               <a:lnSpc>
                 <a:spcPct val="125000"/>
               </a:lnSpc>
@@ -4686,7 +4686,7 @@
           </a:bodyPr>
           <a:lstStyle/>
           <a:p>
-            <a:pPr algn="r" rtl="1">
+            <a:pPr algn="l">
               <a:lnSpc>
                 <a:spcPct val="125000"/>
               </a:lnSpc>
@@ -4701,7 +4701,7 @@
                 </a:solidFill>
                 <a:latin typeface="Arial"/>
               </a:rPr>
-              <a:t>תקציר הפרויקט והטכנולוגיות</a:t>
+              <a:t>Project Summary and Technologies</a:t>
             </a:r>
           </a:p>
         </p:txBody>
@@ -4776,12 +4776,12 @@
           </a:bodyPr>
           <a:lstStyle/>
           <a:p>
-            <a:pPr algn="r" rtl="1">
+            <a:pPr algn="l">
               <a:lnSpc>
                 <a:spcPct val="125000"/>
               </a:lnSpc>
               <a:spcAft>
-                <a:spcPts val="1000"/>
+                <a:spcPts val="0"/>
               </a:spcAft>
             </a:pPr>
             <a:r>
@@ -4791,7 +4791,7 @@
                 </a:solidFill>
                 <a:latin typeface="Arial"/>
               </a:rPr>
-              <a:t>מה המערכת עושה?</a:t>
+              <a:t>What does the system do?</a:t>
             </a:r>
           </a:p>
         </p:txBody>
@@ -4804,8 +4804,8 @@
         </p:nvSpPr>
         <p:spPr>
           <a:xfrm>
-            <a:off x="1051560" y="2103120"/>
-            <a:ext cx="4754880" cy="2651760"/>
+            <a:off x="960120" y="2103120"/>
+            <a:ext cx="4937760" cy="2651760"/>
           </a:xfrm>
           <a:prstGeom prst="rect">
             <a:avLst/>
@@ -4818,79 +4818,79 @@
           </a:bodyPr>
           <a:lstStyle/>
           <a:p>
-            <a:pPr algn="r" rtl="1">
+            <a:pPr algn="l">
               <a:lnSpc>
                 <a:spcPct val="130000"/>
               </a:lnSpc>
               <a:spcAft>
-                <a:spcPts val="1200"/>
-              </a:spcAft>
-            </a:pPr>
-            <a:r>
-              <a:rPr sz="1250" b="0">
+                <a:spcPts val="1000"/>
+              </a:spcAft>
+            </a:pPr>
+            <a:r>
+              <a:rPr sz="1200" b="0">
                 <a:solidFill>
                   <a:srgbClr val="222B35"/>
                 </a:solidFill>
                 <a:latin typeface="Arial"/>
               </a:rPr>
-              <a:t>• ממפה דפיברילטורים נייחים וניידים ומציגה מיקום, מצב סוללה וזמן שידור אחרון.</a:t>
-            </a:r>
-          </a:p>
-          <a:p>
-            <a:pPr algn="r" rtl="1">
+              <a:t>* Maps stationary and mobile defibrillators with location, battery level and last transmission time.</a:t>
+            </a:r>
+          </a:p>
+          <a:p>
+            <a:pPr algn="l">
               <a:lnSpc>
                 <a:spcPct val="130000"/>
               </a:lnSpc>
               <a:spcAft>
-                <a:spcPts val="1200"/>
-              </a:spcAft>
-            </a:pPr>
-            <a:r>
-              <a:rPr sz="1250" b="0">
+                <a:spcPts val="1000"/>
+              </a:spcAft>
+            </a:pPr>
+            <a:r>
+              <a:rPr sz="1200" b="0">
                 <a:solidFill>
                   <a:srgbClr val="222B35"/>
                 </a:solidFill>
                 <a:latin typeface="Arial"/>
               </a:rPr>
-              <a:t>• מדמה קריאת מצוקה: איתור מועמדים לפי רדיוס ומרחק, בחירת מתנדב ומעקב אחר ההגעה.</a:t>
-            </a:r>
-          </a:p>
-          <a:p>
-            <a:pPr algn="r" rtl="1">
+              <a:t>* Simulates a distress call: finds candidates by radius and distance, assigns a volunteer and tracks the arrival.</a:t>
+            </a:r>
+          </a:p>
+          <a:p>
+            <a:pPr algn="l">
               <a:lnSpc>
                 <a:spcPct val="130000"/>
               </a:lnSpc>
               <a:spcAft>
-                <a:spcPts val="1200"/>
-              </a:spcAft>
-            </a:pPr>
-            <a:r>
-              <a:rPr sz="1250" b="0">
+                <a:spcPts val="1000"/>
+              </a:spcAft>
+            </a:pPr>
+            <a:r>
+              <a:rPr sz="1200" b="0">
                 <a:solidFill>
                   <a:srgbClr val="222B35"/>
                 </a:solidFill>
                 <a:latin typeface="Arial"/>
               </a:rPr>
-              <a:t>• מציגה מסלול רכיבה אל האירוע ומדגימה התרעה בערוצים סלולריים ו-LoRa.</a:t>
-            </a:r>
-          </a:p>
-          <a:p>
-            <a:pPr algn="r" rtl="1">
+              <a:t>* Draws a real bike route to the event and demonstrates alerts over both cellular and LoRa channels.</a:t>
+            </a:r>
+          </a:p>
+          <a:p>
+            <a:pPr algn="l">
               <a:lnSpc>
                 <a:spcPct val="130000"/>
               </a:lnSpc>
               <a:spcAft>
-                <a:spcPts val="1200"/>
-              </a:spcAft>
-            </a:pPr>
-            <a:r>
-              <a:rPr sz="1250" b="0">
+                <a:spcPts val="1000"/>
+              </a:spcAft>
+            </a:pPr>
+            <a:r>
+              <a:rPr sz="1200" b="0">
                 <a:solidFill>
                   <a:srgbClr val="222B35"/>
                 </a:solidFill>
                 <a:latin typeface="Arial"/>
               </a:rPr>
-              <a:t>• כוללת אזור Admin לניהול רישום, תוכן שיווקי, הגדרות, התראות ונתוני הדגמה.</a:t>
+              <a:t>* Includes an Admin area for registrations, marketing content, settings, alerts and demo data.</a:t>
             </a:r>
           </a:p>
         </p:txBody>
@@ -4917,7 +4917,7 @@
           </a:bodyPr>
           <a:lstStyle/>
           <a:p>
-            <a:pPr algn="r" rtl="1">
+            <a:pPr algn="l">
               <a:lnSpc>
                 <a:spcPct val="125000"/>
               </a:lnSpc>
@@ -4932,7 +4932,7 @@
                 </a:solidFill>
                 <a:latin typeface="Arial"/>
               </a:rPr>
-              <a:t>תוספות בפרויקט</a:t>
+              <a:t>Extras built into the project</a:t>
             </a:r>
           </a:p>
         </p:txBody>
@@ -4959,7 +4959,7 @@
           </a:bodyPr>
           <a:lstStyle/>
           <a:p>
-            <a:pPr algn="ctr" rtl="0">
+            <a:pPr algn="ctr">
               <a:lnSpc>
                 <a:spcPct val="125000"/>
               </a:lnSpc>
@@ -4974,11 +4974,11 @@
                 </a:solidFill>
                 <a:latin typeface="Arial"/>
               </a:rPr>
-              <a:t>RTL Hebrew  |  WEB Simulator  |  Leaflet Map</a:t>
-            </a:r>
-          </a:p>
-          <a:p>
-            <a:pPr algn="ctr" rtl="0">
+              <a:t>Hebrew RTL UI  |  Web Simulator  |  Leaflet Map</a:t>
+            </a:r>
+          </a:p>
+          <a:p>
+            <a:pPr algn="ctr">
               <a:lnSpc>
                 <a:spcPct val="125000"/>
               </a:lnSpc>
@@ -4993,7 +4993,7 @@
                 </a:solidFill>
                 <a:latin typeface="Arial"/>
               </a:rPr>
-              <a:t>JWT + Refresh  |  Admin CMS  |  Analytics + CPR</a:t>
+              <a:t>JWT + Refresh  |  Admin CMS  |  Analytics + CPR Guide</a:t>
             </a:r>
           </a:p>
         </p:txBody>
@@ -5068,12 +5068,12 @@
           </a:bodyPr>
           <a:lstStyle/>
           <a:p>
-            <a:pPr algn="r" rtl="1">
+            <a:pPr algn="l">
               <a:lnSpc>
                 <a:spcPct val="125000"/>
               </a:lnSpc>
               <a:spcAft>
-                <a:spcPts val="1000"/>
+                <a:spcPts val="0"/>
               </a:spcAft>
             </a:pPr>
             <a:r>
@@ -5083,7 +5083,7 @@
                 </a:solidFill>
                 <a:latin typeface="Arial"/>
               </a:rPr>
-              <a:t>טכנולוגיות מרכזיות</a:t>
+              <a:t>Core technologies</a:t>
             </a:r>
           </a:p>
         </p:txBody>
@@ -5110,117 +5110,117 @@
           </a:bodyPr>
           <a:lstStyle/>
           <a:p>
-            <a:pPr algn="r" rtl="1">
+            <a:pPr algn="l">
               <a:lnSpc>
                 <a:spcPct val="130000"/>
               </a:lnSpc>
               <a:spcAft>
-                <a:spcPts val="1100"/>
-              </a:spcAft>
-            </a:pPr>
-            <a:r>
-              <a:rPr sz="1250" b="0">
+                <a:spcPts val="1000"/>
+              </a:spcAft>
+            </a:pPr>
+            <a:r>
+              <a:rPr sz="1200" b="0">
                 <a:solidFill>
                   <a:srgbClr val="222B35"/>
                 </a:solidFill>
                 <a:latin typeface="Arial"/>
               </a:rPr>
-              <a:t>• Frontend: Next.js 15, React, Tailwind CSS</a:t>
-            </a:r>
-          </a:p>
-          <a:p>
-            <a:pPr algn="r" rtl="1">
+              <a:t>* Frontend: Next.js 15, React, Tailwind CSS</a:t>
+            </a:r>
+          </a:p>
+          <a:p>
+            <a:pPr algn="l">
               <a:lnSpc>
                 <a:spcPct val="130000"/>
               </a:lnSpc>
               <a:spcAft>
-                <a:spcPts val="1100"/>
-              </a:spcAft>
-            </a:pPr>
-            <a:r>
-              <a:rPr sz="1250" b="0">
+                <a:spcPts val="1000"/>
+              </a:spcAft>
+            </a:pPr>
+            <a:r>
+              <a:rPr sz="1200" b="0">
                 <a:solidFill>
                   <a:srgbClr val="222B35"/>
                 </a:solidFill>
                 <a:latin typeface="Arial"/>
               </a:rPr>
-              <a:t>• Backend: Express REST API</a:t>
-            </a:r>
-          </a:p>
-          <a:p>
-            <a:pPr algn="r" rtl="1">
+              <a:t>* Backend: Express REST API</a:t>
+            </a:r>
+          </a:p>
+          <a:p>
+            <a:pPr algn="l">
               <a:lnSpc>
                 <a:spcPct val="130000"/>
               </a:lnSpc>
               <a:spcAft>
-                <a:spcPts val="1100"/>
-              </a:spcAft>
-            </a:pPr>
-            <a:r>
-              <a:rPr sz="1250" b="0">
+                <a:spcPts val="1000"/>
+              </a:spcAft>
+            </a:pPr>
+            <a:r>
+              <a:rPr sz="1200" b="0">
                 <a:solidFill>
                   <a:srgbClr val="222B35"/>
                 </a:solidFill>
                 <a:latin typeface="Arial"/>
               </a:rPr>
-              <a:t>• SQL: SQLite - משתמשים, מכשירים, Admin ו-Refresh Tokens</a:t>
-            </a:r>
-          </a:p>
-          <a:p>
-            <a:pPr algn="r" rtl="1">
+              <a:t>* SQL: SQLite for users, devices, admins and refresh tokens</a:t>
+            </a:r>
+          </a:p>
+          <a:p>
+            <a:pPr algn="l">
               <a:lnSpc>
                 <a:spcPct val="130000"/>
               </a:lnSpc>
               <a:spcAft>
-                <a:spcPts val="1100"/>
-              </a:spcAft>
-            </a:pPr>
-            <a:r>
-              <a:rPr sz="1250" b="0">
+                <a:spcPts val="1000"/>
+              </a:spcAft>
+            </a:pPr>
+            <a:r>
+              <a:rPr sz="1200" b="0">
                 <a:solidFill>
                   <a:srgbClr val="222B35"/>
                 </a:solidFill>
                 <a:latin typeface="Arial"/>
               </a:rPr>
-              <a:t>• NoSQL: MongoDB - אירועים, CMS, Telemetry, Alerts ו-Config</a:t>
-            </a:r>
-          </a:p>
-          <a:p>
-            <a:pPr algn="r" rtl="1">
+              <a:t>* NoSQL: MongoDB for incidents, CMS, telemetry, alerts and config</a:t>
+            </a:r>
+          </a:p>
+          <a:p>
+            <a:pPr algn="l">
               <a:lnSpc>
                 <a:spcPct val="130000"/>
               </a:lnSpc>
               <a:spcAft>
-                <a:spcPts val="1100"/>
-              </a:spcAft>
-            </a:pPr>
-            <a:r>
-              <a:rPr sz="1250" b="0">
+                <a:spcPts val="1000"/>
+              </a:spcAft>
+            </a:pPr>
+            <a:r>
+              <a:rPr sz="1200" b="0">
                 <a:solidFill>
                   <a:srgbClr val="222B35"/>
                 </a:solidFill>
                 <a:latin typeface="Arial"/>
               </a:rPr>
-              <a:t>• Authentication: JWT Access Token + Refresh Token Rotation</a:t>
-            </a:r>
-          </a:p>
-          <a:p>
-            <a:pPr algn="r" rtl="1">
+              <a:t>* Authentication: JWT access token plus refresh token rotation</a:t>
+            </a:r>
+          </a:p>
+          <a:p>
+            <a:pPr algn="l">
               <a:lnSpc>
                 <a:spcPct val="130000"/>
               </a:lnSpc>
               <a:spcAft>
-                <a:spcPts val="1100"/>
-              </a:spcAft>
-            </a:pPr>
-            <a:r>
-              <a:rPr sz="1250" b="0">
+                <a:spcPts val="1000"/>
+              </a:spcAft>
+            </a:pPr>
+            <a:r>
+              <a:rPr sz="1200" b="0">
                 <a:solidFill>
                   <a:srgbClr val="222B35"/>
                 </a:solidFill>
                 <a:latin typeface="Arial"/>
               </a:rPr>
-              <a:t>• Maps and Routing: Leaflet + שירות Routing חיצוני</a:t>
+              <a:t>* Maps and routing: Leaflet plus an external bike routing service</a:t>
             </a:r>
           </a:p>
         </p:txBody>
@@ -5233,8 +5233,8 @@
         </p:nvSpPr>
         <p:spPr>
           <a:xfrm>
-            <a:off x="6629400" y="5230368"/>
-            <a:ext cx="4617720" cy="411480"/>
+            <a:off x="6629400" y="5175504"/>
+            <a:ext cx="4617720" cy="457200"/>
           </a:xfrm>
           <a:prstGeom prst="roundRect">
             <a:avLst>
@@ -5281,8 +5281,8 @@
         </p:nvSpPr>
         <p:spPr>
           <a:xfrm>
-            <a:off x="6812280" y="5330952"/>
-            <a:ext cx="4251960" cy="256032"/>
+            <a:off x="6812280" y="5285232"/>
+            <a:ext cx="4251960" cy="274320"/>
           </a:xfrm>
           <a:prstGeom prst="rect">
             <a:avLst/>
@@ -5295,7 +5295,7 @@
           </a:bodyPr>
           <a:lstStyle/>
           <a:p>
-            <a:pPr algn="r" rtl="1">
+            <a:pPr algn="l">
               <a:lnSpc>
                 <a:spcPct val="125000"/>
               </a:lnSpc>
@@ -5310,7 +5310,7 @@
                 </a:solidFill>
                 <a:latin typeface="Arial"/>
               </a:rPr>
-              <a:t>המערכת בנויה בשני שרתים ושני סוגי בסיסי נתונים, בהתאם לדרישות הפרויקט.</a:t>
+              <a:t>Two servers and two database types, as the spec requires.</a:t>
             </a:r>
           </a:p>
         </p:txBody>
@@ -5323,7 +5323,7 @@
         </p:nvSpPr>
         <p:spPr>
           <a:xfrm>
-            <a:off x="548640" y="6400800"/>
+            <a:off x="548640" y="6446520"/>
             <a:ext cx="3657600" cy="274320"/>
           </a:xfrm>
           <a:prstGeom prst="rect">
@@ -5337,7 +5337,7 @@
           </a:bodyPr>
           <a:lstStyle/>
           <a:p>
-            <a:pPr algn="l" rtl="0">
+            <a:pPr algn="l">
               <a:lnSpc>
                 <a:spcPct val="125000"/>
               </a:lnSpc>
@@ -5352,7 +5352,7 @@
                 </a:solidFill>
                 <a:latin typeface="Arial"/>
               </a:rPr>
-              <a:t>DefiNet - WEB 2026</a:t>
+              <a:t>DefiNet | WEB 2026</a:t>
             </a:r>
           </a:p>
         </p:txBody>
@@ -5365,7 +5365,7 @@
         </p:nvSpPr>
         <p:spPr>
           <a:xfrm>
-            <a:off x="10728655" y="6400800"/>
+            <a:off x="10728655" y="6446520"/>
             <a:ext cx="914400" cy="274320"/>
           </a:xfrm>
           <a:prstGeom prst="rect">
@@ -5379,7 +5379,7 @@
           </a:bodyPr>
           <a:lstStyle/>
           <a:p>
-            <a:pPr algn="r" rtl="0">
+            <a:pPr algn="r">
               <a:lnSpc>
                 <a:spcPct val="125000"/>
               </a:lnSpc>
@@ -5483,7 +5483,7 @@
           </a:bodyPr>
           <a:lstStyle/>
           <a:p>
-            <a:pPr algn="r" rtl="1">
+            <a:pPr algn="l">
               <a:lnSpc>
                 <a:spcPct val="125000"/>
               </a:lnSpc>
@@ -5498,7 +5498,7 @@
                 </a:solidFill>
                 <a:latin typeface="Arial"/>
               </a:rPr>
-              <a:t>מגבלות ידועות / Known Issues</a:t>
+              <a:t>Known Issues</a:t>
             </a:r>
           </a:p>
         </p:txBody>
@@ -5573,12 +5573,12 @@
           </a:bodyPr>
           <a:lstStyle/>
           <a:p>
-            <a:pPr algn="r" rtl="1">
+            <a:pPr algn="l">
               <a:lnSpc>
                 <a:spcPct val="125000"/>
               </a:lnSpc>
               <a:spcAft>
-                <a:spcPts val="1000"/>
+                <a:spcPts val="0"/>
               </a:spcAft>
             </a:pPr>
             <a:r>
@@ -5588,7 +5588,7 @@
                 </a:solidFill>
                 <a:latin typeface="Arial"/>
               </a:rPr>
-              <a:t>סביבת הענן</a:t>
+              <a:t>Cloud environment</a:t>
             </a:r>
           </a:p>
         </p:txBody>
@@ -5602,7 +5602,7 @@
         <p:spPr>
           <a:xfrm>
             <a:off x="960120" y="2103120"/>
-            <a:ext cx="4937760" cy="3566160"/>
+            <a:ext cx="4937760" cy="3383280"/>
           </a:xfrm>
           <a:prstGeom prst="rect">
             <a:avLst/>
@@ -5615,60 +5615,60 @@
           </a:bodyPr>
           <a:lstStyle/>
           <a:p>
-            <a:pPr algn="r" rtl="1">
+            <a:pPr algn="l">
               <a:lnSpc>
                 <a:spcPct val="132000"/>
               </a:lnSpc>
               <a:spcAft>
-                <a:spcPts val="1400"/>
-              </a:spcAft>
-            </a:pPr>
-            <a:r>
-              <a:rPr sz="1250" b="0">
+                <a:spcPts val="1200"/>
+              </a:spcAft>
+            </a:pPr>
+            <a:r>
+              <a:rPr sz="1200" b="0">
                 <a:solidFill>
                   <a:srgbClr val="222B35"/>
                 </a:solidFill>
                 <a:latin typeface="Arial"/>
               </a:rPr>
-              <a:t>• Render Free: לאחר זמן ללא פעילות השרת עשוי להיכנס למצב שינה, ולכן הבקשה הראשונה יכולה להתעכב.</a:t>
-            </a:r>
-          </a:p>
-          <a:p>
-            <a:pPr algn="r" rtl="1">
+              <a:t>* Render free tier: after a period with no traffic the server goes to sleep, so the first request can be delayed.</a:t>
+            </a:r>
+          </a:p>
+          <a:p>
+            <a:pPr algn="l">
               <a:lnSpc>
                 <a:spcPct val="132000"/>
               </a:lnSpc>
               <a:spcAft>
-                <a:spcPts val="1400"/>
-              </a:spcAft>
-            </a:pPr>
-            <a:r>
-              <a:rPr sz="1250" b="0">
+                <a:spcPts val="1200"/>
+              </a:spcAft>
+            </a:pPr>
+            <a:r>
+              <a:rPr sz="1200" b="0">
                 <a:solidFill>
                   <a:srgbClr val="222B35"/>
                 </a:solidFill>
                 <a:latin typeface="Arial"/>
               </a:rPr>
-              <a:t>• SQLite בענן: בשכבה החינמית הנתונים אינם נשמרים לצמיתות בין Deployments; בעת אתחול ריק נטענים מחדש נתוני הדמו.</a:t>
-            </a:r>
-          </a:p>
-          <a:p>
-            <a:pPr algn="r" rtl="1">
+              <a:t>* SQLite in the cloud: on the free tier the data does not persist between deployments; an empty boot reloads the demo data.</a:t>
+            </a:r>
+          </a:p>
+          <a:p>
+            <a:pPr algn="l">
               <a:lnSpc>
                 <a:spcPct val="132000"/>
               </a:lnSpc>
               <a:spcAft>
-                <a:spcPts val="1400"/>
-              </a:spcAft>
-            </a:pPr>
-            <a:r>
-              <a:rPr sz="1250" b="0">
+                <a:spcPts val="1200"/>
+              </a:spcAft>
+            </a:pPr>
+            <a:r>
+              <a:rPr sz="1200" b="0">
                 <a:solidFill>
                   <a:srgbClr val="222B35"/>
                 </a:solidFill>
                 <a:latin typeface="Arial"/>
               </a:rPr>
-              <a:t>• MongoDB Atlas: בשל היעדר IP קבוע יוצא ב-Render Free, הגישה לרשת רחבה יותר ומוגנת באמצעות Authentication ו-TLS.</a:t>
+              <a:t>* MongoDB Atlas: Render's free tier has no fixed outbound IP, so network access is wide and protected by authentication and TLS.</a:t>
             </a:r>
           </a:p>
         </p:txBody>
@@ -5743,12 +5743,12 @@
           </a:bodyPr>
           <a:lstStyle/>
           <a:p>
-            <a:pPr algn="r" rtl="1">
+            <a:pPr algn="l">
               <a:lnSpc>
                 <a:spcPct val="125000"/>
               </a:lnSpc>
               <a:spcAft>
-                <a:spcPts val="1000"/>
+                <a:spcPts val="0"/>
               </a:spcAft>
             </a:pPr>
             <a:r>
@@ -5758,7 +5758,7 @@
                 </a:solidFill>
                 <a:latin typeface="Arial"/>
               </a:rPr>
-              <a:t>שירותים חיצוניים וסימולציה</a:t>
+              <a:t>External services and simulation</a:t>
             </a:r>
           </a:p>
         </p:txBody>
@@ -5772,7 +5772,7 @@
         <p:spPr>
           <a:xfrm>
             <a:off x="6629400" y="2103120"/>
-            <a:ext cx="4617720" cy="2743200"/>
+            <a:ext cx="4617720" cy="2468880"/>
           </a:xfrm>
           <a:prstGeom prst="rect">
             <a:avLst/>
@@ -5785,60 +5785,60 @@
           </a:bodyPr>
           <a:lstStyle/>
           <a:p>
-            <a:pPr algn="r" rtl="1">
+            <a:pPr algn="l">
               <a:lnSpc>
                 <a:spcPct val="132000"/>
               </a:lnSpc>
               <a:spcAft>
-                <a:spcPts val="1400"/>
-              </a:spcAft>
-            </a:pPr>
-            <a:r>
-              <a:rPr sz="1250" b="0">
+                <a:spcPts val="1200"/>
+              </a:spcAft>
+            </a:pPr>
+            <a:r>
+              <a:rPr sz="1200" b="0">
                 <a:solidFill>
                   <a:srgbClr val="222B35"/>
                 </a:solidFill>
                 <a:latin typeface="Arial"/>
               </a:rPr>
-              <a:t>• שירות מסלולי האופניים הוא שירות ציבורי חיצוני, ולכן זמינות המסלול תלויה בזמינות השירות.</a:t>
-            </a:r>
-          </a:p>
-          <a:p>
-            <a:pPr algn="r" rtl="1">
+              <a:t>* The bike route service is a public external service, so route availability depends on it.</a:t>
+            </a:r>
+          </a:p>
+          <a:p>
+            <a:pPr algn="l">
               <a:lnSpc>
                 <a:spcPct val="132000"/>
               </a:lnSpc>
               <a:spcAft>
-                <a:spcPts val="1400"/>
-              </a:spcAft>
-            </a:pPr>
-            <a:r>
-              <a:rPr sz="1250" b="0">
+                <a:spcPts val="1200"/>
+              </a:spcAft>
+            </a:pPr>
+            <a:r>
+              <a:rPr sz="1200" b="0">
                 <a:solidFill>
                   <a:srgbClr val="222B35"/>
                 </a:solidFill>
                 <a:latin typeface="Arial"/>
               </a:rPr>
-              <a:t>• תרחישי LoRa, Push ו-SMS מוצגים במסגרת סימולטור ה-WEB ואינם מחוברים לחומרת LoRa פיזית.</a:t>
-            </a:r>
-          </a:p>
-          <a:p>
-            <a:pPr algn="r" rtl="1">
+              <a:t>* LoRa, push and SMS scenarios run inside the web simulator and are not connected to physical LoRa hardware.</a:t>
+            </a:r>
+          </a:p>
+          <a:p>
+            <a:pPr algn="l">
               <a:lnSpc>
                 <a:spcPct val="132000"/>
               </a:lnSpc>
               <a:spcAft>
-                <a:spcPts val="1400"/>
-              </a:spcAft>
-            </a:pPr>
-            <a:r>
-              <a:rPr sz="1250" b="0">
+                <a:spcPts val="1200"/>
+              </a:spcAft>
+            </a:pPr>
+            <a:r>
+              <a:rPr sz="1200" b="0">
                 <a:solidFill>
                   <a:srgbClr val="222B35"/>
                 </a:solidFill>
                 <a:latin typeface="Arial"/>
               </a:rPr>
-              <a:t>• נתוני המכשירים והמתנדבים כוללים נתוני Demo לצורך הצגה עקבית של תרחיש הקורס.</a:t>
+              <a:t>* Device and volunteer data includes demo records so the course scenario is always presentable.</a:t>
             </a:r>
           </a:p>
         </p:txBody>
@@ -5851,8 +5851,8 @@
         </p:nvSpPr>
         <p:spPr>
           <a:xfrm>
-            <a:off x="6629400" y="5029200"/>
-            <a:ext cx="4617720" cy="658368"/>
+            <a:off x="6629400" y="4937760"/>
+            <a:ext cx="4617720" cy="694944"/>
           </a:xfrm>
           <a:prstGeom prst="roundRect">
             <a:avLst>
@@ -5899,8 +5899,8 @@
         </p:nvSpPr>
         <p:spPr>
           <a:xfrm>
-            <a:off x="6812280" y="5138928"/>
-            <a:ext cx="4251960" cy="457200"/>
+            <a:off x="6812280" y="5047488"/>
+            <a:ext cx="4251960" cy="512064"/>
           </a:xfrm>
           <a:prstGeom prst="rect">
             <a:avLst/>
@@ -5913,7 +5913,7 @@
           </a:bodyPr>
           <a:lstStyle/>
           <a:p>
-            <a:pPr algn="r" rtl="1">
+            <a:pPr algn="l">
               <a:lnSpc>
                 <a:spcPct val="125000"/>
               </a:lnSpc>
@@ -5928,7 +5928,7 @@
                 </a:solidFill>
                 <a:latin typeface="Arial"/>
               </a:rPr>
-              <a:t>גילוי נאות: אלו מגבלות ידועות של סביבת ההדגמה וה-Free Tier. הן אינן מונעות הצגת התרחיש המלא באתר.</a:t>
+              <a:t>Full disclosure: these are known limits of the free tier demo setup. None of them block the full scenario on the site.</a:t>
             </a:r>
           </a:p>
         </p:txBody>
@@ -5941,7 +5941,7 @@
         </p:nvSpPr>
         <p:spPr>
           <a:xfrm>
-            <a:off x="548640" y="6400800"/>
+            <a:off x="548640" y="6446520"/>
             <a:ext cx="3657600" cy="274320"/>
           </a:xfrm>
           <a:prstGeom prst="rect">
@@ -5955,7 +5955,7 @@
           </a:bodyPr>
           <a:lstStyle/>
           <a:p>
-            <a:pPr algn="l" rtl="0">
+            <a:pPr algn="l">
               <a:lnSpc>
                 <a:spcPct val="125000"/>
               </a:lnSpc>
@@ -5970,7 +5970,7 @@
                 </a:solidFill>
                 <a:latin typeface="Arial"/>
               </a:rPr>
-              <a:t>DefiNet - WEB 2026</a:t>
+              <a:t>DefiNet | WEB 2026</a:t>
             </a:r>
           </a:p>
         </p:txBody>
@@ -5983,7 +5983,7 @@
         </p:nvSpPr>
         <p:spPr>
           <a:xfrm>
-            <a:off x="10728655" y="6400800"/>
+            <a:off x="10728655" y="6446520"/>
             <a:ext cx="914400" cy="274320"/>
           </a:xfrm>
           <a:prstGeom prst="rect">
@@ -5997,7 +5997,7 @@
           </a:bodyPr>
           <a:lstStyle/>
           <a:p>
-            <a:pPr algn="r" rtl="0">
+            <a:pPr algn="r">
               <a:lnSpc>
                 <a:spcPct val="125000"/>
               </a:lnSpc>
@@ -6101,7 +6101,7 @@
           </a:bodyPr>
           <a:lstStyle/>
           <a:p>
-            <a:pPr algn="r" rtl="1">
+            <a:pPr algn="l">
               <a:lnSpc>
                 <a:spcPct val="125000"/>
               </a:lnSpc>
@@ -6116,7 +6116,7 @@
                 </a:solidFill>
                 <a:latin typeface="Arial"/>
               </a:rPr>
-              <a:t>מבנה ארכיטקטוני</a:t>
+              <a:t>Architecture</a:t>
             </a:r>
           </a:p>
         </p:txBody>
@@ -6129,7 +6129,7 @@
         </p:nvSpPr>
         <p:spPr>
           <a:xfrm>
-            <a:off x="8503920" y="1554480"/>
+            <a:off x="731520" y="1554480"/>
             <a:ext cx="3017520" cy="1600200"/>
           </a:xfrm>
           <a:prstGeom prst="roundRect">
@@ -6177,7 +6177,7 @@
         </p:nvSpPr>
         <p:spPr>
           <a:xfrm>
-            <a:off x="8641080" y="1810512"/>
+            <a:off x="868680" y="1810512"/>
             <a:ext cx="2743200" cy="365760"/>
           </a:xfrm>
           <a:prstGeom prst="rect">
@@ -6191,12 +6191,12 @@
           </a:bodyPr>
           <a:lstStyle/>
           <a:p>
-            <a:pPr algn="ctr" rtl="0">
+            <a:pPr algn="ctr">
               <a:lnSpc>
                 <a:spcPct val="125000"/>
               </a:lnSpc>
               <a:spcAft>
-                <a:spcPts val="600"/>
+                <a:spcPts val="0"/>
               </a:spcAft>
             </a:pPr>
             <a:r>
@@ -6219,7 +6219,7 @@
         </p:nvSpPr>
         <p:spPr>
           <a:xfrm>
-            <a:off x="8641080" y="2267712"/>
+            <a:off x="868680" y="2267712"/>
             <a:ext cx="2743200" cy="777240"/>
           </a:xfrm>
           <a:prstGeom prst="rect">
@@ -6233,7 +6233,7 @@
           </a:bodyPr>
           <a:lstStyle/>
           <a:p>
-            <a:pPr algn="ctr" rtl="0">
+            <a:pPr algn="ctr">
               <a:lnSpc>
                 <a:spcPct val="125000"/>
               </a:lnSpc>
@@ -6252,7 +6252,7 @@
             </a:r>
           </a:p>
           <a:p>
-            <a:pPr algn="ctr" rtl="0">
+            <a:pPr algn="ctr">
               <a:lnSpc>
                 <a:spcPct val="125000"/>
               </a:lnSpc>
@@ -6280,7 +6280,7 @@
         </p:nvSpPr>
         <p:spPr>
           <a:xfrm>
-            <a:off x="7973568" y="2148840"/>
+            <a:off x="3931920" y="2194560"/>
             <a:ext cx="548640" cy="365760"/>
           </a:xfrm>
           <a:prstGeom prst="rect">
@@ -6294,7 +6294,7 @@
           </a:bodyPr>
           <a:lstStyle/>
           <a:p>
-            <a:pPr algn="ctr" rtl="0">
+            <a:pPr algn="ctr">
               <a:lnSpc>
                 <a:spcPct val="125000"/>
               </a:lnSpc>
@@ -6303,13 +6303,13 @@
               </a:spcAft>
             </a:pPr>
             <a:r>
-              <a:rPr sz="2400" b="0">
+              <a:rPr sz="2200" b="1">
                 <a:solidFill>
                   <a:srgbClr val="1F5C99"/>
                 </a:solidFill>
                 <a:latin typeface="Arial"/>
               </a:rPr>
-              <a:t>←</a:t>
+              <a:t>&gt;</a:t>
             </a:r>
           </a:p>
         </p:txBody>
@@ -6384,12 +6384,12 @@
           </a:bodyPr>
           <a:lstStyle/>
           <a:p>
-            <a:pPr algn="ctr" rtl="0">
+            <a:pPr algn="ctr">
               <a:lnSpc>
                 <a:spcPct val="125000"/>
               </a:lnSpc>
               <a:spcAft>
-                <a:spcPts val="600"/>
+                <a:spcPts val="0"/>
               </a:spcAft>
             </a:pPr>
             <a:r>
@@ -6426,7 +6426,7 @@
           </a:bodyPr>
           <a:lstStyle/>
           <a:p>
-            <a:pPr algn="ctr" rtl="0">
+            <a:pPr algn="ctr">
               <a:lnSpc>
                 <a:spcPct val="125000"/>
               </a:lnSpc>
@@ -6445,7 +6445,7 @@
             </a:r>
           </a:p>
           <a:p>
-            <a:pPr algn="ctr" rtl="0">
+            <a:pPr algn="ctr">
               <a:lnSpc>
                 <a:spcPct val="125000"/>
               </a:lnSpc>
@@ -6460,11 +6460,11 @@
                 </a:solidFill>
                 <a:latin typeface="Arial"/>
               </a:rPr>
-              <a:t>Marketing · Register</a:t>
-            </a:r>
-          </a:p>
-          <a:p>
-            <a:pPr algn="ctr" rtl="0">
+              <a:t>Marketing | Register</a:t>
+            </a:r>
+          </a:p>
+          <a:p>
+            <a:pPr algn="ctr">
               <a:lnSpc>
                 <a:spcPct val="125000"/>
               </a:lnSpc>
@@ -6479,7 +6479,7 @@
                 </a:solidFill>
                 <a:latin typeface="Arial"/>
               </a:rPr>
-              <a:t>Simulator · Admin UI</a:t>
+              <a:t>Simulator | Admin UI</a:t>
             </a:r>
           </a:p>
         </p:txBody>
@@ -6492,7 +6492,7 @@
         </p:nvSpPr>
         <p:spPr>
           <a:xfrm>
-            <a:off x="3977639" y="2148840"/>
+            <a:off x="8065008" y="2194560"/>
             <a:ext cx="548640" cy="365760"/>
           </a:xfrm>
           <a:prstGeom prst="rect">
@@ -6506,7 +6506,7 @@
           </a:bodyPr>
           <a:lstStyle/>
           <a:p>
-            <a:pPr algn="ctr" rtl="0">
+            <a:pPr algn="ctr">
               <a:lnSpc>
                 <a:spcPct val="125000"/>
               </a:lnSpc>
@@ -6515,27 +6515,69 @@
               </a:spcAft>
             </a:pPr>
             <a:r>
-              <a:rPr sz="2400" b="0">
+              <a:rPr sz="2200" b="1">
                 <a:solidFill>
                   <a:srgbClr val="1F5C99"/>
                 </a:solidFill>
                 <a:latin typeface="Arial"/>
               </a:rPr>
-              <a:t>←</a:t>
-            </a:r>
-          </a:p>
-        </p:txBody>
-      </p:sp>
-      <p:sp>
-        <p:nvSpPr>
-          <p:cNvPr id="12" name="Rounded Rectangle 11"/>
+              <a:t>&gt;</a:t>
+            </a:r>
+          </a:p>
+        </p:txBody>
+      </p:sp>
+      <p:sp>
+        <p:nvSpPr>
+          <p:cNvPr id="12" name="TextBox 11"/>
+          <p:cNvSpPr txBox="1"/>
+          <p:nvPr/>
+        </p:nvSpPr>
+        <p:spPr>
+          <a:xfrm>
+            <a:off x="7607808" y="1874519"/>
+            <a:ext cx="868680" cy="274320"/>
+          </a:xfrm>
+          <a:prstGeom prst="rect">
+            <a:avLst/>
+          </a:prstGeom>
+          <a:noFill/>
+        </p:spPr>
+        <p:txBody>
+          <a:bodyPr wrap="square" anchor="t" lIns="0" rIns="0" tIns="0" bIns="0">
+            <a:spAutoFit/>
+          </a:bodyPr>
+          <a:lstStyle/>
+          <a:p>
+            <a:pPr algn="ctr">
+              <a:lnSpc>
+                <a:spcPct val="125000"/>
+              </a:lnSpc>
+              <a:spcAft>
+                <a:spcPts val="0"/>
+              </a:spcAft>
+            </a:pPr>
+            <a:r>
+              <a:rPr sz="900" b="0">
+                <a:solidFill>
+                  <a:srgbClr val="5A6673"/>
+                </a:solidFill>
+                <a:latin typeface="Arial"/>
+              </a:rPr>
+              <a:t>REST / JSON</a:t>
+            </a:r>
+          </a:p>
+        </p:txBody>
+      </p:sp>
+      <p:sp>
+        <p:nvSpPr>
+          <p:cNvPr id="13" name="Rounded Rectangle 12"/>
           <p:cNvSpPr/>
           <p:nvPr/>
         </p:nvSpPr>
         <p:spPr>
           <a:xfrm>
-            <a:off x="731520" y="1554480"/>
-            <a:ext cx="3200400" cy="1600200"/>
+            <a:off x="8595360" y="1554480"/>
+            <a:ext cx="3017520" cy="1600200"/>
           </a:xfrm>
           <a:prstGeom prst="roundRect">
             <a:avLst>
@@ -6576,14 +6618,14 @@
       </p:sp>
       <p:sp>
         <p:nvSpPr>
-          <p:cNvPr id="13" name="TextBox 12"/>
+          <p:cNvPr id="14" name="TextBox 13"/>
           <p:cNvSpPr txBox="1"/>
           <p:nvPr/>
         </p:nvSpPr>
         <p:spPr>
           <a:xfrm>
-            <a:off x="868680" y="1810512"/>
-            <a:ext cx="2926080" cy="365760"/>
+            <a:off x="8732520" y="1810512"/>
+            <a:ext cx="2743200" cy="365760"/>
           </a:xfrm>
           <a:prstGeom prst="rect">
             <a:avLst/>
@@ -6596,12 +6638,12 @@
           </a:bodyPr>
           <a:lstStyle/>
           <a:p>
-            <a:pPr algn="ctr" rtl="0">
+            <a:pPr algn="ctr">
               <a:lnSpc>
                 <a:spcPct val="125000"/>
               </a:lnSpc>
               <a:spcAft>
-                <a:spcPts val="600"/>
+                <a:spcPts val="0"/>
               </a:spcAft>
             </a:pPr>
             <a:r>
@@ -6618,14 +6660,14 @@
       </p:sp>
       <p:sp>
         <p:nvSpPr>
-          <p:cNvPr id="14" name="TextBox 13"/>
+          <p:cNvPr id="15" name="TextBox 14"/>
           <p:cNvSpPr txBox="1"/>
           <p:nvPr/>
         </p:nvSpPr>
         <p:spPr>
           <a:xfrm>
-            <a:off x="868680" y="2267712"/>
-            <a:ext cx="2926080" cy="777240"/>
+            <a:off x="8732520" y="2267712"/>
+            <a:ext cx="2743200" cy="777240"/>
           </a:xfrm>
           <a:prstGeom prst="rect">
             <a:avLst/>
@@ -6638,7 +6680,7 @@
           </a:bodyPr>
           <a:lstStyle/>
           <a:p>
-            <a:pPr algn="ctr" rtl="0">
+            <a:pPr algn="ctr">
               <a:lnSpc>
                 <a:spcPct val="125000"/>
               </a:lnSpc>
@@ -6657,7 +6699,7 @@
             </a:r>
           </a:p>
           <a:p>
-            <a:pPr algn="ctr" rtl="0">
+            <a:pPr algn="ctr">
               <a:lnSpc>
                 <a:spcPct val="125000"/>
               </a:lnSpc>
@@ -6672,11 +6714,11 @@
                 </a:solidFill>
                 <a:latin typeface="Arial"/>
               </a:rPr>
-              <a:t>JWT Refresh · Registry</a:t>
-            </a:r>
-          </a:p>
-          <a:p>
-            <a:pPr algn="ctr" rtl="0">
+              <a:t>JWT Refresh | Registry</a:t>
+            </a:r>
+          </a:p>
+          <a:p>
+            <a:pPr algn="ctr">
               <a:lnSpc>
                 <a:spcPct val="125000"/>
               </a:lnSpc>
@@ -6691,49 +6733,7 @@
                 </a:solidFill>
                 <a:latin typeface="Arial"/>
               </a:rPr>
-              <a:t>Incidents · Telemetry</a:t>
-            </a:r>
-          </a:p>
-        </p:txBody>
-      </p:sp>
-      <p:sp>
-        <p:nvSpPr>
-          <p:cNvPr id="15" name="TextBox 14"/>
-          <p:cNvSpPr txBox="1"/>
-          <p:nvPr/>
-        </p:nvSpPr>
-        <p:spPr>
-          <a:xfrm>
-            <a:off x="3931920" y="1847088"/>
-            <a:ext cx="685800" cy="228600"/>
-          </a:xfrm>
-          <a:prstGeom prst="rect">
-            <a:avLst/>
-          </a:prstGeom>
-          <a:noFill/>
-        </p:spPr>
-        <p:txBody>
-          <a:bodyPr wrap="square" anchor="t" lIns="0" rIns="0" tIns="0" bIns="0">
-            <a:spAutoFit/>
-          </a:bodyPr>
-          <a:lstStyle/>
-          <a:p>
-            <a:pPr algn="ctr" rtl="0">
-              <a:lnSpc>
-                <a:spcPct val="125000"/>
-              </a:lnSpc>
-              <a:spcAft>
-                <a:spcPts val="0"/>
-              </a:spcAft>
-            </a:pPr>
-            <a:r>
-              <a:rPr sz="900" b="0">
-                <a:solidFill>
-                  <a:srgbClr val="5A6673"/>
-                </a:solidFill>
-                <a:latin typeface="Arial"/>
-              </a:rPr>
-              <a:t>REST / JSON</a:t>
+              <a:t>Incidents | Telemetry</a:t>
             </a:r>
           </a:p>
         </p:txBody>
@@ -6746,7 +6746,7 @@
         </p:nvSpPr>
         <p:spPr>
           <a:xfrm>
-            <a:off x="6309360" y="3703320"/>
+            <a:off x="1234440" y="3703320"/>
             <a:ext cx="4617720" cy="1463040"/>
           </a:xfrm>
           <a:prstGeom prst="roundRect">
@@ -6794,7 +6794,7 @@
         </p:nvSpPr>
         <p:spPr>
           <a:xfrm>
-            <a:off x="6446520" y="3959352"/>
+            <a:off x="1371600" y="3959352"/>
             <a:ext cx="4343400" cy="365760"/>
           </a:xfrm>
           <a:prstGeom prst="rect">
@@ -6808,12 +6808,12 @@
           </a:bodyPr>
           <a:lstStyle/>
           <a:p>
-            <a:pPr algn="ctr" rtl="0">
+            <a:pPr algn="ctr">
               <a:lnSpc>
                 <a:spcPct val="125000"/>
               </a:lnSpc>
               <a:spcAft>
-                <a:spcPts val="600"/>
+                <a:spcPts val="0"/>
               </a:spcAft>
             </a:pPr>
             <a:r>
@@ -6823,7 +6823,7 @@
                 </a:solidFill>
                 <a:latin typeface="Arial"/>
               </a:rPr>
-              <a:t>MongoDB - NoSQL</a:t>
+              <a:t>SQLite (SQL)</a:t>
             </a:r>
           </a:p>
         </p:txBody>
@@ -6836,7 +6836,7 @@
         </p:nvSpPr>
         <p:spPr>
           <a:xfrm>
-            <a:off x="6446520" y="4416552"/>
+            <a:off x="1371600" y="4416552"/>
             <a:ext cx="4343400" cy="640080"/>
           </a:xfrm>
           <a:prstGeom prst="rect">
@@ -6850,7 +6850,7 @@
           </a:bodyPr>
           <a:lstStyle/>
           <a:p>
-            <a:pPr algn="ctr" rtl="0">
+            <a:pPr algn="ctr">
               <a:lnSpc>
                 <a:spcPct val="125000"/>
               </a:lnSpc>
@@ -6865,11 +6865,11 @@
                 </a:solidFill>
                 <a:latin typeface="Arial"/>
               </a:rPr>
-              <a:t>Incidents · CMS · Telemetry · Alerts · Config</a:t>
-            </a:r>
-          </a:p>
-          <a:p>
-            <a:pPr algn="ctr" rtl="0">
+              <a:t>Users | Devices | Admins | Refresh Tokens</a:t>
+            </a:r>
+          </a:p>
+          <a:p>
+            <a:pPr algn="ctr">
               <a:lnSpc>
                 <a:spcPct val="125000"/>
               </a:lnSpc>
@@ -6884,7 +6884,7 @@
                 </a:solidFill>
                 <a:latin typeface="Arial"/>
               </a:rPr>
-              <a:t>Flexible / Nested Documents</a:t>
+              <a:t>Relations, constraints, structured data</a:t>
             </a:r>
           </a:p>
         </p:txBody>
@@ -6897,7 +6897,7 @@
         </p:nvSpPr>
         <p:spPr>
           <a:xfrm>
-            <a:off x="1234440" y="3703320"/>
+            <a:off x="6309360" y="3703320"/>
             <a:ext cx="4617720" cy="1463040"/>
           </a:xfrm>
           <a:prstGeom prst="roundRect">
@@ -6945,7 +6945,7 @@
         </p:nvSpPr>
         <p:spPr>
           <a:xfrm>
-            <a:off x="1371600" y="3959352"/>
+            <a:off x="6446520" y="3959352"/>
             <a:ext cx="4343400" cy="365760"/>
           </a:xfrm>
           <a:prstGeom prst="rect">
@@ -6959,12 +6959,12 @@
           </a:bodyPr>
           <a:lstStyle/>
           <a:p>
-            <a:pPr algn="ctr" rtl="0">
+            <a:pPr algn="ctr">
               <a:lnSpc>
                 <a:spcPct val="125000"/>
               </a:lnSpc>
               <a:spcAft>
-                <a:spcPts val="600"/>
+                <a:spcPts val="0"/>
               </a:spcAft>
             </a:pPr>
             <a:r>
@@ -6974,7 +6974,7 @@
                 </a:solidFill>
                 <a:latin typeface="Arial"/>
               </a:rPr>
-              <a:t>SQLite - SQL</a:t>
+              <a:t>MongoDB (NoSQL)</a:t>
             </a:r>
           </a:p>
         </p:txBody>
@@ -6987,7 +6987,7 @@
         </p:nvSpPr>
         <p:spPr>
           <a:xfrm>
-            <a:off x="1371600" y="4416552"/>
+            <a:off x="6446520" y="4416552"/>
             <a:ext cx="4343400" cy="640080"/>
           </a:xfrm>
           <a:prstGeom prst="rect">
@@ -7001,7 +7001,7 @@
           </a:bodyPr>
           <a:lstStyle/>
           <a:p>
-            <a:pPr algn="ctr" rtl="0">
+            <a:pPr algn="ctr">
               <a:lnSpc>
                 <a:spcPct val="125000"/>
               </a:lnSpc>
@@ -7016,11 +7016,11 @@
                 </a:solidFill>
                 <a:latin typeface="Arial"/>
               </a:rPr>
-              <a:t>Users · Devices · Admins · Refresh Tokens</a:t>
-            </a:r>
-          </a:p>
-          <a:p>
-            <a:pPr algn="ctr" rtl="0">
+              <a:t>Incidents | CMS | Telemetry | Alerts | Config</a:t>
+            </a:r>
+          </a:p>
+          <a:p>
+            <a:pPr algn="ctr">
               <a:lnSpc>
                 <a:spcPct val="125000"/>
               </a:lnSpc>
@@ -7035,7 +7035,7 @@
                 </a:solidFill>
                 <a:latin typeface="Arial"/>
               </a:rPr>
-              <a:t>Relations · Constraints · Structured Data</a:t>
+              <a:t>Flexible nested documents</a:t>
             </a:r>
           </a:p>
         </p:txBody>
@@ -7110,7 +7110,7 @@
           </a:bodyPr>
           <a:lstStyle/>
           <a:p>
-            <a:pPr algn="ctr" rtl="0">
+            <a:pPr algn="ctr">
               <a:lnSpc>
                 <a:spcPct val="125000"/>
               </a:lnSpc>
@@ -7200,7 +7200,7 @@
           </a:bodyPr>
           <a:lstStyle/>
           <a:p>
-            <a:pPr algn="ctr" rtl="0">
+            <a:pPr algn="ctr">
               <a:lnSpc>
                 <a:spcPct val="125000"/>
               </a:lnSpc>
@@ -7290,7 +7290,7 @@
           </a:bodyPr>
           <a:lstStyle/>
           <a:p>
-            <a:pPr algn="ctr" rtl="0">
+            <a:pPr algn="ctr">
               <a:lnSpc>
                 <a:spcPct val="125000"/>
               </a:lnSpc>
@@ -7318,7 +7318,7 @@
         </p:nvSpPr>
         <p:spPr>
           <a:xfrm>
-            <a:off x="548640" y="6400800"/>
+            <a:off x="548640" y="6446520"/>
             <a:ext cx="3657600" cy="274320"/>
           </a:xfrm>
           <a:prstGeom prst="rect">
@@ -7332,7 +7332,7 @@
           </a:bodyPr>
           <a:lstStyle/>
           <a:p>
-            <a:pPr algn="l" rtl="0">
+            <a:pPr algn="l">
               <a:lnSpc>
                 <a:spcPct val="125000"/>
               </a:lnSpc>
@@ -7347,7 +7347,7 @@
                 </a:solidFill>
                 <a:latin typeface="Arial"/>
               </a:rPr>
-              <a:t>DefiNet - WEB 2026</a:t>
+              <a:t>DefiNet | WEB 2026</a:t>
             </a:r>
           </a:p>
         </p:txBody>
@@ -7360,7 +7360,7 @@
         </p:nvSpPr>
         <p:spPr>
           <a:xfrm>
-            <a:off x="10728655" y="6400800"/>
+            <a:off x="10728655" y="6446520"/>
             <a:ext cx="914400" cy="274320"/>
           </a:xfrm>
           <a:prstGeom prst="rect">
@@ -7374,7 +7374,7 @@
           </a:bodyPr>
           <a:lstStyle/>
           <a:p>
-            <a:pPr algn="r" rtl="0">
+            <a:pPr algn="r">
               <a:lnSpc>
                 <a:spcPct val="125000"/>
               </a:lnSpc>
@@ -7478,7 +7478,7 @@
           </a:bodyPr>
           <a:lstStyle/>
           <a:p>
-            <a:pPr algn="r" rtl="1">
+            <a:pPr algn="l">
               <a:lnSpc>
                 <a:spcPct val="125000"/>
               </a:lnSpc>
@@ -7493,7 +7493,7 @@
                 </a:solidFill>
                 <a:latin typeface="Arial"/>
               </a:rPr>
-              <a:t>דגימות קוד מרכזיות</a:t>
+              <a:t>Key Code Samples</a:t>
             </a:r>
           </a:p>
         </p:txBody>
@@ -7520,7 +7520,7 @@
           </a:bodyPr>
           <a:lstStyle/>
           <a:p>
-            <a:pPr algn="r" rtl="1">
+            <a:pPr algn="l">
               <a:lnSpc>
                 <a:spcPct val="125000"/>
               </a:lnSpc>
@@ -7535,7 +7535,7 @@
                 </a:solidFill>
                 <a:latin typeface="Arial"/>
               </a:rPr>
-              <a:t>שלושת הקטעים שנשאלים עליהם בדרך כלל: אבטחת Admin, החישוב הגיאוגרפי ורוטציית ה-Refresh Token.</a:t>
+              <a:t>The three parts examiners usually ask about: admin security, the geographic computation and refresh token rotation.</a:t>
             </a:r>
           </a:p>
         </p:txBody>
@@ -7610,7 +7610,7 @@
           </a:bodyPr>
           <a:lstStyle/>
           <a:p>
-            <a:pPr algn="l" rtl="0">
+            <a:pPr algn="l">
               <a:lnSpc>
                 <a:spcPct val="125000"/>
               </a:lnSpc>
@@ -7698,7 +7698,7 @@
           </a:bodyPr>
           <a:lstStyle/>
           <a:p>
-            <a:pPr algn="l" rtl="0">
+            <a:pPr algn="l">
               <a:lnSpc>
                 <a:spcPct val="115000"/>
               </a:lnSpc>
@@ -7717,7 +7717,7 @@
             </a:r>
           </a:p>
           <a:p>
-            <a:pPr algn="l" rtl="0">
+            <a:pPr algn="l">
               <a:lnSpc>
                 <a:spcPct val="115000"/>
               </a:lnSpc>
@@ -7736,7 +7736,7 @@
             </a:r>
           </a:p>
           <a:p>
-            <a:pPr algn="l" rtl="0">
+            <a:pPr algn="l">
               <a:lnSpc>
                 <a:spcPct val="115000"/>
               </a:lnSpc>
@@ -7755,7 +7755,7 @@
             </a:r>
           </a:p>
           <a:p>
-            <a:pPr algn="l" rtl="0">
+            <a:pPr algn="l">
               <a:lnSpc>
                 <a:spcPct val="115000"/>
               </a:lnSpc>
@@ -7774,7 +7774,7 @@
             </a:r>
           </a:p>
           <a:p>
-            <a:pPr algn="l" rtl="0">
+            <a:pPr algn="l">
               <a:lnSpc>
                 <a:spcPct val="115000"/>
               </a:lnSpc>
@@ -7793,7 +7793,7 @@
             </a:r>
           </a:p>
           <a:p>
-            <a:pPr algn="l" rtl="0">
+            <a:pPr algn="l">
               <a:lnSpc>
                 <a:spcPct val="115000"/>
               </a:lnSpc>
@@ -7812,7 +7812,7 @@
             </a:r>
           </a:p>
           <a:p>
-            <a:pPr algn="l" rtl="0">
+            <a:pPr algn="l">
               <a:lnSpc>
                 <a:spcPct val="115000"/>
               </a:lnSpc>
@@ -7854,7 +7854,7 @@
           </a:bodyPr>
           <a:lstStyle/>
           <a:p>
-            <a:pPr algn="r" rtl="1">
+            <a:pPr algn="l">
               <a:lnSpc>
                 <a:spcPct val="128000"/>
               </a:lnSpc>
@@ -7869,7 +7869,7 @@
                 </a:solidFill>
                 <a:latin typeface="Arial"/>
               </a:rPr>
-              <a:t>מנוע האירועים - דירוג המועמדים: בתוך הרדיוס קודם, שידור טרי לפני ישן, ואז המרחק הקצר.</a:t>
+              <a:t>The incident engine ranks candidates: inside the radius first, fresh transmissions before stale ones, then the shortest distance.</a:t>
             </a:r>
           </a:p>
         </p:txBody>
@@ -7944,7 +7944,7 @@
           </a:bodyPr>
           <a:lstStyle/>
           <a:p>
-            <a:pPr algn="l" rtl="0">
+            <a:pPr algn="l">
               <a:lnSpc>
                 <a:spcPct val="125000"/>
               </a:lnSpc>
@@ -8032,7 +8032,7 @@
           </a:bodyPr>
           <a:lstStyle/>
           <a:p>
-            <a:pPr algn="l" rtl="0">
+            <a:pPr algn="l">
               <a:lnSpc>
                 <a:spcPct val="115000"/>
               </a:lnSpc>
@@ -8051,7 +8051,7 @@
             </a:r>
           </a:p>
           <a:p>
-            <a:pPr algn="l" rtl="0">
+            <a:pPr algn="l">
               <a:lnSpc>
                 <a:spcPct val="115000"/>
               </a:lnSpc>
@@ -8070,7 +8070,7 @@
             </a:r>
           </a:p>
           <a:p>
-            <a:pPr algn="l" rtl="0">
+            <a:pPr algn="l">
               <a:lnSpc>
                 <a:spcPct val="115000"/>
               </a:lnSpc>
@@ -8089,7 +8089,7 @@
             </a:r>
           </a:p>
           <a:p>
-            <a:pPr algn="l" rtl="0">
+            <a:pPr algn="l">
               <a:lnSpc>
                 <a:spcPct val="115000"/>
               </a:lnSpc>
@@ -8108,7 +8108,7 @@
             </a:r>
           </a:p>
           <a:p>
-            <a:pPr algn="l" rtl="0">
+            <a:pPr algn="l">
               <a:lnSpc>
                 <a:spcPct val="115000"/>
               </a:lnSpc>
@@ -8127,7 +8127,7 @@
             </a:r>
           </a:p>
           <a:p>
-            <a:pPr algn="l" rtl="0">
+            <a:pPr algn="l">
               <a:lnSpc>
                 <a:spcPct val="115000"/>
               </a:lnSpc>
@@ -8169,7 +8169,7 @@
           </a:bodyPr>
           <a:lstStyle/>
           <a:p>
-            <a:pPr algn="r" rtl="1">
+            <a:pPr algn="l">
               <a:lnSpc>
                 <a:spcPct val="128000"/>
               </a:lnSpc>
@@ -8184,7 +8184,7 @@
                 </a:solidFill>
                 <a:latin typeface="Arial"/>
               </a:rPr>
-              <a:t>נוסחת Haversine: מרחק על פני כדור הארץ בין נקודת המצוקה לכל מכשיר.</a:t>
+              <a:t>The Haversine formula: distance over the surface of the Earth between the distress point and each device.</a:t>
             </a:r>
           </a:p>
         </p:txBody>
@@ -8259,7 +8259,7 @@
           </a:bodyPr>
           <a:lstStyle/>
           <a:p>
-            <a:pPr algn="l" rtl="0">
+            <a:pPr algn="l">
               <a:lnSpc>
                 <a:spcPct val="125000"/>
               </a:lnSpc>
@@ -8347,7 +8347,7 @@
           </a:bodyPr>
           <a:lstStyle/>
           <a:p>
-            <a:pPr algn="l" rtl="0">
+            <a:pPr algn="l">
               <a:lnSpc>
                 <a:spcPct val="115000"/>
               </a:lnSpc>
@@ -8366,7 +8366,7 @@
             </a:r>
           </a:p>
           <a:p>
-            <a:pPr algn="l" rtl="0">
+            <a:pPr algn="l">
               <a:lnSpc>
                 <a:spcPct val="115000"/>
               </a:lnSpc>
@@ -8385,7 +8385,7 @@
             </a:r>
           </a:p>
           <a:p>
-            <a:pPr algn="l" rtl="0">
+            <a:pPr algn="l">
               <a:lnSpc>
                 <a:spcPct val="115000"/>
               </a:lnSpc>
@@ -8404,7 +8404,7 @@
             </a:r>
           </a:p>
           <a:p>
-            <a:pPr algn="l" rtl="0">
+            <a:pPr algn="l">
               <a:lnSpc>
                 <a:spcPct val="115000"/>
               </a:lnSpc>
@@ -8423,7 +8423,7 @@
             </a:r>
           </a:p>
           <a:p>
-            <a:pPr algn="l" rtl="0">
+            <a:pPr algn="l">
               <a:lnSpc>
                 <a:spcPct val="115000"/>
               </a:lnSpc>
@@ -8442,7 +8442,7 @@
             </a:r>
           </a:p>
           <a:p>
-            <a:pPr algn="l" rtl="0">
+            <a:pPr algn="l">
               <a:lnSpc>
                 <a:spcPct val="115000"/>
               </a:lnSpc>
@@ -8461,7 +8461,7 @@
             </a:r>
           </a:p>
           <a:p>
-            <a:pPr algn="l" rtl="0">
+            <a:pPr algn="l">
               <a:lnSpc>
                 <a:spcPct val="115000"/>
               </a:lnSpc>
@@ -8503,7 +8503,7 @@
           </a:bodyPr>
           <a:lstStyle/>
           <a:p>
-            <a:pPr algn="r" rtl="1">
+            <a:pPr algn="l">
               <a:lnSpc>
                 <a:spcPct val="128000"/>
               </a:lnSpc>
@@ -8518,7 +8518,7 @@
                 </a:solidFill>
                 <a:latin typeface="Arial"/>
               </a:rPr>
-              <a:t>רוטציה: כל Refresh Token הוא חד-פעמי, ולכן טוקן גנוב נכשל בשימוש החוזר.</a:t>
+              <a:t>Rotation: every refresh token is single use, so a stolen token fails the moment it is reused.</a:t>
             </a:r>
           </a:p>
         </p:txBody>
@@ -8593,12 +8593,12 @@
           </a:bodyPr>
           <a:lstStyle/>
           <a:p>
-            <a:pPr algn="r" rtl="1">
+            <a:pPr algn="l">
               <a:lnSpc>
                 <a:spcPct val="125000"/>
               </a:lnSpc>
               <a:spcAft>
-                <a:spcPts val="600"/>
+                <a:spcPts val="0"/>
               </a:spcAft>
             </a:pPr>
             <a:r>
@@ -8608,7 +8608,7 @@
                 </a:solidFill>
                 <a:latin typeface="Arial"/>
               </a:rPr>
-              <a:t>קבצים מרכזיים נוספים</a:t>
+              <a:t>Other key files</a:t>
             </a:r>
           </a:p>
         </p:txBody>
@@ -8635,7 +8635,7 @@
           </a:bodyPr>
           <a:lstStyle/>
           <a:p>
-            <a:pPr algn="l" rtl="0">
+            <a:pPr algn="l">
               <a:lnSpc>
                 <a:spcPct val="125000"/>
               </a:lnSpc>
@@ -8650,7 +8650,7 @@
                 </a:solidFill>
                 <a:latin typeface="Arial"/>
               </a:rPr>
-              <a:t>server/src/routes/registry.js · server/src/db/sqlite.js · server/src/db/mongo.js · server/src/lib/silent-update.js · web/components/map/SimulatorApp.jsx · web/lib/api.js</a:t>
+              <a:t>server/src/routes/registry.js | server/src/db/sqlite.js | server/src/db/mongo.js | server/src/lib/silent-update.js | web/components/map/SimulatorApp.jsx | web/lib/api.js</a:t>
             </a:r>
           </a:p>
         </p:txBody>
@@ -8663,7 +8663,7 @@
         </p:nvSpPr>
         <p:spPr>
           <a:xfrm>
-            <a:off x="548640" y="6400800"/>
+            <a:off x="548640" y="6446520"/>
             <a:ext cx="3657600" cy="274320"/>
           </a:xfrm>
           <a:prstGeom prst="rect">
@@ -8677,7 +8677,7 @@
           </a:bodyPr>
           <a:lstStyle/>
           <a:p>
-            <a:pPr algn="l" rtl="0">
+            <a:pPr algn="l">
               <a:lnSpc>
                 <a:spcPct val="125000"/>
               </a:lnSpc>
@@ -8692,7 +8692,7 @@
                 </a:solidFill>
                 <a:latin typeface="Arial"/>
               </a:rPr>
-              <a:t>DefiNet - WEB 2026</a:t>
+              <a:t>DefiNet | WEB 2026</a:t>
             </a:r>
           </a:p>
         </p:txBody>
@@ -8705,7 +8705,7 @@
         </p:nvSpPr>
         <p:spPr>
           <a:xfrm>
-            <a:off x="10728655" y="6400800"/>
+            <a:off x="10728655" y="6446520"/>
             <a:ext cx="914400" cy="274320"/>
           </a:xfrm>
           <a:prstGeom prst="rect">
@@ -8719,7 +8719,7 @@
           </a:bodyPr>
           <a:lstStyle/>
           <a:p>
-            <a:pPr algn="r" rtl="0">
+            <a:pPr algn="r">
               <a:lnSpc>
                 <a:spcPct val="125000"/>
               </a:lnSpc>

</xml_diff>

<commit_message>
docs: final 4-slide English deck
Drops the code-samples page per the submitters' decision and removes the
arrow label that collided with a card on the architecture slide. Footer
page numbers updated to /4. Slide 4 re-verified by rendering.

Co-Authored-By: Claude Fable 5 <noreply@anthropic.com>
</commit_message>
<xml_diff>
--- a/docs/DefiNet-Defense-Deck.pptx
+++ b/docs/DefiNet-Defense-Deck.pptx
@@ -9,7 +9,6 @@
     <p:sldId id="257" r:id="rId8"/>
     <p:sldId id="258" r:id="rId9"/>
     <p:sldId id="259" r:id="rId10"/>
-    <p:sldId id="260" r:id="rId11"/>
   </p:sldIdLst>
   <p:sldSz cx="12191695" cy="6858000" type="screen4x3"/>
   <p:notesSz cx="6858000" cy="9144000"/>
@@ -4597,7 +4596,7 @@
                 </a:solidFill>
                 <a:latin typeface="Arial"/>
               </a:rPr>
-              <a:t>1 / 5</a:t>
+              <a:t>1 / 4</a:t>
             </a:r>
           </a:p>
         </p:txBody>
@@ -5394,7 +5393,7 @@
                 </a:solidFill>
                 <a:latin typeface="Arial"/>
               </a:rPr>
-              <a:t>2 / 5</a:t>
+              <a:t>2 / 4</a:t>
             </a:r>
           </a:p>
         </p:txBody>
@@ -6012,7 +6011,7 @@
                 </a:solidFill>
                 <a:latin typeface="Arial"/>
               </a:rPr>
-              <a:t>3 / 5</a:t>
+              <a:t>3 / 4</a:t>
             </a:r>
           </a:p>
         </p:txBody>
@@ -6528,49 +6527,7 @@
       </p:sp>
       <p:sp>
         <p:nvSpPr>
-          <p:cNvPr id="12" name="TextBox 11"/>
-          <p:cNvSpPr txBox="1"/>
-          <p:nvPr/>
-        </p:nvSpPr>
-        <p:spPr>
-          <a:xfrm>
-            <a:off x="7607808" y="1874519"/>
-            <a:ext cx="868680" cy="274320"/>
-          </a:xfrm>
-          <a:prstGeom prst="rect">
-            <a:avLst/>
-          </a:prstGeom>
-          <a:noFill/>
-        </p:spPr>
-        <p:txBody>
-          <a:bodyPr wrap="square" anchor="t" lIns="0" rIns="0" tIns="0" bIns="0">
-            <a:spAutoFit/>
-          </a:bodyPr>
-          <a:lstStyle/>
-          <a:p>
-            <a:pPr algn="ctr">
-              <a:lnSpc>
-                <a:spcPct val="125000"/>
-              </a:lnSpc>
-              <a:spcAft>
-                <a:spcPts val="0"/>
-              </a:spcAft>
-            </a:pPr>
-            <a:r>
-              <a:rPr sz="900" b="0">
-                <a:solidFill>
-                  <a:srgbClr val="5A6673"/>
-                </a:solidFill>
-                <a:latin typeface="Arial"/>
-              </a:rPr>
-              <a:t>REST / JSON</a:t>
-            </a:r>
-          </a:p>
-        </p:txBody>
-      </p:sp>
-      <p:sp>
-        <p:nvSpPr>
-          <p:cNvPr id="13" name="Rounded Rectangle 12"/>
+          <p:cNvPr id="12" name="Rounded Rectangle 11"/>
           <p:cNvSpPr/>
           <p:nvPr/>
         </p:nvSpPr>
@@ -6618,7 +6575,7 @@
       </p:sp>
       <p:sp>
         <p:nvSpPr>
-          <p:cNvPr id="14" name="TextBox 13"/>
+          <p:cNvPr id="13" name="TextBox 12"/>
           <p:cNvSpPr txBox="1"/>
           <p:nvPr/>
         </p:nvSpPr>
@@ -6660,7 +6617,7 @@
       </p:sp>
       <p:sp>
         <p:nvSpPr>
-          <p:cNvPr id="15" name="TextBox 14"/>
+          <p:cNvPr id="14" name="TextBox 13"/>
           <p:cNvSpPr txBox="1"/>
           <p:nvPr/>
         </p:nvSpPr>
@@ -6740,7 +6697,7 @@
       </p:sp>
       <p:sp>
         <p:nvSpPr>
-          <p:cNvPr id="16" name="Rounded Rectangle 15"/>
+          <p:cNvPr id="15" name="Rounded Rectangle 14"/>
           <p:cNvSpPr/>
           <p:nvPr/>
         </p:nvSpPr>
@@ -6788,7 +6745,7 @@
       </p:sp>
       <p:sp>
         <p:nvSpPr>
-          <p:cNvPr id="17" name="TextBox 16"/>
+          <p:cNvPr id="16" name="TextBox 15"/>
           <p:cNvSpPr txBox="1"/>
           <p:nvPr/>
         </p:nvSpPr>
@@ -6830,7 +6787,7 @@
       </p:sp>
       <p:sp>
         <p:nvSpPr>
-          <p:cNvPr id="18" name="TextBox 17"/>
+          <p:cNvPr id="17" name="TextBox 16"/>
           <p:cNvSpPr txBox="1"/>
           <p:nvPr/>
         </p:nvSpPr>
@@ -6891,7 +6848,7 @@
       </p:sp>
       <p:sp>
         <p:nvSpPr>
-          <p:cNvPr id="19" name="Rounded Rectangle 18"/>
+          <p:cNvPr id="18" name="Rounded Rectangle 17"/>
           <p:cNvSpPr/>
           <p:nvPr/>
         </p:nvSpPr>
@@ -6939,7 +6896,7 @@
       </p:sp>
       <p:sp>
         <p:nvSpPr>
-          <p:cNvPr id="20" name="TextBox 19"/>
+          <p:cNvPr id="19" name="TextBox 18"/>
           <p:cNvSpPr txBox="1"/>
           <p:nvPr/>
         </p:nvSpPr>
@@ -6981,7 +6938,7 @@
       </p:sp>
       <p:sp>
         <p:nvSpPr>
-          <p:cNvPr id="21" name="TextBox 20"/>
+          <p:cNvPr id="20" name="TextBox 19"/>
           <p:cNvSpPr txBox="1"/>
           <p:nvPr/>
         </p:nvSpPr>
@@ -7042,7 +6999,7 @@
       </p:sp>
       <p:sp>
         <p:nvSpPr>
-          <p:cNvPr id="22" name="Rounded Rectangle 21"/>
+          <p:cNvPr id="21" name="Rounded Rectangle 20"/>
           <p:cNvSpPr/>
           <p:nvPr/>
         </p:nvSpPr>
@@ -7090,7 +7047,7 @@
       </p:sp>
       <p:sp>
         <p:nvSpPr>
-          <p:cNvPr id="23" name="TextBox 22"/>
+          <p:cNvPr id="22" name="TextBox 21"/>
           <p:cNvSpPr txBox="1"/>
           <p:nvPr/>
         </p:nvSpPr>
@@ -7132,7 +7089,7 @@
       </p:sp>
       <p:sp>
         <p:nvSpPr>
-          <p:cNvPr id="24" name="Rounded Rectangle 23"/>
+          <p:cNvPr id="23" name="Rounded Rectangle 22"/>
           <p:cNvSpPr/>
           <p:nvPr/>
         </p:nvSpPr>
@@ -7180,7 +7137,7 @@
       </p:sp>
       <p:sp>
         <p:nvSpPr>
-          <p:cNvPr id="25" name="TextBox 24"/>
+          <p:cNvPr id="24" name="TextBox 23"/>
           <p:cNvSpPr txBox="1"/>
           <p:nvPr/>
         </p:nvSpPr>
@@ -7222,7 +7179,7 @@
       </p:sp>
       <p:sp>
         <p:nvSpPr>
-          <p:cNvPr id="26" name="Rounded Rectangle 25"/>
+          <p:cNvPr id="25" name="Rounded Rectangle 24"/>
           <p:cNvSpPr/>
           <p:nvPr/>
         </p:nvSpPr>
@@ -7270,7 +7227,7 @@
       </p:sp>
       <p:sp>
         <p:nvSpPr>
-          <p:cNvPr id="27" name="TextBox 26"/>
+          <p:cNvPr id="26" name="TextBox 25"/>
           <p:cNvSpPr txBox="1"/>
           <p:nvPr/>
         </p:nvSpPr>
@@ -7312,7 +7269,7 @@
       </p:sp>
       <p:sp>
         <p:nvSpPr>
-          <p:cNvPr id="28" name="TextBox 27"/>
+          <p:cNvPr id="27" name="TextBox 26"/>
           <p:cNvSpPr txBox="1"/>
           <p:nvPr/>
         </p:nvSpPr>
@@ -7354,7 +7311,7 @@
       </p:sp>
       <p:sp>
         <p:nvSpPr>
-          <p:cNvPr id="29" name="TextBox 28"/>
+          <p:cNvPr id="28" name="TextBox 27"/>
           <p:cNvSpPr txBox="1"/>
           <p:nvPr/>
         </p:nvSpPr>
@@ -7389,1352 +7346,7 @@
                 </a:solidFill>
                 <a:latin typeface="Arial"/>
               </a:rPr>
-              <a:t>4 / 5</a:t>
-            </a:r>
-          </a:p>
-        </p:txBody>
-      </p:sp>
-    </p:spTree>
-  </p:cSld>
-  <p:clrMapOvr>
-    <a:masterClrMapping/>
-  </p:clrMapOvr>
-</p:sld>
-</file>
-
-<file path=ppt/slides/slide5.xml><?xml version="1.0" encoding="utf-8"?>
-<p:sld xmlns:a="http://schemas.openxmlformats.org/drawingml/2006/main" xmlns:p="http://schemas.openxmlformats.org/presentationml/2006/main" xmlns:r="http://schemas.openxmlformats.org/officeDocument/2006/relationships">
-  <p:cSld>
-    <p:spTree>
-      <p:nvGrpSpPr>
-        <p:cNvPr id="1" name=""/>
-        <p:cNvGrpSpPr/>
-        <p:nvPr/>
-      </p:nvGrpSpPr>
-      <p:grpSpPr/>
-      <p:sp>
-        <p:nvSpPr>
-          <p:cNvPr id="2" name="Rectangle 1"/>
-          <p:cNvSpPr/>
-          <p:nvPr/>
-        </p:nvSpPr>
-        <p:spPr>
-          <a:xfrm>
-            <a:off x="0" y="0"/>
-            <a:ext cx="12191695" cy="384048"/>
-          </a:xfrm>
-          <a:prstGeom prst="rect">
-            <a:avLst/>
-          </a:prstGeom>
-          <a:solidFill>
-            <a:srgbClr val="1F5C99"/>
-          </a:solidFill>
-          <a:ln>
-            <a:noFill/>
-          </a:ln>
-          <a:effectLst/>
-        </p:spPr>
-        <p:style>
-          <a:lnRef idx="1">
-            <a:schemeClr val="accent1"/>
-          </a:lnRef>
-          <a:fillRef idx="3">
-            <a:schemeClr val="accent1"/>
-          </a:fillRef>
-          <a:effectRef idx="2">
-            <a:schemeClr val="accent1"/>
-          </a:effectRef>
-          <a:fontRef idx="minor">
-            <a:schemeClr val="lt1"/>
-          </a:fontRef>
-        </p:style>
-        <p:txBody>
-          <a:bodyPr rtlCol="0" anchor="ctr"/>
-          <a:lstStyle/>
-          <a:p>
-            <a:pPr algn="ctr"/>
-          </a:p>
-        </p:txBody>
-      </p:sp>
-      <p:sp>
-        <p:nvSpPr>
-          <p:cNvPr id="3" name="TextBox 2"/>
-          <p:cNvSpPr txBox="1"/>
-          <p:nvPr/>
-        </p:nvSpPr>
-        <p:spPr>
-          <a:xfrm>
-            <a:off x="731520" y="685800"/>
-            <a:ext cx="10728655" cy="640080"/>
-          </a:xfrm>
-          <a:prstGeom prst="rect">
-            <a:avLst/>
-          </a:prstGeom>
-          <a:noFill/>
-        </p:spPr>
-        <p:txBody>
-          <a:bodyPr wrap="square" anchor="t" lIns="0" rIns="0" tIns="0" bIns="0">
-            <a:spAutoFit/>
-          </a:bodyPr>
-          <a:lstStyle/>
-          <a:p>
-            <a:pPr algn="l">
-              <a:lnSpc>
-                <a:spcPct val="125000"/>
-              </a:lnSpc>
-              <a:spcAft>
-                <a:spcPts val="0"/>
-              </a:spcAft>
-            </a:pPr>
-            <a:r>
-              <a:rPr sz="3000" b="1">
-                <a:solidFill>
-                  <a:srgbClr val="143A66"/>
-                </a:solidFill>
-                <a:latin typeface="Arial"/>
-              </a:rPr>
-              <a:t>Key Code Samples</a:t>
-            </a:r>
-          </a:p>
-        </p:txBody>
-      </p:sp>
-      <p:sp>
-        <p:nvSpPr>
-          <p:cNvPr id="4" name="TextBox 3"/>
-          <p:cNvSpPr txBox="1"/>
-          <p:nvPr/>
-        </p:nvSpPr>
-        <p:spPr>
-          <a:xfrm>
-            <a:off x="731520" y="1234440"/>
-            <a:ext cx="10728655" cy="274320"/>
-          </a:xfrm>
-          <a:prstGeom prst="rect">
-            <a:avLst/>
-          </a:prstGeom>
-          <a:noFill/>
-        </p:spPr>
-        <p:txBody>
-          <a:bodyPr wrap="square" anchor="t" lIns="0" rIns="0" tIns="0" bIns="0">
-            <a:spAutoFit/>
-          </a:bodyPr>
-          <a:lstStyle/>
-          <a:p>
-            <a:pPr algn="l">
-              <a:lnSpc>
-                <a:spcPct val="125000"/>
-              </a:lnSpc>
-              <a:spcAft>
-                <a:spcPts val="0"/>
-              </a:spcAft>
-            </a:pPr>
-            <a:r>
-              <a:rPr sz="1200" b="0">
-                <a:solidFill>
-                  <a:srgbClr val="5A6673"/>
-                </a:solidFill>
-                <a:latin typeface="Arial"/>
-              </a:rPr>
-              <a:t>The three parts examiners usually ask about: admin security, the geographic computation and refresh token rotation.</a:t>
-            </a:r>
-          </a:p>
-        </p:txBody>
-      </p:sp>
-      <p:sp>
-        <p:nvSpPr>
-          <p:cNvPr id="5" name="Rounded Rectangle 4"/>
-          <p:cNvSpPr/>
-          <p:nvPr/>
-        </p:nvSpPr>
-        <p:spPr>
-          <a:xfrm>
-            <a:off x="731520" y="1691640"/>
-            <a:ext cx="3502152" cy="3931920"/>
-          </a:xfrm>
-          <a:prstGeom prst="roundRect">
-            <a:avLst>
-              <a:gd name="adj" fmla="val 6000"/>
-            </a:avLst>
-          </a:prstGeom>
-          <a:solidFill>
-            <a:srgbClr val="F1F6FB"/>
-          </a:solidFill>
-          <a:ln w="12700">
-            <a:solidFill>
-              <a:srgbClr val="DBE6F2"/>
-            </a:solidFill>
-          </a:ln>
-          <a:effectLst/>
-        </p:spPr>
-        <p:style>
-          <a:lnRef idx="1">
-            <a:schemeClr val="accent1"/>
-          </a:lnRef>
-          <a:fillRef idx="3">
-            <a:schemeClr val="accent1"/>
-          </a:fillRef>
-          <a:effectRef idx="2">
-            <a:schemeClr val="accent1"/>
-          </a:effectRef>
-          <a:fontRef idx="minor">
-            <a:schemeClr val="lt1"/>
-          </a:fontRef>
-        </p:style>
-        <p:txBody>
-          <a:bodyPr rtlCol="0" anchor="ctr"/>
-          <a:lstStyle/>
-          <a:p>
-            <a:pPr algn="ctr"/>
-          </a:p>
-        </p:txBody>
-      </p:sp>
-      <p:sp>
-        <p:nvSpPr>
-          <p:cNvPr id="6" name="TextBox 5"/>
-          <p:cNvSpPr txBox="1"/>
-          <p:nvPr/>
-        </p:nvSpPr>
-        <p:spPr>
-          <a:xfrm>
-            <a:off x="868680" y="1828800"/>
-            <a:ext cx="3227832" cy="237744"/>
-          </a:xfrm>
-          <a:prstGeom prst="rect">
-            <a:avLst/>
-          </a:prstGeom>
-          <a:noFill/>
-        </p:spPr>
-        <p:txBody>
-          <a:bodyPr wrap="square" anchor="t" lIns="0" rIns="0" tIns="0" bIns="0">
-            <a:spAutoFit/>
-          </a:bodyPr>
-          <a:lstStyle/>
-          <a:p>
-            <a:pPr algn="l">
-              <a:lnSpc>
-                <a:spcPct val="125000"/>
-              </a:lnSpc>
-              <a:spcAft>
-                <a:spcPts val="0"/>
-              </a:spcAft>
-            </a:pPr>
-            <a:r>
-              <a:rPr sz="950" b="1">
-                <a:solidFill>
-                  <a:srgbClr val="143A66"/>
-                </a:solidFill>
-                <a:latin typeface="Arial"/>
-              </a:rPr>
-              <a:t>server/src/routes/incidents.js</a:t>
-            </a:r>
-          </a:p>
-        </p:txBody>
-      </p:sp>
-      <p:sp>
-        <p:nvSpPr>
-          <p:cNvPr id="7" name="Rounded Rectangle 6"/>
-          <p:cNvSpPr/>
-          <p:nvPr/>
-        </p:nvSpPr>
-        <p:spPr>
-          <a:xfrm>
-            <a:off x="868680" y="2121408"/>
-            <a:ext cx="3227832" cy="1650492"/>
-          </a:xfrm>
-          <a:prstGeom prst="roundRect">
-            <a:avLst>
-              <a:gd name="adj" fmla="val 6000"/>
-            </a:avLst>
-          </a:prstGeom>
-          <a:solidFill>
-            <a:srgbClr val="1B2433"/>
-          </a:solidFill>
-          <a:ln>
-            <a:noFill/>
-          </a:ln>
-          <a:effectLst/>
-        </p:spPr>
-        <p:style>
-          <a:lnRef idx="1">
-            <a:schemeClr val="accent1"/>
-          </a:lnRef>
-          <a:fillRef idx="3">
-            <a:schemeClr val="accent1"/>
-          </a:fillRef>
-          <a:effectRef idx="2">
-            <a:schemeClr val="accent1"/>
-          </a:effectRef>
-          <a:fontRef idx="minor">
-            <a:schemeClr val="lt1"/>
-          </a:fontRef>
-        </p:style>
-        <p:txBody>
-          <a:bodyPr rtlCol="0" anchor="ctr"/>
-          <a:lstStyle/>
-          <a:p>
-            <a:pPr algn="ctr"/>
-          </a:p>
-        </p:txBody>
-      </p:sp>
-      <p:sp>
-        <p:nvSpPr>
-          <p:cNvPr id="8" name="TextBox 7"/>
-          <p:cNvSpPr txBox="1"/>
-          <p:nvPr/>
-        </p:nvSpPr>
-        <p:spPr>
-          <a:xfrm>
-            <a:off x="1033272" y="2249424"/>
-            <a:ext cx="2898648" cy="1394460"/>
-          </a:xfrm>
-          <a:prstGeom prst="rect">
-            <a:avLst/>
-          </a:prstGeom>
-          <a:noFill/>
-        </p:spPr>
-        <p:txBody>
-          <a:bodyPr wrap="square" anchor="t" lIns="0" rIns="0" tIns="0" bIns="0">
-            <a:spAutoFit/>
-          </a:bodyPr>
-          <a:lstStyle/>
-          <a:p>
-            <a:pPr algn="l">
-              <a:lnSpc>
-                <a:spcPct val="115000"/>
-              </a:lnSpc>
-              <a:spcAft>
-                <a:spcPts val="100"/>
-              </a:spcAft>
-            </a:pPr>
-            <a:r>
-              <a:rPr sz="950" b="0">
-                <a:solidFill>
-                  <a:srgbClr val="D8E4F0"/>
-                </a:solidFill>
-                <a:latin typeface="Consolas"/>
-              </a:rPr>
-              <a:t>sorted.sort((a, b) =&gt; {</a:t>
-            </a:r>
-          </a:p>
-          <a:p>
-            <a:pPr algn="l">
-              <a:lnSpc>
-                <a:spcPct val="115000"/>
-              </a:lnSpc>
-              <a:spcAft>
-                <a:spcPts val="100"/>
-              </a:spcAft>
-            </a:pPr>
-            <a:r>
-              <a:rPr sz="950" b="0">
-                <a:solidFill>
-                  <a:srgbClr val="D8E4F0"/>
-                </a:solidFill>
-                <a:latin typeface="Consolas"/>
-              </a:rPr>
-              <a:t>  if (a.inRadius !== b.inRadius)</a:t>
-            </a:r>
-          </a:p>
-          <a:p>
-            <a:pPr algn="l">
-              <a:lnSpc>
-                <a:spcPct val="115000"/>
-              </a:lnSpc>
-              <a:spcAft>
-                <a:spcPts val="100"/>
-              </a:spcAft>
-            </a:pPr>
-            <a:r>
-              <a:rPr sz="950" b="0">
-                <a:solidFill>
-                  <a:srgbClr val="D8E4F0"/>
-                </a:solidFill>
-                <a:latin typeface="Consolas"/>
-              </a:rPr>
-              <a:t>    return a.inRadius ? -1 : 1;</a:t>
-            </a:r>
-          </a:p>
-          <a:p>
-            <a:pPr algn="l">
-              <a:lnSpc>
-                <a:spcPct val="115000"/>
-              </a:lnSpc>
-              <a:spcAft>
-                <a:spcPts val="100"/>
-              </a:spcAft>
-            </a:pPr>
-            <a:r>
-              <a:rPr sz="950" b="0">
-                <a:solidFill>
-                  <a:srgbClr val="D8E4F0"/>
-                </a:solidFill>
-                <a:latin typeface="Consolas"/>
-              </a:rPr>
-              <a:t>  if (a.fresh !== b.fresh)</a:t>
-            </a:r>
-          </a:p>
-          <a:p>
-            <a:pPr algn="l">
-              <a:lnSpc>
-                <a:spcPct val="115000"/>
-              </a:lnSpc>
-              <a:spcAft>
-                <a:spcPts val="100"/>
-              </a:spcAft>
-            </a:pPr>
-            <a:r>
-              <a:rPr sz="950" b="0">
-                <a:solidFill>
-                  <a:srgbClr val="D8E4F0"/>
-                </a:solidFill>
-                <a:latin typeface="Consolas"/>
-              </a:rPr>
-              <a:t>    return a.fresh ? -1 : 1;</a:t>
-            </a:r>
-          </a:p>
-          <a:p>
-            <a:pPr algn="l">
-              <a:lnSpc>
-                <a:spcPct val="115000"/>
-              </a:lnSpc>
-              <a:spcAft>
-                <a:spcPts val="100"/>
-              </a:spcAft>
-            </a:pPr>
-            <a:r>
-              <a:rPr sz="950" b="0">
-                <a:solidFill>
-                  <a:srgbClr val="D8E4F0"/>
-                </a:solidFill>
-                <a:latin typeface="Consolas"/>
-              </a:rPr>
-              <a:t>  return a.distanceM - b.distanceM;</a:t>
-            </a:r>
-          </a:p>
-          <a:p>
-            <a:pPr algn="l">
-              <a:lnSpc>
-                <a:spcPct val="115000"/>
-              </a:lnSpc>
-              <a:spcAft>
-                <a:spcPts val="100"/>
-              </a:spcAft>
-            </a:pPr>
-            <a:r>
-              <a:rPr sz="950" b="0">
-                <a:solidFill>
-                  <a:srgbClr val="D8E4F0"/>
-                </a:solidFill>
-                <a:latin typeface="Consolas"/>
-              </a:rPr>
-              <a:t>});</a:t>
-            </a:r>
-          </a:p>
-        </p:txBody>
-      </p:sp>
-      <p:sp>
-        <p:nvSpPr>
-          <p:cNvPr id="9" name="TextBox 8"/>
-          <p:cNvSpPr txBox="1"/>
-          <p:nvPr/>
-        </p:nvSpPr>
-        <p:spPr>
-          <a:xfrm>
-            <a:off x="868680" y="3881628"/>
-            <a:ext cx="3227832" cy="1371600"/>
-          </a:xfrm>
-          <a:prstGeom prst="rect">
-            <a:avLst/>
-          </a:prstGeom>
-          <a:noFill/>
-        </p:spPr>
-        <p:txBody>
-          <a:bodyPr wrap="square" anchor="t" lIns="0" rIns="0" tIns="0" bIns="0">
-            <a:spAutoFit/>
-          </a:bodyPr>
-          <a:lstStyle/>
-          <a:p>
-            <a:pPr algn="l">
-              <a:lnSpc>
-                <a:spcPct val="128000"/>
-              </a:lnSpc>
-              <a:spcAft>
-                <a:spcPts val="0"/>
-              </a:spcAft>
-            </a:pPr>
-            <a:r>
-              <a:rPr sz="1050" b="0">
-                <a:solidFill>
-                  <a:srgbClr val="5A6673"/>
-                </a:solidFill>
-                <a:latin typeface="Arial"/>
-              </a:rPr>
-              <a:t>The incident engine ranks candidates: inside the radius first, fresh transmissions before stale ones, then the shortest distance.</a:t>
-            </a:r>
-          </a:p>
-        </p:txBody>
-      </p:sp>
-      <p:sp>
-        <p:nvSpPr>
-          <p:cNvPr id="10" name="Rounded Rectangle 9"/>
-          <p:cNvSpPr/>
-          <p:nvPr/>
-        </p:nvSpPr>
-        <p:spPr>
-          <a:xfrm>
-            <a:off x="4343400" y="1691640"/>
-            <a:ext cx="3502152" cy="3931920"/>
-          </a:xfrm>
-          <a:prstGeom prst="roundRect">
-            <a:avLst>
-              <a:gd name="adj" fmla="val 6000"/>
-            </a:avLst>
-          </a:prstGeom>
-          <a:solidFill>
-            <a:srgbClr val="F1F6FB"/>
-          </a:solidFill>
-          <a:ln w="12700">
-            <a:solidFill>
-              <a:srgbClr val="DBE6F2"/>
-            </a:solidFill>
-          </a:ln>
-          <a:effectLst/>
-        </p:spPr>
-        <p:style>
-          <a:lnRef idx="1">
-            <a:schemeClr val="accent1"/>
-          </a:lnRef>
-          <a:fillRef idx="3">
-            <a:schemeClr val="accent1"/>
-          </a:fillRef>
-          <a:effectRef idx="2">
-            <a:schemeClr val="accent1"/>
-          </a:effectRef>
-          <a:fontRef idx="minor">
-            <a:schemeClr val="lt1"/>
-          </a:fontRef>
-        </p:style>
-        <p:txBody>
-          <a:bodyPr rtlCol="0" anchor="ctr"/>
-          <a:lstStyle/>
-          <a:p>
-            <a:pPr algn="ctr"/>
-          </a:p>
-        </p:txBody>
-      </p:sp>
-      <p:sp>
-        <p:nvSpPr>
-          <p:cNvPr id="11" name="TextBox 10"/>
-          <p:cNvSpPr txBox="1"/>
-          <p:nvPr/>
-        </p:nvSpPr>
-        <p:spPr>
-          <a:xfrm>
-            <a:off x="4480560" y="1828800"/>
-            <a:ext cx="3227832" cy="237744"/>
-          </a:xfrm>
-          <a:prstGeom prst="rect">
-            <a:avLst/>
-          </a:prstGeom>
-          <a:noFill/>
-        </p:spPr>
-        <p:txBody>
-          <a:bodyPr wrap="square" anchor="t" lIns="0" rIns="0" tIns="0" bIns="0">
-            <a:spAutoFit/>
-          </a:bodyPr>
-          <a:lstStyle/>
-          <a:p>
-            <a:pPr algn="l">
-              <a:lnSpc>
-                <a:spcPct val="125000"/>
-              </a:lnSpc>
-              <a:spcAft>
-                <a:spcPts val="0"/>
-              </a:spcAft>
-            </a:pPr>
-            <a:r>
-              <a:rPr sz="950" b="1">
-                <a:solidFill>
-                  <a:srgbClr val="143A66"/>
-                </a:solidFill>
-                <a:latin typeface="Arial"/>
-              </a:rPr>
-              <a:t>server/src/lib/geo.js</a:t>
-            </a:r>
-          </a:p>
-        </p:txBody>
-      </p:sp>
-      <p:sp>
-        <p:nvSpPr>
-          <p:cNvPr id="12" name="Rounded Rectangle 11"/>
-          <p:cNvSpPr/>
-          <p:nvPr/>
-        </p:nvSpPr>
-        <p:spPr>
-          <a:xfrm>
-            <a:off x="4480560" y="2121408"/>
-            <a:ext cx="3227832" cy="1453896"/>
-          </a:xfrm>
-          <a:prstGeom prst="roundRect">
-            <a:avLst>
-              <a:gd name="adj" fmla="val 6000"/>
-            </a:avLst>
-          </a:prstGeom>
-          <a:solidFill>
-            <a:srgbClr val="1B2433"/>
-          </a:solidFill>
-          <a:ln>
-            <a:noFill/>
-          </a:ln>
-          <a:effectLst/>
-        </p:spPr>
-        <p:style>
-          <a:lnRef idx="1">
-            <a:schemeClr val="accent1"/>
-          </a:lnRef>
-          <a:fillRef idx="3">
-            <a:schemeClr val="accent1"/>
-          </a:fillRef>
-          <a:effectRef idx="2">
-            <a:schemeClr val="accent1"/>
-          </a:effectRef>
-          <a:fontRef idx="minor">
-            <a:schemeClr val="lt1"/>
-          </a:fontRef>
-        </p:style>
-        <p:txBody>
-          <a:bodyPr rtlCol="0" anchor="ctr"/>
-          <a:lstStyle/>
-          <a:p>
-            <a:pPr algn="ctr"/>
-          </a:p>
-        </p:txBody>
-      </p:sp>
-      <p:sp>
-        <p:nvSpPr>
-          <p:cNvPr id="13" name="TextBox 12"/>
-          <p:cNvSpPr txBox="1"/>
-          <p:nvPr/>
-        </p:nvSpPr>
-        <p:spPr>
-          <a:xfrm>
-            <a:off x="4645152" y="2249424"/>
-            <a:ext cx="2898648" cy="1197864"/>
-          </a:xfrm>
-          <a:prstGeom prst="rect">
-            <a:avLst/>
-          </a:prstGeom>
-          <a:noFill/>
-        </p:spPr>
-        <p:txBody>
-          <a:bodyPr wrap="square" anchor="t" lIns="0" rIns="0" tIns="0" bIns="0">
-            <a:spAutoFit/>
-          </a:bodyPr>
-          <a:lstStyle/>
-          <a:p>
-            <a:pPr algn="l">
-              <a:lnSpc>
-                <a:spcPct val="115000"/>
-              </a:lnSpc>
-              <a:spcAft>
-                <a:spcPts val="100"/>
-              </a:spcAft>
-            </a:pPr>
-            <a:r>
-              <a:rPr sz="950" b="0">
-                <a:solidFill>
-                  <a:srgbClr val="D8E4F0"/>
-                </a:solidFill>
-                <a:latin typeface="Consolas"/>
-              </a:rPr>
-              <a:t>const a =</a:t>
-            </a:r>
-          </a:p>
-          <a:p>
-            <a:pPr algn="l">
-              <a:lnSpc>
-                <a:spcPct val="115000"/>
-              </a:lnSpc>
-              <a:spcAft>
-                <a:spcPts val="100"/>
-              </a:spcAft>
-            </a:pPr>
-            <a:r>
-              <a:rPr sz="950" b="0">
-                <a:solidFill>
-                  <a:srgbClr val="D8E4F0"/>
-                </a:solidFill>
-                <a:latin typeface="Consolas"/>
-              </a:rPr>
-              <a:t>  Math.sin(dLat / 2) ** 2 +</a:t>
-            </a:r>
-          </a:p>
-          <a:p>
-            <a:pPr algn="l">
-              <a:lnSpc>
-                <a:spcPct val="115000"/>
-              </a:lnSpc>
-              <a:spcAft>
-                <a:spcPts val="100"/>
-              </a:spcAft>
-            </a:pPr>
-            <a:r>
-              <a:rPr sz="950" b="0">
-                <a:solidFill>
-                  <a:srgbClr val="D8E4F0"/>
-                </a:solidFill>
-                <a:latin typeface="Consolas"/>
-              </a:rPr>
-              <a:t>  Math.cos(la1) * Math.cos(la2) *</a:t>
-            </a:r>
-          </a:p>
-          <a:p>
-            <a:pPr algn="l">
-              <a:lnSpc>
-                <a:spcPct val="115000"/>
-              </a:lnSpc>
-              <a:spcAft>
-                <a:spcPts val="100"/>
-              </a:spcAft>
-            </a:pPr>
-            <a:r>
-              <a:rPr sz="950" b="0">
-                <a:solidFill>
-                  <a:srgbClr val="D8E4F0"/>
-                </a:solidFill>
-                <a:latin typeface="Consolas"/>
-              </a:rPr>
-              <a:t>  Math.sin(dLng / 2) ** 2;</a:t>
-            </a:r>
-          </a:p>
-          <a:p>
-            <a:pPr algn="l">
-              <a:lnSpc>
-                <a:spcPct val="115000"/>
-              </a:lnSpc>
-              <a:spcAft>
-                <a:spcPts val="100"/>
-              </a:spcAft>
-            </a:pPr>
-            <a:r>
-              <a:rPr sz="950" b="0">
-                <a:solidFill>
-                  <a:srgbClr val="D8E4F0"/>
-                </a:solidFill>
-                <a:latin typeface="Consolas"/>
-              </a:rPr>
-              <a:t>return 2 * EARTH_RADIUS_M *</a:t>
-            </a:r>
-          </a:p>
-          <a:p>
-            <a:pPr algn="l">
-              <a:lnSpc>
-                <a:spcPct val="115000"/>
-              </a:lnSpc>
-              <a:spcAft>
-                <a:spcPts val="100"/>
-              </a:spcAft>
-            </a:pPr>
-            <a:r>
-              <a:rPr sz="950" b="0">
-                <a:solidFill>
-                  <a:srgbClr val="D8E4F0"/>
-                </a:solidFill>
-                <a:latin typeface="Consolas"/>
-              </a:rPr>
-              <a:t>  Math.asin(Math.sqrt(a));</a:t>
-            </a:r>
-          </a:p>
-        </p:txBody>
-      </p:sp>
-      <p:sp>
-        <p:nvSpPr>
-          <p:cNvPr id="14" name="TextBox 13"/>
-          <p:cNvSpPr txBox="1"/>
-          <p:nvPr/>
-        </p:nvSpPr>
-        <p:spPr>
-          <a:xfrm>
-            <a:off x="4480560" y="3685032"/>
-            <a:ext cx="3227832" cy="1371600"/>
-          </a:xfrm>
-          <a:prstGeom prst="rect">
-            <a:avLst/>
-          </a:prstGeom>
-          <a:noFill/>
-        </p:spPr>
-        <p:txBody>
-          <a:bodyPr wrap="square" anchor="t" lIns="0" rIns="0" tIns="0" bIns="0">
-            <a:spAutoFit/>
-          </a:bodyPr>
-          <a:lstStyle/>
-          <a:p>
-            <a:pPr algn="l">
-              <a:lnSpc>
-                <a:spcPct val="128000"/>
-              </a:lnSpc>
-              <a:spcAft>
-                <a:spcPts val="0"/>
-              </a:spcAft>
-            </a:pPr>
-            <a:r>
-              <a:rPr sz="1050" b="0">
-                <a:solidFill>
-                  <a:srgbClr val="5A6673"/>
-                </a:solidFill>
-                <a:latin typeface="Arial"/>
-              </a:rPr>
-              <a:t>The Haversine formula: distance over the surface of the Earth between the distress point and each device.</a:t>
-            </a:r>
-          </a:p>
-        </p:txBody>
-      </p:sp>
-      <p:sp>
-        <p:nvSpPr>
-          <p:cNvPr id="15" name="Rounded Rectangle 14"/>
-          <p:cNvSpPr/>
-          <p:nvPr/>
-        </p:nvSpPr>
-        <p:spPr>
-          <a:xfrm>
-            <a:off x="7955279" y="1691640"/>
-            <a:ext cx="3502152" cy="3931920"/>
-          </a:xfrm>
-          <a:prstGeom prst="roundRect">
-            <a:avLst>
-              <a:gd name="adj" fmla="val 6000"/>
-            </a:avLst>
-          </a:prstGeom>
-          <a:solidFill>
-            <a:srgbClr val="F1F6FB"/>
-          </a:solidFill>
-          <a:ln w="12700">
-            <a:solidFill>
-              <a:srgbClr val="DBE6F2"/>
-            </a:solidFill>
-          </a:ln>
-          <a:effectLst/>
-        </p:spPr>
-        <p:style>
-          <a:lnRef idx="1">
-            <a:schemeClr val="accent1"/>
-          </a:lnRef>
-          <a:fillRef idx="3">
-            <a:schemeClr val="accent1"/>
-          </a:fillRef>
-          <a:effectRef idx="2">
-            <a:schemeClr val="accent1"/>
-          </a:effectRef>
-          <a:fontRef idx="minor">
-            <a:schemeClr val="lt1"/>
-          </a:fontRef>
-        </p:style>
-        <p:txBody>
-          <a:bodyPr rtlCol="0" anchor="ctr"/>
-          <a:lstStyle/>
-          <a:p>
-            <a:pPr algn="ctr"/>
-          </a:p>
-        </p:txBody>
-      </p:sp>
-      <p:sp>
-        <p:nvSpPr>
-          <p:cNvPr id="16" name="TextBox 15"/>
-          <p:cNvSpPr txBox="1"/>
-          <p:nvPr/>
-        </p:nvSpPr>
-        <p:spPr>
-          <a:xfrm>
-            <a:off x="8092440" y="1828800"/>
-            <a:ext cx="3227832" cy="237744"/>
-          </a:xfrm>
-          <a:prstGeom prst="rect">
-            <a:avLst/>
-          </a:prstGeom>
-          <a:noFill/>
-        </p:spPr>
-        <p:txBody>
-          <a:bodyPr wrap="square" anchor="t" lIns="0" rIns="0" tIns="0" bIns="0">
-            <a:spAutoFit/>
-          </a:bodyPr>
-          <a:lstStyle/>
-          <a:p>
-            <a:pPr algn="l">
-              <a:lnSpc>
-                <a:spcPct val="125000"/>
-              </a:lnSpc>
-              <a:spcAft>
-                <a:spcPts val="0"/>
-              </a:spcAft>
-            </a:pPr>
-            <a:r>
-              <a:rPr sz="950" b="1">
-                <a:solidFill>
-                  <a:srgbClr val="143A66"/>
-                </a:solidFill>
-                <a:latin typeface="Arial"/>
-              </a:rPr>
-              <a:t>server/src/routes/auth.js</a:t>
-            </a:r>
-          </a:p>
-        </p:txBody>
-      </p:sp>
-      <p:sp>
-        <p:nvSpPr>
-          <p:cNvPr id="17" name="Rounded Rectangle 16"/>
-          <p:cNvSpPr/>
-          <p:nvPr/>
-        </p:nvSpPr>
-        <p:spPr>
-          <a:xfrm>
-            <a:off x="8092440" y="2121408"/>
-            <a:ext cx="3227832" cy="1650492"/>
-          </a:xfrm>
-          <a:prstGeom prst="roundRect">
-            <a:avLst>
-              <a:gd name="adj" fmla="val 6000"/>
-            </a:avLst>
-          </a:prstGeom>
-          <a:solidFill>
-            <a:srgbClr val="1B2433"/>
-          </a:solidFill>
-          <a:ln>
-            <a:noFill/>
-          </a:ln>
-          <a:effectLst/>
-        </p:spPr>
-        <p:style>
-          <a:lnRef idx="1">
-            <a:schemeClr val="accent1"/>
-          </a:lnRef>
-          <a:fillRef idx="3">
-            <a:schemeClr val="accent1"/>
-          </a:fillRef>
-          <a:effectRef idx="2">
-            <a:schemeClr val="accent1"/>
-          </a:effectRef>
-          <a:fontRef idx="minor">
-            <a:schemeClr val="lt1"/>
-          </a:fontRef>
-        </p:style>
-        <p:txBody>
-          <a:bodyPr rtlCol="0" anchor="ctr"/>
-          <a:lstStyle/>
-          <a:p>
-            <a:pPr algn="ctr"/>
-          </a:p>
-        </p:txBody>
-      </p:sp>
-      <p:sp>
-        <p:nvSpPr>
-          <p:cNvPr id="18" name="TextBox 17"/>
-          <p:cNvSpPr txBox="1"/>
-          <p:nvPr/>
-        </p:nvSpPr>
-        <p:spPr>
-          <a:xfrm>
-            <a:off x="8257031" y="2249424"/>
-            <a:ext cx="2898648" cy="1394460"/>
-          </a:xfrm>
-          <a:prstGeom prst="rect">
-            <a:avLst/>
-          </a:prstGeom>
-          <a:noFill/>
-        </p:spPr>
-        <p:txBody>
-          <a:bodyPr wrap="square" anchor="t" lIns="0" rIns="0" tIns="0" bIns="0">
-            <a:spAutoFit/>
-          </a:bodyPr>
-          <a:lstStyle/>
-          <a:p>
-            <a:pPr algn="l">
-              <a:lnSpc>
-                <a:spcPct val="115000"/>
-              </a:lnSpc>
-              <a:spcAft>
-                <a:spcPts val="100"/>
-              </a:spcAft>
-            </a:pPr>
-            <a:r>
-              <a:rPr sz="950" b="0">
-                <a:solidFill>
-                  <a:srgbClr val="D8E4F0"/>
-                </a:solidFill>
-                <a:latin typeface="Consolas"/>
-              </a:rPr>
-              <a:t>db.transaction(() =&gt; {</a:t>
-            </a:r>
-          </a:p>
-          <a:p>
-            <a:pPr algn="l">
-              <a:lnSpc>
-                <a:spcPct val="115000"/>
-              </a:lnSpc>
-              <a:spcAft>
-                <a:spcPts val="100"/>
-              </a:spcAft>
-            </a:pPr>
-            <a:r>
-              <a:rPr sz="950" b="0">
-                <a:solidFill>
-                  <a:srgbClr val="D8E4F0"/>
-                </a:solidFill>
-                <a:latin typeface="Consolas"/>
-              </a:rPr>
-              <a:t>  db.prepare(</a:t>
-            </a:r>
-          </a:p>
-          <a:p>
-            <a:pPr algn="l">
-              <a:lnSpc>
-                <a:spcPct val="115000"/>
-              </a:lnSpc>
-              <a:spcAft>
-                <a:spcPts val="100"/>
-              </a:spcAft>
-            </a:pPr>
-            <a:r>
-              <a:rPr sz="950" b="0">
-                <a:solidFill>
-                  <a:srgbClr val="D8E4F0"/>
-                </a:solidFill>
-                <a:latin typeface="Consolas"/>
-              </a:rPr>
-              <a:t>    'UPDATE refresh_tokens ' +</a:t>
-            </a:r>
-          </a:p>
-          <a:p>
-            <a:pPr algn="l">
-              <a:lnSpc>
-                <a:spcPct val="115000"/>
-              </a:lnSpc>
-              <a:spcAft>
-                <a:spcPts val="100"/>
-              </a:spcAft>
-            </a:pPr>
-            <a:r>
-              <a:rPr sz="950" b="0">
-                <a:solidFill>
-                  <a:srgbClr val="D8E4F0"/>
-                </a:solidFill>
-                <a:latin typeface="Consolas"/>
-              </a:rPr>
-              <a:t>    'SET revoked = 1 WHERE jti = ?'</a:t>
-            </a:r>
-          </a:p>
-          <a:p>
-            <a:pPr algn="l">
-              <a:lnSpc>
-                <a:spcPct val="115000"/>
-              </a:lnSpc>
-              <a:spcAft>
-                <a:spcPts val="100"/>
-              </a:spcAft>
-            </a:pPr>
-            <a:r>
-              <a:rPr sz="950" b="0">
-                <a:solidFill>
-                  <a:srgbClr val="D8E4F0"/>
-                </a:solidFill>
-                <a:latin typeface="Consolas"/>
-              </a:rPr>
-              <a:t>  ).run(session.jti);</a:t>
-            </a:r>
-          </a:p>
-          <a:p>
-            <a:pPr algn="l">
-              <a:lnSpc>
-                <a:spcPct val="115000"/>
-              </a:lnSpc>
-              <a:spcAft>
-                <a:spcPts val="100"/>
-              </a:spcAft>
-            </a:pPr>
-            <a:r>
-              <a:rPr sz="950" b="0">
-                <a:solidFill>
-                  <a:srgbClr val="D8E4F0"/>
-                </a:solidFill>
-                <a:latin typeface="Consolas"/>
-              </a:rPr>
-              <a:t>  issueRefreshToken(res, user);</a:t>
-            </a:r>
-          </a:p>
-          <a:p>
-            <a:pPr algn="l">
-              <a:lnSpc>
-                <a:spcPct val="115000"/>
-              </a:lnSpc>
-              <a:spcAft>
-                <a:spcPts val="100"/>
-              </a:spcAft>
-            </a:pPr>
-            <a:r>
-              <a:rPr sz="950" b="0">
-                <a:solidFill>
-                  <a:srgbClr val="D8E4F0"/>
-                </a:solidFill>
-                <a:latin typeface="Consolas"/>
-              </a:rPr>
-              <a:t>})();</a:t>
-            </a:r>
-          </a:p>
-        </p:txBody>
-      </p:sp>
-      <p:sp>
-        <p:nvSpPr>
-          <p:cNvPr id="19" name="TextBox 18"/>
-          <p:cNvSpPr txBox="1"/>
-          <p:nvPr/>
-        </p:nvSpPr>
-        <p:spPr>
-          <a:xfrm>
-            <a:off x="8092440" y="3881628"/>
-            <a:ext cx="3227832" cy="1371600"/>
-          </a:xfrm>
-          <a:prstGeom prst="rect">
-            <a:avLst/>
-          </a:prstGeom>
-          <a:noFill/>
-        </p:spPr>
-        <p:txBody>
-          <a:bodyPr wrap="square" anchor="t" lIns="0" rIns="0" tIns="0" bIns="0">
-            <a:spAutoFit/>
-          </a:bodyPr>
-          <a:lstStyle/>
-          <a:p>
-            <a:pPr algn="l">
-              <a:lnSpc>
-                <a:spcPct val="128000"/>
-              </a:lnSpc>
-              <a:spcAft>
-                <a:spcPts val="0"/>
-              </a:spcAft>
-            </a:pPr>
-            <a:r>
-              <a:rPr sz="1050" b="0">
-                <a:solidFill>
-                  <a:srgbClr val="5A6673"/>
-                </a:solidFill>
-                <a:latin typeface="Arial"/>
-              </a:rPr>
-              <a:t>Rotation: every refresh token is single use, so a stolen token fails the moment it is reused.</a:t>
-            </a:r>
-          </a:p>
-        </p:txBody>
-      </p:sp>
-      <p:sp>
-        <p:nvSpPr>
-          <p:cNvPr id="20" name="Rounded Rectangle 19"/>
-          <p:cNvSpPr/>
-          <p:nvPr/>
-        </p:nvSpPr>
-        <p:spPr>
-          <a:xfrm>
-            <a:off x="731520" y="5760720"/>
-            <a:ext cx="10725912" cy="566928"/>
-          </a:xfrm>
-          <a:prstGeom prst="roundRect">
-            <a:avLst>
-              <a:gd name="adj" fmla="val 6000"/>
-            </a:avLst>
-          </a:prstGeom>
-          <a:solidFill>
-            <a:srgbClr val="F1F6FB"/>
-          </a:solidFill>
-          <a:ln w="12700">
-            <a:solidFill>
-              <a:srgbClr val="DBE6F2"/>
-            </a:solidFill>
-          </a:ln>
-          <a:effectLst/>
-        </p:spPr>
-        <p:style>
-          <a:lnRef idx="1">
-            <a:schemeClr val="accent1"/>
-          </a:lnRef>
-          <a:fillRef idx="3">
-            <a:schemeClr val="accent1"/>
-          </a:fillRef>
-          <a:effectRef idx="2">
-            <a:schemeClr val="accent1"/>
-          </a:effectRef>
-          <a:fontRef idx="minor">
-            <a:schemeClr val="lt1"/>
-          </a:fontRef>
-        </p:style>
-        <p:txBody>
-          <a:bodyPr rtlCol="0" anchor="ctr"/>
-          <a:lstStyle/>
-          <a:p>
-            <a:pPr algn="ctr"/>
-          </a:p>
-        </p:txBody>
-      </p:sp>
-      <p:sp>
-        <p:nvSpPr>
-          <p:cNvPr id="21" name="TextBox 20"/>
-          <p:cNvSpPr txBox="1"/>
-          <p:nvPr/>
-        </p:nvSpPr>
-        <p:spPr>
-          <a:xfrm>
-            <a:off x="960120" y="5833872"/>
-            <a:ext cx="10287000" cy="219456"/>
-          </a:xfrm>
-          <a:prstGeom prst="rect">
-            <a:avLst/>
-          </a:prstGeom>
-          <a:noFill/>
-        </p:spPr>
-        <p:txBody>
-          <a:bodyPr wrap="square" anchor="t" lIns="0" rIns="0" tIns="0" bIns="0">
-            <a:spAutoFit/>
-          </a:bodyPr>
-          <a:lstStyle/>
-          <a:p>
-            <a:pPr algn="l">
-              <a:lnSpc>
-                <a:spcPct val="125000"/>
-              </a:lnSpc>
-              <a:spcAft>
-                <a:spcPts val="0"/>
-              </a:spcAft>
-            </a:pPr>
-            <a:r>
-              <a:rPr sz="1100" b="1">
-                <a:solidFill>
-                  <a:srgbClr val="1F5C99"/>
-                </a:solidFill>
-                <a:latin typeface="Arial"/>
-              </a:rPr>
-              <a:t>Other key files</a:t>
-            </a:r>
-          </a:p>
-        </p:txBody>
-      </p:sp>
-      <p:sp>
-        <p:nvSpPr>
-          <p:cNvPr id="22" name="TextBox 21"/>
-          <p:cNvSpPr txBox="1"/>
-          <p:nvPr/>
-        </p:nvSpPr>
-        <p:spPr>
-          <a:xfrm>
-            <a:off x="960120" y="6071616"/>
-            <a:ext cx="10287000" cy="219456"/>
-          </a:xfrm>
-          <a:prstGeom prst="rect">
-            <a:avLst/>
-          </a:prstGeom>
-          <a:noFill/>
-        </p:spPr>
-        <p:txBody>
-          <a:bodyPr wrap="square" anchor="t" lIns="0" rIns="0" tIns="0" bIns="0">
-            <a:spAutoFit/>
-          </a:bodyPr>
-          <a:lstStyle/>
-          <a:p>
-            <a:pPr algn="l">
-              <a:lnSpc>
-                <a:spcPct val="125000"/>
-              </a:lnSpc>
-              <a:spcAft>
-                <a:spcPts val="0"/>
-              </a:spcAft>
-            </a:pPr>
-            <a:r>
-              <a:rPr sz="900" b="0">
-                <a:solidFill>
-                  <a:srgbClr val="5A6673"/>
-                </a:solidFill>
-                <a:latin typeface="Arial"/>
-              </a:rPr>
-              <a:t>server/src/routes/registry.js | server/src/db/sqlite.js | server/src/db/mongo.js | server/src/lib/silent-update.js | web/components/map/SimulatorApp.jsx | web/lib/api.js</a:t>
-            </a:r>
-          </a:p>
-        </p:txBody>
-      </p:sp>
-      <p:sp>
-        <p:nvSpPr>
-          <p:cNvPr id="23" name="TextBox 22"/>
-          <p:cNvSpPr txBox="1"/>
-          <p:nvPr/>
-        </p:nvSpPr>
-        <p:spPr>
-          <a:xfrm>
-            <a:off x="548640" y="6446520"/>
-            <a:ext cx="3657600" cy="274320"/>
-          </a:xfrm>
-          <a:prstGeom prst="rect">
-            <a:avLst/>
-          </a:prstGeom>
-          <a:noFill/>
-        </p:spPr>
-        <p:txBody>
-          <a:bodyPr wrap="square" anchor="t" lIns="0" rIns="0" tIns="0" bIns="0">
-            <a:spAutoFit/>
-          </a:bodyPr>
-          <a:lstStyle/>
-          <a:p>
-            <a:pPr algn="l">
-              <a:lnSpc>
-                <a:spcPct val="125000"/>
-              </a:lnSpc>
-              <a:spcAft>
-                <a:spcPts val="0"/>
-              </a:spcAft>
-            </a:pPr>
-            <a:r>
-              <a:rPr sz="1000" b="0">
-                <a:solidFill>
-                  <a:srgbClr val="5A6673"/>
-                </a:solidFill>
-                <a:latin typeface="Arial"/>
-              </a:rPr>
-              <a:t>DefiNet | WEB 2026</a:t>
-            </a:r>
-          </a:p>
-        </p:txBody>
-      </p:sp>
-      <p:sp>
-        <p:nvSpPr>
-          <p:cNvPr id="24" name="TextBox 23"/>
-          <p:cNvSpPr txBox="1"/>
-          <p:nvPr/>
-        </p:nvSpPr>
-        <p:spPr>
-          <a:xfrm>
-            <a:off x="10728655" y="6446520"/>
-            <a:ext cx="914400" cy="274320"/>
-          </a:xfrm>
-          <a:prstGeom prst="rect">
-            <a:avLst/>
-          </a:prstGeom>
-          <a:noFill/>
-        </p:spPr>
-        <p:txBody>
-          <a:bodyPr wrap="square" anchor="t" lIns="0" rIns="0" tIns="0" bIns="0">
-            <a:spAutoFit/>
-          </a:bodyPr>
-          <a:lstStyle/>
-          <a:p>
-            <a:pPr algn="r">
-              <a:lnSpc>
-                <a:spcPct val="125000"/>
-              </a:lnSpc>
-              <a:spcAft>
-                <a:spcPts val="0"/>
-              </a:spcAft>
-            </a:pPr>
-            <a:r>
-              <a:rPr sz="1000" b="0">
-                <a:solidFill>
-                  <a:srgbClr val="5A6673"/>
-                </a:solidFill>
-                <a:latin typeface="Arial"/>
-              </a:rPr>
-              <a:t>5 / 5</a:t>
+              <a:t>4 / 4</a:t>
             </a:r>
           </a:p>
         </p:txBody>

</xml_diff>

<commit_message>
docs: restore the code-samples page (final 5-slide deck)
The submission spec asks for sample sections from the project, so page 5
returns: the ranking sort, the haversine computation and the refresh token
rotation transaction, each with a one-line caption. Verified by rendering.

Co-Authored-By: Claude Fable 5 <noreply@anthropic.com>
</commit_message>
<xml_diff>
--- a/docs/DefiNet-Defense-Deck.pptx
+++ b/docs/DefiNet-Defense-Deck.pptx
@@ -9,6 +9,7 @@
     <p:sldId id="257" r:id="rId8"/>
     <p:sldId id="258" r:id="rId9"/>
     <p:sldId id="259" r:id="rId10"/>
+    <p:sldId id="260" r:id="rId11"/>
   </p:sldIdLst>
   <p:sldSz cx="12191695" cy="6858000" type="screen4x3"/>
   <p:notesSz cx="6858000" cy="9144000"/>
@@ -4596,7 +4597,7 @@
                 </a:solidFill>
                 <a:latin typeface="Arial"/>
               </a:rPr>
-              <a:t>1 / 4</a:t>
+              <a:t>1 / 5</a:t>
             </a:r>
           </a:p>
         </p:txBody>
@@ -5393,7 +5394,7 @@
                 </a:solidFill>
                 <a:latin typeface="Arial"/>
               </a:rPr>
-              <a:t>2 / 4</a:t>
+              <a:t>2 / 5</a:t>
             </a:r>
           </a:p>
         </p:txBody>
@@ -6011,7 +6012,7 @@
                 </a:solidFill>
                 <a:latin typeface="Arial"/>
               </a:rPr>
-              <a:t>3 / 4</a:t>
+              <a:t>3 / 5</a:t>
             </a:r>
           </a:p>
         </p:txBody>
@@ -7346,7 +7347,1352 @@
                 </a:solidFill>
                 <a:latin typeface="Arial"/>
               </a:rPr>
-              <a:t>4 / 4</a:t>
+              <a:t>4 / 5</a:t>
+            </a:r>
+          </a:p>
+        </p:txBody>
+      </p:sp>
+    </p:spTree>
+  </p:cSld>
+  <p:clrMapOvr>
+    <a:masterClrMapping/>
+  </p:clrMapOvr>
+</p:sld>
+</file>
+
+<file path=ppt/slides/slide5.xml><?xml version="1.0" encoding="utf-8"?>
+<p:sld xmlns:a="http://schemas.openxmlformats.org/drawingml/2006/main" xmlns:p="http://schemas.openxmlformats.org/presentationml/2006/main" xmlns:r="http://schemas.openxmlformats.org/officeDocument/2006/relationships">
+  <p:cSld>
+    <p:spTree>
+      <p:nvGrpSpPr>
+        <p:cNvPr id="1" name=""/>
+        <p:cNvGrpSpPr/>
+        <p:nvPr/>
+      </p:nvGrpSpPr>
+      <p:grpSpPr/>
+      <p:sp>
+        <p:nvSpPr>
+          <p:cNvPr id="2" name="Rectangle 1"/>
+          <p:cNvSpPr/>
+          <p:nvPr/>
+        </p:nvSpPr>
+        <p:spPr>
+          <a:xfrm>
+            <a:off x="0" y="0"/>
+            <a:ext cx="12191695" cy="384048"/>
+          </a:xfrm>
+          <a:prstGeom prst="rect">
+            <a:avLst/>
+          </a:prstGeom>
+          <a:solidFill>
+            <a:srgbClr val="1F5C99"/>
+          </a:solidFill>
+          <a:ln>
+            <a:noFill/>
+          </a:ln>
+          <a:effectLst/>
+        </p:spPr>
+        <p:style>
+          <a:lnRef idx="1">
+            <a:schemeClr val="accent1"/>
+          </a:lnRef>
+          <a:fillRef idx="3">
+            <a:schemeClr val="accent1"/>
+          </a:fillRef>
+          <a:effectRef idx="2">
+            <a:schemeClr val="accent1"/>
+          </a:effectRef>
+          <a:fontRef idx="minor">
+            <a:schemeClr val="lt1"/>
+          </a:fontRef>
+        </p:style>
+        <p:txBody>
+          <a:bodyPr rtlCol="0" anchor="ctr"/>
+          <a:lstStyle/>
+          <a:p>
+            <a:pPr algn="ctr"/>
+          </a:p>
+        </p:txBody>
+      </p:sp>
+      <p:sp>
+        <p:nvSpPr>
+          <p:cNvPr id="3" name="TextBox 2"/>
+          <p:cNvSpPr txBox="1"/>
+          <p:nvPr/>
+        </p:nvSpPr>
+        <p:spPr>
+          <a:xfrm>
+            <a:off x="731520" y="685800"/>
+            <a:ext cx="10728655" cy="640080"/>
+          </a:xfrm>
+          <a:prstGeom prst="rect">
+            <a:avLst/>
+          </a:prstGeom>
+          <a:noFill/>
+        </p:spPr>
+        <p:txBody>
+          <a:bodyPr wrap="square" anchor="t" lIns="0" rIns="0" tIns="0" bIns="0">
+            <a:spAutoFit/>
+          </a:bodyPr>
+          <a:lstStyle/>
+          <a:p>
+            <a:pPr algn="l">
+              <a:lnSpc>
+                <a:spcPct val="125000"/>
+              </a:lnSpc>
+              <a:spcAft>
+                <a:spcPts val="0"/>
+              </a:spcAft>
+            </a:pPr>
+            <a:r>
+              <a:rPr sz="3000" b="1">
+                <a:solidFill>
+                  <a:srgbClr val="143A66"/>
+                </a:solidFill>
+                <a:latin typeface="Arial"/>
+              </a:rPr>
+              <a:t>Key Code Samples</a:t>
+            </a:r>
+          </a:p>
+        </p:txBody>
+      </p:sp>
+      <p:sp>
+        <p:nvSpPr>
+          <p:cNvPr id="4" name="TextBox 3"/>
+          <p:cNvSpPr txBox="1"/>
+          <p:nvPr/>
+        </p:nvSpPr>
+        <p:spPr>
+          <a:xfrm>
+            <a:off x="731520" y="1234440"/>
+            <a:ext cx="10728655" cy="274320"/>
+          </a:xfrm>
+          <a:prstGeom prst="rect">
+            <a:avLst/>
+          </a:prstGeom>
+          <a:noFill/>
+        </p:spPr>
+        <p:txBody>
+          <a:bodyPr wrap="square" anchor="t" lIns="0" rIns="0" tIns="0" bIns="0">
+            <a:spAutoFit/>
+          </a:bodyPr>
+          <a:lstStyle/>
+          <a:p>
+            <a:pPr algn="l">
+              <a:lnSpc>
+                <a:spcPct val="125000"/>
+              </a:lnSpc>
+              <a:spcAft>
+                <a:spcPts val="0"/>
+              </a:spcAft>
+            </a:pPr>
+            <a:r>
+              <a:rPr sz="1200" b="0">
+                <a:solidFill>
+                  <a:srgbClr val="5A6673"/>
+                </a:solidFill>
+                <a:latin typeface="Arial"/>
+              </a:rPr>
+              <a:t>The three parts examiners usually ask about: the incident engine, the geographic computation and refresh token rotation.</a:t>
+            </a:r>
+          </a:p>
+        </p:txBody>
+      </p:sp>
+      <p:sp>
+        <p:nvSpPr>
+          <p:cNvPr id="5" name="Rounded Rectangle 4"/>
+          <p:cNvSpPr/>
+          <p:nvPr/>
+        </p:nvSpPr>
+        <p:spPr>
+          <a:xfrm>
+            <a:off x="731520" y="1691640"/>
+            <a:ext cx="3502152" cy="3931920"/>
+          </a:xfrm>
+          <a:prstGeom prst="roundRect">
+            <a:avLst>
+              <a:gd name="adj" fmla="val 6000"/>
+            </a:avLst>
+          </a:prstGeom>
+          <a:solidFill>
+            <a:srgbClr val="F1F6FB"/>
+          </a:solidFill>
+          <a:ln w="12700">
+            <a:solidFill>
+              <a:srgbClr val="DBE6F2"/>
+            </a:solidFill>
+          </a:ln>
+          <a:effectLst/>
+        </p:spPr>
+        <p:style>
+          <a:lnRef idx="1">
+            <a:schemeClr val="accent1"/>
+          </a:lnRef>
+          <a:fillRef idx="3">
+            <a:schemeClr val="accent1"/>
+          </a:fillRef>
+          <a:effectRef idx="2">
+            <a:schemeClr val="accent1"/>
+          </a:effectRef>
+          <a:fontRef idx="minor">
+            <a:schemeClr val="lt1"/>
+          </a:fontRef>
+        </p:style>
+        <p:txBody>
+          <a:bodyPr rtlCol="0" anchor="ctr"/>
+          <a:lstStyle/>
+          <a:p>
+            <a:pPr algn="ctr"/>
+          </a:p>
+        </p:txBody>
+      </p:sp>
+      <p:sp>
+        <p:nvSpPr>
+          <p:cNvPr id="6" name="TextBox 5"/>
+          <p:cNvSpPr txBox="1"/>
+          <p:nvPr/>
+        </p:nvSpPr>
+        <p:spPr>
+          <a:xfrm>
+            <a:off x="868680" y="1828800"/>
+            <a:ext cx="3227832" cy="237744"/>
+          </a:xfrm>
+          <a:prstGeom prst="rect">
+            <a:avLst/>
+          </a:prstGeom>
+          <a:noFill/>
+        </p:spPr>
+        <p:txBody>
+          <a:bodyPr wrap="square" anchor="t" lIns="0" rIns="0" tIns="0" bIns="0">
+            <a:spAutoFit/>
+          </a:bodyPr>
+          <a:lstStyle/>
+          <a:p>
+            <a:pPr algn="l">
+              <a:lnSpc>
+                <a:spcPct val="125000"/>
+              </a:lnSpc>
+              <a:spcAft>
+                <a:spcPts val="0"/>
+              </a:spcAft>
+            </a:pPr>
+            <a:r>
+              <a:rPr sz="950" b="1">
+                <a:solidFill>
+                  <a:srgbClr val="143A66"/>
+                </a:solidFill>
+                <a:latin typeface="Arial"/>
+              </a:rPr>
+              <a:t>server/src/routes/incidents.js</a:t>
+            </a:r>
+          </a:p>
+        </p:txBody>
+      </p:sp>
+      <p:sp>
+        <p:nvSpPr>
+          <p:cNvPr id="7" name="Rounded Rectangle 6"/>
+          <p:cNvSpPr/>
+          <p:nvPr/>
+        </p:nvSpPr>
+        <p:spPr>
+          <a:xfrm>
+            <a:off x="868680" y="2121408"/>
+            <a:ext cx="3227832" cy="1650492"/>
+          </a:xfrm>
+          <a:prstGeom prst="roundRect">
+            <a:avLst>
+              <a:gd name="adj" fmla="val 6000"/>
+            </a:avLst>
+          </a:prstGeom>
+          <a:solidFill>
+            <a:srgbClr val="1B2433"/>
+          </a:solidFill>
+          <a:ln>
+            <a:noFill/>
+          </a:ln>
+          <a:effectLst/>
+        </p:spPr>
+        <p:style>
+          <a:lnRef idx="1">
+            <a:schemeClr val="accent1"/>
+          </a:lnRef>
+          <a:fillRef idx="3">
+            <a:schemeClr val="accent1"/>
+          </a:fillRef>
+          <a:effectRef idx="2">
+            <a:schemeClr val="accent1"/>
+          </a:effectRef>
+          <a:fontRef idx="minor">
+            <a:schemeClr val="lt1"/>
+          </a:fontRef>
+        </p:style>
+        <p:txBody>
+          <a:bodyPr rtlCol="0" anchor="ctr"/>
+          <a:lstStyle/>
+          <a:p>
+            <a:pPr algn="ctr"/>
+          </a:p>
+        </p:txBody>
+      </p:sp>
+      <p:sp>
+        <p:nvSpPr>
+          <p:cNvPr id="8" name="TextBox 7"/>
+          <p:cNvSpPr txBox="1"/>
+          <p:nvPr/>
+        </p:nvSpPr>
+        <p:spPr>
+          <a:xfrm>
+            <a:off x="1033272" y="2249424"/>
+            <a:ext cx="2898648" cy="1394460"/>
+          </a:xfrm>
+          <a:prstGeom prst="rect">
+            <a:avLst/>
+          </a:prstGeom>
+          <a:noFill/>
+        </p:spPr>
+        <p:txBody>
+          <a:bodyPr wrap="square" anchor="t" lIns="0" rIns="0" tIns="0" bIns="0">
+            <a:spAutoFit/>
+          </a:bodyPr>
+          <a:lstStyle/>
+          <a:p>
+            <a:pPr algn="l">
+              <a:lnSpc>
+                <a:spcPct val="115000"/>
+              </a:lnSpc>
+              <a:spcAft>
+                <a:spcPts val="100"/>
+              </a:spcAft>
+            </a:pPr>
+            <a:r>
+              <a:rPr sz="950" b="0">
+                <a:solidFill>
+                  <a:srgbClr val="D8E4F0"/>
+                </a:solidFill>
+                <a:latin typeface="Consolas"/>
+              </a:rPr>
+              <a:t>sorted.sort((a, b) =&gt; {</a:t>
+            </a:r>
+          </a:p>
+          <a:p>
+            <a:pPr algn="l">
+              <a:lnSpc>
+                <a:spcPct val="115000"/>
+              </a:lnSpc>
+              <a:spcAft>
+                <a:spcPts val="100"/>
+              </a:spcAft>
+            </a:pPr>
+            <a:r>
+              <a:rPr sz="950" b="0">
+                <a:solidFill>
+                  <a:srgbClr val="D8E4F0"/>
+                </a:solidFill>
+                <a:latin typeface="Consolas"/>
+              </a:rPr>
+              <a:t>  if (a.inRadius !== b.inRadius)</a:t>
+            </a:r>
+          </a:p>
+          <a:p>
+            <a:pPr algn="l">
+              <a:lnSpc>
+                <a:spcPct val="115000"/>
+              </a:lnSpc>
+              <a:spcAft>
+                <a:spcPts val="100"/>
+              </a:spcAft>
+            </a:pPr>
+            <a:r>
+              <a:rPr sz="950" b="0">
+                <a:solidFill>
+                  <a:srgbClr val="D8E4F0"/>
+                </a:solidFill>
+                <a:latin typeface="Consolas"/>
+              </a:rPr>
+              <a:t>    return a.inRadius ? -1 : 1;</a:t>
+            </a:r>
+          </a:p>
+          <a:p>
+            <a:pPr algn="l">
+              <a:lnSpc>
+                <a:spcPct val="115000"/>
+              </a:lnSpc>
+              <a:spcAft>
+                <a:spcPts val="100"/>
+              </a:spcAft>
+            </a:pPr>
+            <a:r>
+              <a:rPr sz="950" b="0">
+                <a:solidFill>
+                  <a:srgbClr val="D8E4F0"/>
+                </a:solidFill>
+                <a:latin typeface="Consolas"/>
+              </a:rPr>
+              <a:t>  if (a.fresh !== b.fresh)</a:t>
+            </a:r>
+          </a:p>
+          <a:p>
+            <a:pPr algn="l">
+              <a:lnSpc>
+                <a:spcPct val="115000"/>
+              </a:lnSpc>
+              <a:spcAft>
+                <a:spcPts val="100"/>
+              </a:spcAft>
+            </a:pPr>
+            <a:r>
+              <a:rPr sz="950" b="0">
+                <a:solidFill>
+                  <a:srgbClr val="D8E4F0"/>
+                </a:solidFill>
+                <a:latin typeface="Consolas"/>
+              </a:rPr>
+              <a:t>    return a.fresh ? -1 : 1;</a:t>
+            </a:r>
+          </a:p>
+          <a:p>
+            <a:pPr algn="l">
+              <a:lnSpc>
+                <a:spcPct val="115000"/>
+              </a:lnSpc>
+              <a:spcAft>
+                <a:spcPts val="100"/>
+              </a:spcAft>
+            </a:pPr>
+            <a:r>
+              <a:rPr sz="950" b="0">
+                <a:solidFill>
+                  <a:srgbClr val="D8E4F0"/>
+                </a:solidFill>
+                <a:latin typeface="Consolas"/>
+              </a:rPr>
+              <a:t>  return a.distanceM - b.distanceM;</a:t>
+            </a:r>
+          </a:p>
+          <a:p>
+            <a:pPr algn="l">
+              <a:lnSpc>
+                <a:spcPct val="115000"/>
+              </a:lnSpc>
+              <a:spcAft>
+                <a:spcPts val="100"/>
+              </a:spcAft>
+            </a:pPr>
+            <a:r>
+              <a:rPr sz="950" b="0">
+                <a:solidFill>
+                  <a:srgbClr val="D8E4F0"/>
+                </a:solidFill>
+                <a:latin typeface="Consolas"/>
+              </a:rPr>
+              <a:t>});</a:t>
+            </a:r>
+          </a:p>
+        </p:txBody>
+      </p:sp>
+      <p:sp>
+        <p:nvSpPr>
+          <p:cNvPr id="9" name="TextBox 8"/>
+          <p:cNvSpPr txBox="1"/>
+          <p:nvPr/>
+        </p:nvSpPr>
+        <p:spPr>
+          <a:xfrm>
+            <a:off x="868680" y="3881628"/>
+            <a:ext cx="3227832" cy="1371600"/>
+          </a:xfrm>
+          <a:prstGeom prst="rect">
+            <a:avLst/>
+          </a:prstGeom>
+          <a:noFill/>
+        </p:spPr>
+        <p:txBody>
+          <a:bodyPr wrap="square" anchor="t" lIns="0" rIns="0" tIns="0" bIns="0">
+            <a:spAutoFit/>
+          </a:bodyPr>
+          <a:lstStyle/>
+          <a:p>
+            <a:pPr algn="l">
+              <a:lnSpc>
+                <a:spcPct val="128000"/>
+              </a:lnSpc>
+              <a:spcAft>
+                <a:spcPts val="0"/>
+              </a:spcAft>
+            </a:pPr>
+            <a:r>
+              <a:rPr sz="1050" b="0">
+                <a:solidFill>
+                  <a:srgbClr val="5A6673"/>
+                </a:solidFill>
+                <a:latin typeface="Arial"/>
+              </a:rPr>
+              <a:t>The incident engine ranks candidates: inside the radius first, fresh transmissions before stale ones, then the shortest distance.</a:t>
+            </a:r>
+          </a:p>
+        </p:txBody>
+      </p:sp>
+      <p:sp>
+        <p:nvSpPr>
+          <p:cNvPr id="10" name="Rounded Rectangle 9"/>
+          <p:cNvSpPr/>
+          <p:nvPr/>
+        </p:nvSpPr>
+        <p:spPr>
+          <a:xfrm>
+            <a:off x="4343400" y="1691640"/>
+            <a:ext cx="3502152" cy="3931920"/>
+          </a:xfrm>
+          <a:prstGeom prst="roundRect">
+            <a:avLst>
+              <a:gd name="adj" fmla="val 6000"/>
+            </a:avLst>
+          </a:prstGeom>
+          <a:solidFill>
+            <a:srgbClr val="F1F6FB"/>
+          </a:solidFill>
+          <a:ln w="12700">
+            <a:solidFill>
+              <a:srgbClr val="DBE6F2"/>
+            </a:solidFill>
+          </a:ln>
+          <a:effectLst/>
+        </p:spPr>
+        <p:style>
+          <a:lnRef idx="1">
+            <a:schemeClr val="accent1"/>
+          </a:lnRef>
+          <a:fillRef idx="3">
+            <a:schemeClr val="accent1"/>
+          </a:fillRef>
+          <a:effectRef idx="2">
+            <a:schemeClr val="accent1"/>
+          </a:effectRef>
+          <a:fontRef idx="minor">
+            <a:schemeClr val="lt1"/>
+          </a:fontRef>
+        </p:style>
+        <p:txBody>
+          <a:bodyPr rtlCol="0" anchor="ctr"/>
+          <a:lstStyle/>
+          <a:p>
+            <a:pPr algn="ctr"/>
+          </a:p>
+        </p:txBody>
+      </p:sp>
+      <p:sp>
+        <p:nvSpPr>
+          <p:cNvPr id="11" name="TextBox 10"/>
+          <p:cNvSpPr txBox="1"/>
+          <p:nvPr/>
+        </p:nvSpPr>
+        <p:spPr>
+          <a:xfrm>
+            <a:off x="4480560" y="1828800"/>
+            <a:ext cx="3227832" cy="237744"/>
+          </a:xfrm>
+          <a:prstGeom prst="rect">
+            <a:avLst/>
+          </a:prstGeom>
+          <a:noFill/>
+        </p:spPr>
+        <p:txBody>
+          <a:bodyPr wrap="square" anchor="t" lIns="0" rIns="0" tIns="0" bIns="0">
+            <a:spAutoFit/>
+          </a:bodyPr>
+          <a:lstStyle/>
+          <a:p>
+            <a:pPr algn="l">
+              <a:lnSpc>
+                <a:spcPct val="125000"/>
+              </a:lnSpc>
+              <a:spcAft>
+                <a:spcPts val="0"/>
+              </a:spcAft>
+            </a:pPr>
+            <a:r>
+              <a:rPr sz="950" b="1">
+                <a:solidFill>
+                  <a:srgbClr val="143A66"/>
+                </a:solidFill>
+                <a:latin typeface="Arial"/>
+              </a:rPr>
+              <a:t>server/src/lib/geo.js</a:t>
+            </a:r>
+          </a:p>
+        </p:txBody>
+      </p:sp>
+      <p:sp>
+        <p:nvSpPr>
+          <p:cNvPr id="12" name="Rounded Rectangle 11"/>
+          <p:cNvSpPr/>
+          <p:nvPr/>
+        </p:nvSpPr>
+        <p:spPr>
+          <a:xfrm>
+            <a:off x="4480560" y="2121408"/>
+            <a:ext cx="3227832" cy="1453896"/>
+          </a:xfrm>
+          <a:prstGeom prst="roundRect">
+            <a:avLst>
+              <a:gd name="adj" fmla="val 6000"/>
+            </a:avLst>
+          </a:prstGeom>
+          <a:solidFill>
+            <a:srgbClr val="1B2433"/>
+          </a:solidFill>
+          <a:ln>
+            <a:noFill/>
+          </a:ln>
+          <a:effectLst/>
+        </p:spPr>
+        <p:style>
+          <a:lnRef idx="1">
+            <a:schemeClr val="accent1"/>
+          </a:lnRef>
+          <a:fillRef idx="3">
+            <a:schemeClr val="accent1"/>
+          </a:fillRef>
+          <a:effectRef idx="2">
+            <a:schemeClr val="accent1"/>
+          </a:effectRef>
+          <a:fontRef idx="minor">
+            <a:schemeClr val="lt1"/>
+          </a:fontRef>
+        </p:style>
+        <p:txBody>
+          <a:bodyPr rtlCol="0" anchor="ctr"/>
+          <a:lstStyle/>
+          <a:p>
+            <a:pPr algn="ctr"/>
+          </a:p>
+        </p:txBody>
+      </p:sp>
+      <p:sp>
+        <p:nvSpPr>
+          <p:cNvPr id="13" name="TextBox 12"/>
+          <p:cNvSpPr txBox="1"/>
+          <p:nvPr/>
+        </p:nvSpPr>
+        <p:spPr>
+          <a:xfrm>
+            <a:off x="4645152" y="2249424"/>
+            <a:ext cx="2898648" cy="1197864"/>
+          </a:xfrm>
+          <a:prstGeom prst="rect">
+            <a:avLst/>
+          </a:prstGeom>
+          <a:noFill/>
+        </p:spPr>
+        <p:txBody>
+          <a:bodyPr wrap="square" anchor="t" lIns="0" rIns="0" tIns="0" bIns="0">
+            <a:spAutoFit/>
+          </a:bodyPr>
+          <a:lstStyle/>
+          <a:p>
+            <a:pPr algn="l">
+              <a:lnSpc>
+                <a:spcPct val="115000"/>
+              </a:lnSpc>
+              <a:spcAft>
+                <a:spcPts val="100"/>
+              </a:spcAft>
+            </a:pPr>
+            <a:r>
+              <a:rPr sz="950" b="0">
+                <a:solidFill>
+                  <a:srgbClr val="D8E4F0"/>
+                </a:solidFill>
+                <a:latin typeface="Consolas"/>
+              </a:rPr>
+              <a:t>const a =</a:t>
+            </a:r>
+          </a:p>
+          <a:p>
+            <a:pPr algn="l">
+              <a:lnSpc>
+                <a:spcPct val="115000"/>
+              </a:lnSpc>
+              <a:spcAft>
+                <a:spcPts val="100"/>
+              </a:spcAft>
+            </a:pPr>
+            <a:r>
+              <a:rPr sz="950" b="0">
+                <a:solidFill>
+                  <a:srgbClr val="D8E4F0"/>
+                </a:solidFill>
+                <a:latin typeface="Consolas"/>
+              </a:rPr>
+              <a:t>  Math.sin(dLat / 2) ** 2 +</a:t>
+            </a:r>
+          </a:p>
+          <a:p>
+            <a:pPr algn="l">
+              <a:lnSpc>
+                <a:spcPct val="115000"/>
+              </a:lnSpc>
+              <a:spcAft>
+                <a:spcPts val="100"/>
+              </a:spcAft>
+            </a:pPr>
+            <a:r>
+              <a:rPr sz="950" b="0">
+                <a:solidFill>
+                  <a:srgbClr val="D8E4F0"/>
+                </a:solidFill>
+                <a:latin typeface="Consolas"/>
+              </a:rPr>
+              <a:t>  Math.cos(la1) * Math.cos(la2) *</a:t>
+            </a:r>
+          </a:p>
+          <a:p>
+            <a:pPr algn="l">
+              <a:lnSpc>
+                <a:spcPct val="115000"/>
+              </a:lnSpc>
+              <a:spcAft>
+                <a:spcPts val="100"/>
+              </a:spcAft>
+            </a:pPr>
+            <a:r>
+              <a:rPr sz="950" b="0">
+                <a:solidFill>
+                  <a:srgbClr val="D8E4F0"/>
+                </a:solidFill>
+                <a:latin typeface="Consolas"/>
+              </a:rPr>
+              <a:t>  Math.sin(dLng / 2) ** 2;</a:t>
+            </a:r>
+          </a:p>
+          <a:p>
+            <a:pPr algn="l">
+              <a:lnSpc>
+                <a:spcPct val="115000"/>
+              </a:lnSpc>
+              <a:spcAft>
+                <a:spcPts val="100"/>
+              </a:spcAft>
+            </a:pPr>
+            <a:r>
+              <a:rPr sz="950" b="0">
+                <a:solidFill>
+                  <a:srgbClr val="D8E4F0"/>
+                </a:solidFill>
+                <a:latin typeface="Consolas"/>
+              </a:rPr>
+              <a:t>return 2 * EARTH_RADIUS_M *</a:t>
+            </a:r>
+          </a:p>
+          <a:p>
+            <a:pPr algn="l">
+              <a:lnSpc>
+                <a:spcPct val="115000"/>
+              </a:lnSpc>
+              <a:spcAft>
+                <a:spcPts val="100"/>
+              </a:spcAft>
+            </a:pPr>
+            <a:r>
+              <a:rPr sz="950" b="0">
+                <a:solidFill>
+                  <a:srgbClr val="D8E4F0"/>
+                </a:solidFill>
+                <a:latin typeface="Consolas"/>
+              </a:rPr>
+              <a:t>  Math.asin(Math.sqrt(a));</a:t>
+            </a:r>
+          </a:p>
+        </p:txBody>
+      </p:sp>
+      <p:sp>
+        <p:nvSpPr>
+          <p:cNvPr id="14" name="TextBox 13"/>
+          <p:cNvSpPr txBox="1"/>
+          <p:nvPr/>
+        </p:nvSpPr>
+        <p:spPr>
+          <a:xfrm>
+            <a:off x="4480560" y="3685032"/>
+            <a:ext cx="3227832" cy="1371600"/>
+          </a:xfrm>
+          <a:prstGeom prst="rect">
+            <a:avLst/>
+          </a:prstGeom>
+          <a:noFill/>
+        </p:spPr>
+        <p:txBody>
+          <a:bodyPr wrap="square" anchor="t" lIns="0" rIns="0" tIns="0" bIns="0">
+            <a:spAutoFit/>
+          </a:bodyPr>
+          <a:lstStyle/>
+          <a:p>
+            <a:pPr algn="l">
+              <a:lnSpc>
+                <a:spcPct val="128000"/>
+              </a:lnSpc>
+              <a:spcAft>
+                <a:spcPts val="0"/>
+              </a:spcAft>
+            </a:pPr>
+            <a:r>
+              <a:rPr sz="1050" b="0">
+                <a:solidFill>
+                  <a:srgbClr val="5A6673"/>
+                </a:solidFill>
+                <a:latin typeface="Arial"/>
+              </a:rPr>
+              <a:t>The Haversine formula: distance over the surface of the Earth between the distress point and each device.</a:t>
+            </a:r>
+          </a:p>
+        </p:txBody>
+      </p:sp>
+      <p:sp>
+        <p:nvSpPr>
+          <p:cNvPr id="15" name="Rounded Rectangle 14"/>
+          <p:cNvSpPr/>
+          <p:nvPr/>
+        </p:nvSpPr>
+        <p:spPr>
+          <a:xfrm>
+            <a:off x="7955279" y="1691640"/>
+            <a:ext cx="3502152" cy="3931920"/>
+          </a:xfrm>
+          <a:prstGeom prst="roundRect">
+            <a:avLst>
+              <a:gd name="adj" fmla="val 6000"/>
+            </a:avLst>
+          </a:prstGeom>
+          <a:solidFill>
+            <a:srgbClr val="F1F6FB"/>
+          </a:solidFill>
+          <a:ln w="12700">
+            <a:solidFill>
+              <a:srgbClr val="DBE6F2"/>
+            </a:solidFill>
+          </a:ln>
+          <a:effectLst/>
+        </p:spPr>
+        <p:style>
+          <a:lnRef idx="1">
+            <a:schemeClr val="accent1"/>
+          </a:lnRef>
+          <a:fillRef idx="3">
+            <a:schemeClr val="accent1"/>
+          </a:fillRef>
+          <a:effectRef idx="2">
+            <a:schemeClr val="accent1"/>
+          </a:effectRef>
+          <a:fontRef idx="minor">
+            <a:schemeClr val="lt1"/>
+          </a:fontRef>
+        </p:style>
+        <p:txBody>
+          <a:bodyPr rtlCol="0" anchor="ctr"/>
+          <a:lstStyle/>
+          <a:p>
+            <a:pPr algn="ctr"/>
+          </a:p>
+        </p:txBody>
+      </p:sp>
+      <p:sp>
+        <p:nvSpPr>
+          <p:cNvPr id="16" name="TextBox 15"/>
+          <p:cNvSpPr txBox="1"/>
+          <p:nvPr/>
+        </p:nvSpPr>
+        <p:spPr>
+          <a:xfrm>
+            <a:off x="8092440" y="1828800"/>
+            <a:ext cx="3227832" cy="237744"/>
+          </a:xfrm>
+          <a:prstGeom prst="rect">
+            <a:avLst/>
+          </a:prstGeom>
+          <a:noFill/>
+        </p:spPr>
+        <p:txBody>
+          <a:bodyPr wrap="square" anchor="t" lIns="0" rIns="0" tIns="0" bIns="0">
+            <a:spAutoFit/>
+          </a:bodyPr>
+          <a:lstStyle/>
+          <a:p>
+            <a:pPr algn="l">
+              <a:lnSpc>
+                <a:spcPct val="125000"/>
+              </a:lnSpc>
+              <a:spcAft>
+                <a:spcPts val="0"/>
+              </a:spcAft>
+            </a:pPr>
+            <a:r>
+              <a:rPr sz="950" b="1">
+                <a:solidFill>
+                  <a:srgbClr val="143A66"/>
+                </a:solidFill>
+                <a:latin typeface="Arial"/>
+              </a:rPr>
+              <a:t>server/src/routes/auth.js</a:t>
+            </a:r>
+          </a:p>
+        </p:txBody>
+      </p:sp>
+      <p:sp>
+        <p:nvSpPr>
+          <p:cNvPr id="17" name="Rounded Rectangle 16"/>
+          <p:cNvSpPr/>
+          <p:nvPr/>
+        </p:nvSpPr>
+        <p:spPr>
+          <a:xfrm>
+            <a:off x="8092440" y="2121408"/>
+            <a:ext cx="3227832" cy="1650492"/>
+          </a:xfrm>
+          <a:prstGeom prst="roundRect">
+            <a:avLst>
+              <a:gd name="adj" fmla="val 6000"/>
+            </a:avLst>
+          </a:prstGeom>
+          <a:solidFill>
+            <a:srgbClr val="1B2433"/>
+          </a:solidFill>
+          <a:ln>
+            <a:noFill/>
+          </a:ln>
+          <a:effectLst/>
+        </p:spPr>
+        <p:style>
+          <a:lnRef idx="1">
+            <a:schemeClr val="accent1"/>
+          </a:lnRef>
+          <a:fillRef idx="3">
+            <a:schemeClr val="accent1"/>
+          </a:fillRef>
+          <a:effectRef idx="2">
+            <a:schemeClr val="accent1"/>
+          </a:effectRef>
+          <a:fontRef idx="minor">
+            <a:schemeClr val="lt1"/>
+          </a:fontRef>
+        </p:style>
+        <p:txBody>
+          <a:bodyPr rtlCol="0" anchor="ctr"/>
+          <a:lstStyle/>
+          <a:p>
+            <a:pPr algn="ctr"/>
+          </a:p>
+        </p:txBody>
+      </p:sp>
+      <p:sp>
+        <p:nvSpPr>
+          <p:cNvPr id="18" name="TextBox 17"/>
+          <p:cNvSpPr txBox="1"/>
+          <p:nvPr/>
+        </p:nvSpPr>
+        <p:spPr>
+          <a:xfrm>
+            <a:off x="8257031" y="2249424"/>
+            <a:ext cx="2898648" cy="1394460"/>
+          </a:xfrm>
+          <a:prstGeom prst="rect">
+            <a:avLst/>
+          </a:prstGeom>
+          <a:noFill/>
+        </p:spPr>
+        <p:txBody>
+          <a:bodyPr wrap="square" anchor="t" lIns="0" rIns="0" tIns="0" bIns="0">
+            <a:spAutoFit/>
+          </a:bodyPr>
+          <a:lstStyle/>
+          <a:p>
+            <a:pPr algn="l">
+              <a:lnSpc>
+                <a:spcPct val="115000"/>
+              </a:lnSpc>
+              <a:spcAft>
+                <a:spcPts val="100"/>
+              </a:spcAft>
+            </a:pPr>
+            <a:r>
+              <a:rPr sz="950" b="0">
+                <a:solidFill>
+                  <a:srgbClr val="D8E4F0"/>
+                </a:solidFill>
+                <a:latin typeface="Consolas"/>
+              </a:rPr>
+              <a:t>db.transaction(() =&gt; {</a:t>
+            </a:r>
+          </a:p>
+          <a:p>
+            <a:pPr algn="l">
+              <a:lnSpc>
+                <a:spcPct val="115000"/>
+              </a:lnSpc>
+              <a:spcAft>
+                <a:spcPts val="100"/>
+              </a:spcAft>
+            </a:pPr>
+            <a:r>
+              <a:rPr sz="950" b="0">
+                <a:solidFill>
+                  <a:srgbClr val="D8E4F0"/>
+                </a:solidFill>
+                <a:latin typeface="Consolas"/>
+              </a:rPr>
+              <a:t>  db.prepare(</a:t>
+            </a:r>
+          </a:p>
+          <a:p>
+            <a:pPr algn="l">
+              <a:lnSpc>
+                <a:spcPct val="115000"/>
+              </a:lnSpc>
+              <a:spcAft>
+                <a:spcPts val="100"/>
+              </a:spcAft>
+            </a:pPr>
+            <a:r>
+              <a:rPr sz="950" b="0">
+                <a:solidFill>
+                  <a:srgbClr val="D8E4F0"/>
+                </a:solidFill>
+                <a:latin typeface="Consolas"/>
+              </a:rPr>
+              <a:t>    'UPDATE refresh_tokens ' +</a:t>
+            </a:r>
+          </a:p>
+          <a:p>
+            <a:pPr algn="l">
+              <a:lnSpc>
+                <a:spcPct val="115000"/>
+              </a:lnSpc>
+              <a:spcAft>
+                <a:spcPts val="100"/>
+              </a:spcAft>
+            </a:pPr>
+            <a:r>
+              <a:rPr sz="950" b="0">
+                <a:solidFill>
+                  <a:srgbClr val="D8E4F0"/>
+                </a:solidFill>
+                <a:latin typeface="Consolas"/>
+              </a:rPr>
+              <a:t>    'SET revoked = 1 WHERE jti = ?'</a:t>
+            </a:r>
+          </a:p>
+          <a:p>
+            <a:pPr algn="l">
+              <a:lnSpc>
+                <a:spcPct val="115000"/>
+              </a:lnSpc>
+              <a:spcAft>
+                <a:spcPts val="100"/>
+              </a:spcAft>
+            </a:pPr>
+            <a:r>
+              <a:rPr sz="950" b="0">
+                <a:solidFill>
+                  <a:srgbClr val="D8E4F0"/>
+                </a:solidFill>
+                <a:latin typeface="Consolas"/>
+              </a:rPr>
+              <a:t>  ).run(session.jti);</a:t>
+            </a:r>
+          </a:p>
+          <a:p>
+            <a:pPr algn="l">
+              <a:lnSpc>
+                <a:spcPct val="115000"/>
+              </a:lnSpc>
+              <a:spcAft>
+                <a:spcPts val="100"/>
+              </a:spcAft>
+            </a:pPr>
+            <a:r>
+              <a:rPr sz="950" b="0">
+                <a:solidFill>
+                  <a:srgbClr val="D8E4F0"/>
+                </a:solidFill>
+                <a:latin typeface="Consolas"/>
+              </a:rPr>
+              <a:t>  issueRefreshToken(res, user);</a:t>
+            </a:r>
+          </a:p>
+          <a:p>
+            <a:pPr algn="l">
+              <a:lnSpc>
+                <a:spcPct val="115000"/>
+              </a:lnSpc>
+              <a:spcAft>
+                <a:spcPts val="100"/>
+              </a:spcAft>
+            </a:pPr>
+            <a:r>
+              <a:rPr sz="950" b="0">
+                <a:solidFill>
+                  <a:srgbClr val="D8E4F0"/>
+                </a:solidFill>
+                <a:latin typeface="Consolas"/>
+              </a:rPr>
+              <a:t>})();</a:t>
+            </a:r>
+          </a:p>
+        </p:txBody>
+      </p:sp>
+      <p:sp>
+        <p:nvSpPr>
+          <p:cNvPr id="19" name="TextBox 18"/>
+          <p:cNvSpPr txBox="1"/>
+          <p:nvPr/>
+        </p:nvSpPr>
+        <p:spPr>
+          <a:xfrm>
+            <a:off x="8092440" y="3881628"/>
+            <a:ext cx="3227832" cy="1371600"/>
+          </a:xfrm>
+          <a:prstGeom prst="rect">
+            <a:avLst/>
+          </a:prstGeom>
+          <a:noFill/>
+        </p:spPr>
+        <p:txBody>
+          <a:bodyPr wrap="square" anchor="t" lIns="0" rIns="0" tIns="0" bIns="0">
+            <a:spAutoFit/>
+          </a:bodyPr>
+          <a:lstStyle/>
+          <a:p>
+            <a:pPr algn="l">
+              <a:lnSpc>
+                <a:spcPct val="128000"/>
+              </a:lnSpc>
+              <a:spcAft>
+                <a:spcPts val="0"/>
+              </a:spcAft>
+            </a:pPr>
+            <a:r>
+              <a:rPr sz="1050" b="0">
+                <a:solidFill>
+                  <a:srgbClr val="5A6673"/>
+                </a:solidFill>
+                <a:latin typeface="Arial"/>
+              </a:rPr>
+              <a:t>Rotation: every refresh token is single use, so a stolen token fails the moment it is reused.</a:t>
+            </a:r>
+          </a:p>
+        </p:txBody>
+      </p:sp>
+      <p:sp>
+        <p:nvSpPr>
+          <p:cNvPr id="20" name="Rounded Rectangle 19"/>
+          <p:cNvSpPr/>
+          <p:nvPr/>
+        </p:nvSpPr>
+        <p:spPr>
+          <a:xfrm>
+            <a:off x="731520" y="5760720"/>
+            <a:ext cx="10725912" cy="566928"/>
+          </a:xfrm>
+          <a:prstGeom prst="roundRect">
+            <a:avLst>
+              <a:gd name="adj" fmla="val 6000"/>
+            </a:avLst>
+          </a:prstGeom>
+          <a:solidFill>
+            <a:srgbClr val="F1F6FB"/>
+          </a:solidFill>
+          <a:ln w="12700">
+            <a:solidFill>
+              <a:srgbClr val="DBE6F2"/>
+            </a:solidFill>
+          </a:ln>
+          <a:effectLst/>
+        </p:spPr>
+        <p:style>
+          <a:lnRef idx="1">
+            <a:schemeClr val="accent1"/>
+          </a:lnRef>
+          <a:fillRef idx="3">
+            <a:schemeClr val="accent1"/>
+          </a:fillRef>
+          <a:effectRef idx="2">
+            <a:schemeClr val="accent1"/>
+          </a:effectRef>
+          <a:fontRef idx="minor">
+            <a:schemeClr val="lt1"/>
+          </a:fontRef>
+        </p:style>
+        <p:txBody>
+          <a:bodyPr rtlCol="0" anchor="ctr"/>
+          <a:lstStyle/>
+          <a:p>
+            <a:pPr algn="ctr"/>
+          </a:p>
+        </p:txBody>
+      </p:sp>
+      <p:sp>
+        <p:nvSpPr>
+          <p:cNvPr id="21" name="TextBox 20"/>
+          <p:cNvSpPr txBox="1"/>
+          <p:nvPr/>
+        </p:nvSpPr>
+        <p:spPr>
+          <a:xfrm>
+            <a:off x="960120" y="5833872"/>
+            <a:ext cx="10287000" cy="219456"/>
+          </a:xfrm>
+          <a:prstGeom prst="rect">
+            <a:avLst/>
+          </a:prstGeom>
+          <a:noFill/>
+        </p:spPr>
+        <p:txBody>
+          <a:bodyPr wrap="square" anchor="t" lIns="0" rIns="0" tIns="0" bIns="0">
+            <a:spAutoFit/>
+          </a:bodyPr>
+          <a:lstStyle/>
+          <a:p>
+            <a:pPr algn="l">
+              <a:lnSpc>
+                <a:spcPct val="125000"/>
+              </a:lnSpc>
+              <a:spcAft>
+                <a:spcPts val="0"/>
+              </a:spcAft>
+            </a:pPr>
+            <a:r>
+              <a:rPr sz="1100" b="1">
+                <a:solidFill>
+                  <a:srgbClr val="1F5C99"/>
+                </a:solidFill>
+                <a:latin typeface="Arial"/>
+              </a:rPr>
+              <a:t>Other key files</a:t>
+            </a:r>
+          </a:p>
+        </p:txBody>
+      </p:sp>
+      <p:sp>
+        <p:nvSpPr>
+          <p:cNvPr id="22" name="TextBox 21"/>
+          <p:cNvSpPr txBox="1"/>
+          <p:nvPr/>
+        </p:nvSpPr>
+        <p:spPr>
+          <a:xfrm>
+            <a:off x="960120" y="6071616"/>
+            <a:ext cx="10287000" cy="219456"/>
+          </a:xfrm>
+          <a:prstGeom prst="rect">
+            <a:avLst/>
+          </a:prstGeom>
+          <a:noFill/>
+        </p:spPr>
+        <p:txBody>
+          <a:bodyPr wrap="square" anchor="t" lIns="0" rIns="0" tIns="0" bIns="0">
+            <a:spAutoFit/>
+          </a:bodyPr>
+          <a:lstStyle/>
+          <a:p>
+            <a:pPr algn="l">
+              <a:lnSpc>
+                <a:spcPct val="125000"/>
+              </a:lnSpc>
+              <a:spcAft>
+                <a:spcPts val="0"/>
+              </a:spcAft>
+            </a:pPr>
+            <a:r>
+              <a:rPr sz="900" b="0">
+                <a:solidFill>
+                  <a:srgbClr val="5A6673"/>
+                </a:solidFill>
+                <a:latin typeface="Arial"/>
+              </a:rPr>
+              <a:t>server/src/routes/registry.js | server/src/db/sqlite.js | server/src/db/mongo.js | server/src/lib/silent-update.js | web/components/map/SimulatorApp.jsx | web/lib/api.js</a:t>
+            </a:r>
+          </a:p>
+        </p:txBody>
+      </p:sp>
+      <p:sp>
+        <p:nvSpPr>
+          <p:cNvPr id="23" name="TextBox 22"/>
+          <p:cNvSpPr txBox="1"/>
+          <p:nvPr/>
+        </p:nvSpPr>
+        <p:spPr>
+          <a:xfrm>
+            <a:off x="548640" y="6446520"/>
+            <a:ext cx="3657600" cy="274320"/>
+          </a:xfrm>
+          <a:prstGeom prst="rect">
+            <a:avLst/>
+          </a:prstGeom>
+          <a:noFill/>
+        </p:spPr>
+        <p:txBody>
+          <a:bodyPr wrap="square" anchor="t" lIns="0" rIns="0" tIns="0" bIns="0">
+            <a:spAutoFit/>
+          </a:bodyPr>
+          <a:lstStyle/>
+          <a:p>
+            <a:pPr algn="l">
+              <a:lnSpc>
+                <a:spcPct val="125000"/>
+              </a:lnSpc>
+              <a:spcAft>
+                <a:spcPts val="0"/>
+              </a:spcAft>
+            </a:pPr>
+            <a:r>
+              <a:rPr sz="1000" b="0">
+                <a:solidFill>
+                  <a:srgbClr val="5A6673"/>
+                </a:solidFill>
+                <a:latin typeface="Arial"/>
+              </a:rPr>
+              <a:t>DefiNet | WEB 2026</a:t>
+            </a:r>
+          </a:p>
+        </p:txBody>
+      </p:sp>
+      <p:sp>
+        <p:nvSpPr>
+          <p:cNvPr id="24" name="TextBox 23"/>
+          <p:cNvSpPr txBox="1"/>
+          <p:nvPr/>
+        </p:nvSpPr>
+        <p:spPr>
+          <a:xfrm>
+            <a:off x="10728655" y="6446520"/>
+            <a:ext cx="914400" cy="274320"/>
+          </a:xfrm>
+          <a:prstGeom prst="rect">
+            <a:avLst/>
+          </a:prstGeom>
+          <a:noFill/>
+        </p:spPr>
+        <p:txBody>
+          <a:bodyPr wrap="square" anchor="t" lIns="0" rIns="0" tIns="0" bIns="0">
+            <a:spAutoFit/>
+          </a:bodyPr>
+          <a:lstStyle/>
+          <a:p>
+            <a:pPr algn="r">
+              <a:lnSpc>
+                <a:spcPct val="125000"/>
+              </a:lnSpc>
+              <a:spcAft>
+                <a:spcPts val="0"/>
+              </a:spcAft>
+            </a:pPr>
+            <a:r>
+              <a:rPr sz="1000" b="0">
+                <a:solidFill>
+                  <a:srgbClr val="5A6673"/>
+                </a:solidFill>
+                <a:latin typeface="Arial"/>
+              </a:rPr>
+              <a:t>5 / 5</a:t>
             </a:r>
           </a:p>
         </p:txBody>

</xml_diff>